<commit_message>
docs: author name, demo URL and current test counts in slides and READMEs
Co-Authored-By: Claude Opus 5.5 <noreply@anthropic.com>
</commit_message>
<xml_diff>
--- a/docs/slides/multicooperativa-tfm.pptx
+++ b/docs/slides/multicooperativa-tfm.pptx
@@ -2358,7 +2358,7 @@
                   <a:schemeClr val="bg2"/>
                 </a:solidFill>
               </a:rPr>
-              <a:t>&lt;Nombre&gt; · Octubre 2026</a:t>
+              <a:t>Juan Chaparro García · Octubre 2026</a:t>
             </a:r>
             <a:endParaRPr lang="en-US" sz="1600" dirty="0"/>
           </a:p>
@@ -2454,6 +2454,10 @@
             <a:prstDash val="solid"/>
           </a:ln>
         </p:spPr>
+        <p:txBody>
+          <a:bodyPr/>
+          <a:p/>
+        </p:txBody>
       </p:sp>
       <p:sp>
         <p:nvSpPr>
@@ -2488,7 +2492,7 @@
                 <a:ea typeface="Cambria" pitchFamily="34" charset="-122"/>
                 <a:cs typeface="Cambria" pitchFamily="34" charset="-120"/>
               </a:rPr>
-              <a:t>613</a:t>
+              <a:t>649</a:t>
             </a:r>
             <a:endParaRPr lang="en-US" sz="4600" dirty="0"/>
           </a:p>
@@ -2524,7 +2528,7 @@
                   <a:schemeClr val="bg1"/>
                 </a:solidFill>
               </a:rPr>
-              <a:t>tests unitarios en 67 ficheros</a:t>
+              <a:t>tests unitarios en 68 ficheros</a:t>
             </a:r>
             <a:endParaRPr lang="en-US" sz="1400" dirty="0"/>
           </a:p>
@@ -2556,6 +2560,10 @@
             <a:prstDash val="solid"/>
           </a:ln>
         </p:spPr>
+        <p:txBody>
+          <a:bodyPr/>
+          <a:p/>
+        </p:txBody>
       </p:sp>
       <p:sp>
         <p:nvSpPr>
@@ -2626,7 +2634,7 @@
                   <a:schemeClr val="bg1"/>
                 </a:solidFill>
               </a:rPr>
-              <a:t>preguntas de evaluación del asistente</a:t>
+              <a:t>preguntas de evaluación del asistente (20/20 con Gemini real)</a:t>
             </a:r>
             <a:endParaRPr lang="en-US" sz="1400" dirty="0"/>
           </a:p>
@@ -2658,6 +2666,10 @@
             <a:prstDash val="solid"/>
           </a:ln>
         </p:spPr>
+        <p:txBody>
+          <a:bodyPr/>
+          <a:p/>
+        </p:txBody>
       </p:sp>
       <p:sp>
         <p:nvSpPr>
@@ -2757,6 +2769,10 @@
             <a:prstDash val="solid"/>
           </a:ln>
         </p:spPr>
+        <p:txBody>
+          <a:bodyPr/>
+          <a:p/>
+        </p:txBody>
       </p:sp>
       <p:sp>
         <p:nvSpPr>
@@ -2856,6 +2872,10 @@
             <a:prstDash val="solid"/>
           </a:ln>
         </p:spPr>
+        <p:txBody>
+          <a:bodyPr/>
+          <a:p/>
+        </p:txBody>
       </p:sp>
       <p:sp>
         <p:nvSpPr>
@@ -2887,7 +2907,7 @@
                   <a:schemeClr val="tx2"/>
                 </a:solidFill>
               </a:rPr>
-              <a:t>Tests de integración</a:t>
+              <a:t>364 tests de integración</a:t>
             </a:r>
             <a:endParaRPr lang="en-US" sz="1600" dirty="0"/>
           </a:p>
@@ -3064,6 +3084,10 @@
             <a:prstDash val="solid"/>
           </a:ln>
         </p:spPr>
+        <p:txBody>
+          <a:bodyPr/>
+          <a:p/>
+        </p:txBody>
       </p:sp>
       <p:sp>
         <p:nvSpPr>
@@ -3141,6 +3165,10 @@
             <a:prstDash val="solid"/>
           </a:ln>
         </p:spPr>
+        <p:txBody>
+          <a:bodyPr/>
+          <a:p/>
+        </p:txBody>
       </p:sp>
       <p:sp>
         <p:nvSpPr>
@@ -3215,6 +3243,10 @@
             <a:tailEnd type="triangle"/>
           </a:ln>
         </p:spPr>
+        <p:txBody>
+          <a:bodyPr/>
+          <a:p/>
+        </p:txBody>
       </p:sp>
       <p:sp>
         <p:nvSpPr>
@@ -3242,6 +3274,10 @@
             <a:prstDash val="solid"/>
           </a:ln>
         </p:spPr>
+        <p:txBody>
+          <a:bodyPr/>
+          <a:p/>
+        </p:txBody>
       </p:sp>
       <p:sp>
         <p:nvSpPr>
@@ -3319,6 +3355,10 @@
             <a:prstDash val="solid"/>
           </a:ln>
         </p:spPr>
+        <p:txBody>
+          <a:bodyPr/>
+          <a:p/>
+        </p:txBody>
       </p:sp>
       <p:sp>
         <p:nvSpPr>
@@ -3396,6 +3436,10 @@
             <a:prstDash val="solid"/>
           </a:ln>
         </p:spPr>
+        <p:txBody>
+          <a:bodyPr/>
+          <a:p/>
+        </p:txBody>
       </p:sp>
       <p:sp>
         <p:nvSpPr>
@@ -3456,6 +3500,10 @@
             <a:tailEnd type="triangle"/>
           </a:ln>
         </p:spPr>
+        <p:txBody>
+          <a:bodyPr/>
+          <a:p/>
+        </p:txBody>
       </p:sp>
       <p:sp>
         <p:nvSpPr>
@@ -3480,6 +3528,10 @@
             <a:tailEnd type="triangle"/>
           </a:ln>
         </p:spPr>
+        <p:txBody>
+          <a:bodyPr/>
+          <a:p/>
+        </p:txBody>
       </p:sp>
       <p:sp>
         <p:nvSpPr>
@@ -3504,6 +3556,10 @@
             <a:tailEnd type="triangle"/>
           </a:ln>
         </p:spPr>
+        <p:txBody>
+          <a:bodyPr/>
+          <a:p/>
+        </p:txBody>
       </p:sp>
       <p:sp>
         <p:nvSpPr>
@@ -3531,6 +3587,10 @@
             <a:prstDash val="solid"/>
           </a:ln>
         </p:spPr>
+        <p:txBody>
+          <a:bodyPr/>
+          <a:p/>
+        </p:txBody>
       </p:sp>
       <p:sp>
         <p:nvSpPr>
@@ -3605,6 +3665,10 @@
             <a:tailEnd type="triangle"/>
           </a:ln>
         </p:spPr>
+        <p:txBody>
+          <a:bodyPr/>
+          <a:p/>
+        </p:txBody>
       </p:sp>
       <p:sp>
         <p:nvSpPr>
@@ -3632,6 +3696,10 @@
             <a:prstDash val="solid"/>
           </a:ln>
         </p:spPr>
+        <p:txBody>
+          <a:bodyPr/>
+          <a:p/>
+        </p:txBody>
       </p:sp>
       <p:sp>
         <p:nvSpPr>
@@ -3931,7 +3999,7 @@
                   <a:schemeClr val="tx1"/>
                 </a:solidFill>
               </a:rPr>
-              <a:t>&lt;URL demo&gt;</a:t>
+              <a:t>chaparro2001.github.io/multiCooperativa</a:t>
             </a:r>
             <a:endParaRPr lang="en-US" sz="2000" dirty="0"/>
           </a:p>
@@ -4882,6 +4950,10 @@
             <a:prstDash val="solid"/>
           </a:ln>
         </p:spPr>
+        <p:txBody>
+          <a:bodyPr/>
+          <a:p/>
+        </p:txBody>
       </p:sp>
       <p:sp>
         <p:nvSpPr>
@@ -5039,6 +5111,10 @@
             <a:prstDash val="solid"/>
           </a:ln>
         </p:spPr>
+        <p:txBody>
+          <a:bodyPr/>
+          <a:p/>
+        </p:txBody>
       </p:sp>
       <p:sp>
         <p:nvSpPr>
@@ -5365,7 +5441,7 @@
                   <a:schemeClr val="bg2"/>
                 </a:solidFill>
               </a:rPr>
-              <a:t>Demo: &lt;URL demo&gt;</a:t>
+              <a:t>Demo: chaparro2001.github.io/multiCooperativa</a:t>
             </a:r>
             <a:endParaRPr lang="en-US" sz="2000" dirty="0"/>
           </a:p>
@@ -5418,7 +5494,7 @@
                   <a:schemeClr val="accent2"/>
                 </a:solidFill>
               </a:rPr>
-              <a:t>&lt;Nombre&gt; · TFM Máster de Desarrollo con IA · BIG school · Octubre 2026</a:t>
+              <a:t>Juan Chaparro García · TFM Máster de Desarrollo con IA · BIG school · Octubre 2026</a:t>
             </a:r>
             <a:endParaRPr lang="en-US" sz="1400" dirty="0"/>
           </a:p>
@@ -5514,6 +5590,10 @@
             <a:prstDash val="solid"/>
           </a:ln>
         </p:spPr>
+        <p:txBody>
+          <a:bodyPr/>
+          <a:p/>
+        </p:txBody>
       </p:sp>
       <p:sp>
         <p:nvSpPr>
@@ -5613,6 +5693,10 @@
             <a:prstDash val="solid"/>
           </a:ln>
         </p:spPr>
+        <p:txBody>
+          <a:bodyPr/>
+          <a:p/>
+        </p:txBody>
       </p:sp>
       <p:sp>
         <p:nvSpPr>
@@ -5712,6 +5796,10 @@
             <a:prstDash val="solid"/>
           </a:ln>
         </p:spPr>
+        <p:txBody>
+          <a:bodyPr/>
+          <a:p/>
+        </p:txBody>
       </p:sp>
       <p:sp>
         <p:nvSpPr>
@@ -5811,6 +5899,10 @@
             <a:prstDash val="solid"/>
           </a:ln>
         </p:spPr>
+        <p:txBody>
+          <a:bodyPr/>
+          <a:p/>
+        </p:txBody>
       </p:sp>
       <p:sp>
         <p:nvSpPr>
@@ -6055,6 +6147,10 @@
             <a:prstDash val="solid"/>
           </a:ln>
         </p:spPr>
+        <p:txBody>
+          <a:bodyPr/>
+          <a:p/>
+        </p:txBody>
       </p:sp>
       <p:sp>
         <p:nvSpPr>
@@ -6154,6 +6250,10 @@
             <a:prstDash val="solid"/>
           </a:ln>
         </p:spPr>
+        <p:txBody>
+          <a:bodyPr/>
+          <a:p/>
+        </p:txBody>
       </p:sp>
       <p:sp>
         <p:nvSpPr>
@@ -6253,6 +6353,10 @@
             <a:prstDash val="solid"/>
           </a:ln>
         </p:spPr>
+        <p:txBody>
+          <a:bodyPr/>
+          <a:p/>
+        </p:txBody>
       </p:sp>
       <p:sp>
         <p:nvSpPr>
@@ -6352,6 +6456,10 @@
             <a:prstDash val="solid"/>
           </a:ln>
         </p:spPr>
+        <p:txBody>
+          <a:bodyPr/>
+          <a:p/>
+        </p:txBody>
       </p:sp>
       <p:sp>
         <p:nvSpPr>
@@ -6560,6 +6668,10 @@
             <a:prstDash val="solid"/>
           </a:ln>
         </p:spPr>
+        <p:txBody>
+          <a:bodyPr/>
+          <a:p/>
+        </p:txBody>
       </p:sp>
       <p:sp>
         <p:nvSpPr>
@@ -6753,6 +6865,10 @@
             <a:prstDash val="solid"/>
           </a:ln>
         </p:spPr>
+        <p:txBody>
+          <a:bodyPr/>
+          <a:p/>
+        </p:txBody>
       </p:sp>
       <p:sp>
         <p:nvSpPr>
@@ -7037,6 +7153,10 @@
             <a:prstDash val="solid"/>
           </a:ln>
         </p:spPr>
+        <p:txBody>
+          <a:bodyPr/>
+          <a:p/>
+        </p:txBody>
       </p:sp>
       <p:sp>
         <p:nvSpPr>
@@ -7111,6 +7231,10 @@
             <a:tailEnd type="triangle"/>
           </a:ln>
         </p:spPr>
+        <p:txBody>
+          <a:bodyPr/>
+          <a:p/>
+        </p:txBody>
       </p:sp>
       <p:sp>
         <p:nvSpPr>
@@ -7138,6 +7262,10 @@
             <a:prstDash val="solid"/>
           </a:ln>
         </p:spPr>
+        <p:txBody>
+          <a:bodyPr/>
+          <a:p/>
+        </p:txBody>
       </p:sp>
       <p:sp>
         <p:nvSpPr>
@@ -7201,6 +7329,10 @@
             <a:prstDash val="solid"/>
           </a:ln>
         </p:spPr>
+        <p:txBody>
+          <a:bodyPr/>
+          <a:p/>
+        </p:txBody>
       </p:sp>
       <p:sp>
         <p:nvSpPr>
@@ -7264,6 +7396,10 @@
             <a:prstDash val="solid"/>
           </a:ln>
         </p:spPr>
+        <p:txBody>
+          <a:bodyPr/>
+          <a:p/>
+        </p:txBody>
       </p:sp>
       <p:sp>
         <p:nvSpPr>
@@ -7327,6 +7463,10 @@
             <a:prstDash val="solid"/>
           </a:ln>
         </p:spPr>
+        <p:txBody>
+          <a:bodyPr/>
+          <a:p/>
+        </p:txBody>
       </p:sp>
       <p:sp>
         <p:nvSpPr>
@@ -7390,6 +7530,10 @@
             <a:prstDash val="solid"/>
           </a:ln>
         </p:spPr>
+        <p:txBody>
+          <a:bodyPr/>
+          <a:p/>
+        </p:txBody>
       </p:sp>
       <p:sp>
         <p:nvSpPr>
@@ -7453,6 +7597,10 @@
             <a:prstDash val="solid"/>
           </a:ln>
         </p:spPr>
+        <p:txBody>
+          <a:bodyPr/>
+          <a:p/>
+        </p:txBody>
       </p:sp>
       <p:sp>
         <p:nvSpPr>
@@ -7516,6 +7664,10 @@
             <a:prstDash val="solid"/>
           </a:ln>
         </p:spPr>
+        <p:txBody>
+          <a:bodyPr/>
+          <a:p/>
+        </p:txBody>
       </p:sp>
       <p:sp>
         <p:nvSpPr>
@@ -7615,6 +7767,10 @@
             <a:prstDash val="solid"/>
           </a:ln>
         </p:spPr>
+        <p:txBody>
+          <a:bodyPr/>
+          <a:p/>
+        </p:txBody>
       </p:sp>
       <p:sp>
         <p:nvSpPr>
@@ -7675,6 +7831,10 @@
             <a:tailEnd type="triangle"/>
           </a:ln>
         </p:spPr>
+        <p:txBody>
+          <a:bodyPr/>
+          <a:p/>
+        </p:txBody>
       </p:sp>
       <p:sp>
         <p:nvSpPr>
@@ -7702,6 +7862,10 @@
             <a:prstDash val="solid"/>
           </a:ln>
         </p:spPr>
+        <p:txBody>
+          <a:bodyPr/>
+          <a:p/>
+        </p:txBody>
       </p:sp>
       <p:sp>
         <p:nvSpPr>
@@ -7762,6 +7926,10 @@
             <a:tailEnd type="triangle"/>
           </a:ln>
         </p:spPr>
+        <p:txBody>
+          <a:bodyPr/>
+          <a:p/>
+        </p:txBody>
       </p:sp>
       <p:sp>
         <p:nvSpPr>
@@ -7789,6 +7957,10 @@
             <a:prstDash val="solid"/>
           </a:ln>
         </p:spPr>
+        <p:txBody>
+          <a:bodyPr/>
+          <a:p/>
+        </p:txBody>
       </p:sp>
       <p:sp>
         <p:nvSpPr>
@@ -7849,6 +8021,10 @@
             <a:tailEnd type="triangle"/>
           </a:ln>
         </p:spPr>
+        <p:txBody>
+          <a:bodyPr/>
+          <a:p/>
+        </p:txBody>
       </p:sp>
       <p:sp>
         <p:nvSpPr>
@@ -8021,6 +8197,10 @@
             <a:prstDash val="solid"/>
           </a:ln>
         </p:spPr>
+        <p:txBody>
+          <a:bodyPr/>
+          <a:p/>
+        </p:txBody>
       </p:sp>
       <p:sp>
         <p:nvSpPr>
@@ -8120,6 +8300,10 @@
             <a:prstDash val="solid"/>
           </a:ln>
         </p:spPr>
+        <p:txBody>
+          <a:bodyPr/>
+          <a:p/>
+        </p:txBody>
       </p:sp>
       <p:sp>
         <p:nvSpPr>
@@ -8219,6 +8403,10 @@
             <a:prstDash val="solid"/>
           </a:ln>
         </p:spPr>
+        <p:txBody>
+          <a:bodyPr/>
+          <a:p/>
+        </p:txBody>
       </p:sp>
       <p:sp>
         <p:nvSpPr>
@@ -8318,6 +8506,10 @@
             <a:prstDash val="solid"/>
           </a:ln>
         </p:spPr>
+        <p:txBody>
+          <a:bodyPr/>
+          <a:p/>
+        </p:txBody>
       </p:sp>
       <p:sp>
         <p:nvSpPr>
@@ -8417,6 +8609,10 @@
             <a:prstDash val="solid"/>
           </a:ln>
         </p:spPr>
+        <p:txBody>
+          <a:bodyPr/>
+          <a:p/>
+        </p:txBody>
       </p:sp>
       <p:sp>
         <p:nvSpPr>
@@ -8516,6 +8712,10 @@
             <a:prstDash val="solid"/>
           </a:ln>
         </p:spPr>
+        <p:txBody>
+          <a:bodyPr/>
+          <a:p/>
+        </p:txBody>
       </p:sp>
       <p:sp>
         <p:nvSpPr>
@@ -8615,6 +8815,10 @@
             <a:prstDash val="solid"/>
           </a:ln>
         </p:spPr>
+        <p:txBody>
+          <a:bodyPr/>
+          <a:p/>
+        </p:txBody>
       </p:sp>
       <p:sp>
         <p:nvSpPr>
@@ -8714,6 +8918,10 @@
             <a:prstDash val="solid"/>
           </a:ln>
         </p:spPr>
+        <p:txBody>
+          <a:bodyPr/>
+          <a:p/>
+        </p:txBody>
       </p:sp>
       <p:sp>
         <p:nvSpPr>
@@ -8813,6 +9021,10 @@
             <a:prstDash val="solid"/>
           </a:ln>
         </p:spPr>
+        <p:txBody>
+          <a:bodyPr/>
+          <a:p/>
+        </p:txBody>
       </p:sp>
       <p:sp>
         <p:nvSpPr>
@@ -8912,6 +9124,10 @@
             <a:prstDash val="solid"/>
           </a:ln>
         </p:spPr>
+        <p:txBody>
+          <a:bodyPr/>
+          <a:p/>
+        </p:txBody>
       </p:sp>
       <p:sp>
         <p:nvSpPr>
@@ -9011,6 +9227,10 @@
             <a:prstDash val="solid"/>
           </a:ln>
         </p:spPr>
+        <p:txBody>
+          <a:bodyPr/>
+          <a:p/>
+        </p:txBody>
       </p:sp>
       <p:sp>
         <p:nvSpPr>
@@ -9219,6 +9439,10 @@
             <a:prstDash val="solid"/>
           </a:ln>
         </p:spPr>
+        <p:txBody>
+          <a:bodyPr/>
+          <a:p/>
+        </p:txBody>
       </p:sp>
       <p:sp>
         <p:nvSpPr>
@@ -9318,6 +9542,10 @@
             <a:prstDash val="solid"/>
           </a:ln>
         </p:spPr>
+        <p:txBody>
+          <a:bodyPr/>
+          <a:p/>
+        </p:txBody>
       </p:sp>
       <p:sp>
         <p:nvSpPr>
@@ -9417,6 +9645,10 @@
             <a:prstDash val="solid"/>
           </a:ln>
         </p:spPr>
+        <p:txBody>
+          <a:bodyPr/>
+          <a:p/>
+        </p:txBody>
       </p:sp>
       <p:sp>
         <p:nvSpPr>
@@ -9516,6 +9748,10 @@
             <a:prstDash val="solid"/>
           </a:ln>
         </p:spPr>
+        <p:txBody>
+          <a:bodyPr/>
+          <a:p/>
+        </p:txBody>
       </p:sp>
       <p:sp>
         <p:nvSpPr>
@@ -9615,6 +9851,10 @@
             <a:prstDash val="solid"/>
           </a:ln>
         </p:spPr>
+        <p:txBody>
+          <a:bodyPr/>
+          <a:p/>
+        </p:txBody>
       </p:sp>
       <p:sp>
         <p:nvSpPr>
@@ -9714,6 +9954,10 @@
             <a:prstDash val="solid"/>
           </a:ln>
         </p:spPr>
+        <p:txBody>
+          <a:bodyPr/>
+          <a:p/>
+        </p:txBody>
       </p:sp>
       <p:sp>
         <p:nvSpPr>
@@ -9922,6 +10166,10 @@
             <a:prstDash val="solid"/>
           </a:ln>
         </p:spPr>
+        <p:txBody>
+          <a:bodyPr/>
+          <a:p/>
+        </p:txBody>
       </p:sp>
       <p:sp>
         <p:nvSpPr>
@@ -10021,6 +10269,10 @@
             <a:prstDash val="solid"/>
           </a:ln>
         </p:spPr>
+        <p:txBody>
+          <a:bodyPr/>
+          <a:p/>
+        </p:txBody>
       </p:sp>
       <p:sp>
         <p:nvSpPr>
@@ -10120,6 +10372,10 @@
             <a:prstDash val="solid"/>
           </a:ln>
         </p:spPr>
+        <p:txBody>
+          <a:bodyPr/>
+          <a:p/>
+        </p:txBody>
       </p:sp>
       <p:sp>
         <p:nvSpPr>
@@ -10219,6 +10475,10 @@
             <a:prstDash val="solid"/>
           </a:ln>
         </p:spPr>
+        <p:txBody>
+          <a:bodyPr/>
+          <a:p/>
+        </p:txBody>
       </p:sp>
       <p:sp>
         <p:nvSpPr>
@@ -10463,6 +10723,10 @@
             <a:prstDash val="solid"/>
           </a:ln>
         </p:spPr>
+        <p:txBody>
+          <a:bodyPr/>
+          <a:p/>
+        </p:txBody>
       </p:sp>
       <p:sp>
         <p:nvSpPr>

</xml_diff>

<commit_message>
feat(deploy): serve the web app on cooperativa.chaparro2001.com at the root path (ADR-017)
Remove experiments.baseUrl, add a CNAME file to the Pages artifact, allow the
new origin in CORS, default WEB_APP_URL to the custom domain and update docs,
READMEs and slides. Adds ADR-017.

Co-Authored-By: Claude Opus 5.5 <noreply@anthropic.com>
</commit_message>
<xml_diff>
--- a/docs/slides/multicooperativa-tfm.pptx
+++ b/docs/slides/multicooperativa-tfm.pptx
@@ -3999,7 +3999,7 @@
                   <a:schemeClr val="tx1"/>
                 </a:solidFill>
               </a:rPr>
-              <a:t>chaparro2001.github.io/multiCooperativa</a:t>
+              <a:t>cooperativa.chaparro2001.com</a:t>
             </a:r>
             <a:endParaRPr lang="en-US" sz="2000" dirty="0"/>
           </a:p>
@@ -5441,7 +5441,7 @@
                   <a:schemeClr val="bg2"/>
                 </a:solidFill>
               </a:rPr>
-              <a:t>Demo: chaparro2001.github.io/multiCooperativa</a:t>
+              <a:t>Demo: cooperativa.chaparro2001.com</a:t>
             </a:r>
             <a:endParaRPr lang="en-US" sz="2000" dirty="0"/>
           </a:p>

</xml_diff>

<commit_message>
docs(slides): update defense deck, script and READMEs for react-native-paper (ADR-020) and the AI-driven process
Numbers at 2026-10-21: 1168 unit tests, 477 integration, 160 of 161 commits
co-authored with Claude, 20 ADRs. PDF now exported from the .pptx with PowerPoint.

Co-Authored-By: Claude Opus 5.5 <noreply@anthropic.com>
</commit_message>
<xml_diff>
--- a/docs/slides/multicooperativa-tfm.pptx
+++ b/docs/slides/multicooperativa-tfm.pptx
@@ -777,7 +777,7 @@
           <a:lstStyle/>
           <a:p>
             <a:r>
-              <a:t>Los números, medidos el 21 de octubre ejecutando pnpm test y pnpm test:integration: 941 tests unitarios en 92 ficheros y 477 tests de integración en 25 ficheros, todos en verde. Los de integración corren contra PostgreSQL y S3 reales, e incluyen el aislamiento entre cooperativas. Husky ejecuta lint, typecheck y tests en el pre-commit, y la CI de GitHub Actions comprueba formato, lint, tipos, tests, migraciones e integración. A la derecha, el benchmark de modelos locales para el asistente, sobre el conjunto de evaluación de entonces, 22 preguntas, medido en un Mac con 12 CPU y sin GPU: qwen3:8b acierta 19, qwen3:4b-instruct 18, gemma4:e4b 15, llama3.2:3b 7, qwen2.5:3b 5 y phi4-mini 4. Hoy el conjunto tiene 23 preguntas. El servidor lleva qwen3:4b-instruct por defecto: pierde una pregunta frente al 8b pero responde más rápido en esa CPU; esa rapidez en el servidor la ha comprobado el autor, no se ha medido con el conjunto de evaluación.</a:t>
+              <a:t>Los números, medidos el 21 de octubre ejecutando pnpm test y pnpm test:integration: 1168 tests unitarios en 113 ficheros (852 de la API, 295 de la app y 21 de contratos) y 477 tests de integración en 25 ficheros, todos en verde. Los de integración corren contra PostgreSQL y S3 reales, e incluyen el aislamiento entre cooperativas. Husky ejecuta lint, typecheck y tests en el pre-commit, y la CI de GitHub Actions comprueba formato, lint, tipos, tests, migraciones e integración. A la derecha, el benchmark de modelos locales para el asistente, sobre el conjunto de evaluación de entonces, 22 preguntas, medido en un Mac con 12 CPU y sin GPU: qwen3:8b acierta 19, qwen3:4b-instruct 18, gemma4:e4b 15, llama3.2:3b 7, qwen2.5:3b 5 y phi4-mini 4. Hoy el conjunto tiene 23 preguntas. El servidor lleva qwen3:4b-instruct por defecto: pierde una pregunta frente al 8b pero responde más rápido en esa CPU; esa rapidez en el servidor la ha comprobado el autor, no se ha medido con el conjunto de evaluación.</a:t>
             </a:r>
           </a:p>
         </p:txBody>
@@ -949,7 +949,7 @@
           <a:lstStyle/>
           <a:p>
             <a:r>
-              <a:t>Aquí enseño la demo en directo o en vídeo, en https://cooperativa.chaparro2001.com. La contraseña de la demo se completa antes de la entrega. Conviene hacer una pregunta al asistente un par de minutos antes para que el modelo local esté cargado en memoria. Hay un usuario por perfil en la Cooperativa Agrícola San Isidro: el socio, que ve comunicados, documentos, asamblea y voto, su capital y el asistente; el gestor, que registra facturas, escanea con IA y revisa discrepancias; el consejo, que publica comunicados y vigila pagos y cobros; y el administrador, que invita miembros con un enlace y personaliza la apariencia y el modelo del asistente. Lucía pertenece a dos cooperativas con perfil distinto en cada una, y sirve para ver el selector de cooperativa. Usar solo facturas ficticias: la capa gratuita de Gemini puede usar el contenido.</a:t>
+              <a:t>Aquí enseño la demo en directo o en vídeo, en https://cooperativa.chaparro2001.com. La contraseña de la demo se completa antes de la entrega. Conviene hacer una pregunta al asistente un par de minutos antes para que el modelo local esté cargado en memoria. Hay un usuario por perfil en la Cooperativa Agrícola San Isidro: el socio, que ve comunicados, documentos, asamblea y voto, su capital y el asistente; el gestor, que registra facturas, escanea con IA y revisa discrepancias; el consejo, que publica comunicados y vigila pagos y cobros; y el administrador, que invita miembros con un enlace y personaliza la apariencia y el modelo del asistente; en Ajustes, Apariencia, se ve el aspecto Material Design de la app y cómo el color de la cooperativa llega a los chips y a las opciones seleccionadas. Lucía pertenece a dos cooperativas con perfil distinto en cada una, y sirve para ver el selector de cooperativa. Usar solo facturas ficticias: la capa gratuita de Gemini puede usar el contenido.</a:t>
             </a:r>
           </a:p>
         </p:txBody>
@@ -1121,7 +1121,7 @@
           <a:lstStyle/>
           <a:p>
             <a:r>
-              <a:t>Muchas gracias. El código, la documentación y los 19 ADR están en el repositorio de GitHub; la demo está en cooperativa.chaparro2001.com, la API en api-cooperativa.chaparro2001.com y el vídeo en el enlace de la diapositiva. Quedo a disposición del tribunal para preguntas.</a:t>
+              <a:t>Muchas gracias. El código, la documentación y los 20 ADR están en el repositorio de GitHub; la demo está en cooperativa.chaparro2001.com, la API en api-cooperativa.chaparro2001.com y el vídeo en el enlace de la diapositiva. Quedo a disposición del tribunal para preguntas.</a:t>
             </a:r>
           </a:p>
         </p:txBody>
@@ -1467,7 +1467,7 @@
           <a:lstStyle/>
           <a:p>
             <a:r>
-              <a:t>La app Expo, que genera iOS, Android y web, habla con una API REST en Node y TypeScript. El backend es un monolito modular con Clean Architecture: cada módulo tiene capas de dominio, aplicación e infraestructura y solo expone su index.ts. Los módulos no leen las tablas de otros; se comunican por su interfaz pública o por eventos internos, y una regla de ESLint propia lo hace cumplir. Hay ocho módulos: acceso, comunicados, documentos, asambleas, facturas, área del socio, asistente y marca. A la derecha están las dependencias: PostgreSQL con pgvector, almacenamiento compatible con S3 con URLs firmadas, Ollama en local para el asistente y los embeddings, Gemini solo para la visión y las explicaciones de discrepancias, y, de forma opcional, un proveedor externo de modelos que una cooperativa puede elegir con su propia clave. Todo ello corre en Docker en un servidor propio; solo la API sale a internet, a través de Cloudflare Tunnel.</a:t>
+              <a:t>La app Expo, que genera iOS, Android y web, con la interfaz en react-native-paper (Material Design 3), habla con una API REST en Node y TypeScript. El backend es un monolito modular con Clean Architecture: cada módulo tiene capas de dominio, aplicación e infraestructura y solo expone su index.ts. Los módulos no leen las tablas de otros; se comunican por su interfaz pública o por eventos internos, y una regla de ESLint propia lo hace cumplir. Hay ocho módulos: acceso, comunicados, documentos, asambleas, facturas, área del socio, asistente y marca. A la derecha están las dependencias: PostgreSQL con pgvector, almacenamiento compatible con S3 con URLs firmadas, Ollama en local para el asistente y los embeddings, Gemini solo para la visión y las explicaciones de discrepancias, y, de forma opcional, un proveedor externo de modelos que una cooperativa puede elegir con su propia clave. Todo ello corre en Docker en un servidor propio; solo la API sale a internet, a través de Cloudflare Tunnel.</a:t>
             </a:r>
           </a:p>
         </p:txBody>
@@ -1553,7 +1553,7 @@
           <a:lstStyle/>
           <a:p>
             <a:r>
-              <a:t>Cada decisión importante está en un ADR inmutable: si una decisión cambia, se escribe otro ADR. Hay 19. Las primeras, de la 001 a la 005, fijan la base: Expo, monolito modular, multi-cooperativa con base de datos compartida, permisos por perfil y almacenamiento S3 tras un puerto. El 007 elegía Claude para visión y fue sustituido por el 009, con Gemini. Las últimas cuentan lo que pasó al desplegar: la 012 mueve la API a un servidor propio con Cloudflare Tunnel porque Render y Railway pedían tarjeta; la 013 pasa el asistente a un modelo local en Ollama por la cuota de Gemini; la 014 deja elegir el modelo por cooperativa; la 015 fija qwen3:4b-instruct como modelo por defecto tras medir; la 016 entrega las invitaciones como enlace; la 017 pone dominio propio a la web; y la 018 permite color y logo por cooperativa; y la 019 deja que una cooperativa use un proveedor externo de modelos con su propia clave, cifrada en el servidor.</a:t>
+              <a:t>Cada decisión importante está en un ADR inmutable: si una decisión cambia, se escribe otro ADR. Hay 20. Las primeras, de la 001 a la 005, fijan la base: Expo, monolito modular, multi-cooperativa con base de datos compartida, permisos por perfil y almacenamiento S3 tras un puerto. El 007 elegía Claude para visión y fue sustituido por el 009, con Gemini. Las últimas cuentan lo que pasó al desplegar: la 012 mueve la API a un servidor propio con Cloudflare Tunnel porque Render y Railway pedían tarjeta; la 013 pasa el asistente a un modelo local en Ollama por la cuota de Gemini; la 014 deja elegir el modelo por cooperativa; la 015 fija qwen3:4b-instruct como modelo por defecto tras medir; la 016 entrega las invitaciones como enlace; la 017 pone dominio propio a la web; la 018 permite color y logo por cooperativa; la 019 deja que una cooperativa use un proveedor externo de modelos con su propia clave, cifrada en el servidor; y la 020, la última, migra la interfaz a react-native-paper (Material Design 3), con el tema generado a partir del color de cada cooperativa.</a:t>
             </a:r>
           </a:p>
         </p:txBody>
@@ -1811,7 +1811,7 @@
           <a:lstStyle/>
           <a:p>
             <a:r>
-              <a:t>Además de usar IA en el producto, el proyecto se ha construido con Claude Code y Spec Driven Development. Primero la especificación: visión, stack, plan por hitos y 56 historias de usuario con reglas de negocio y requisitos no funcionales, antes del código. CLAUDE.md es el contrato con el agente: reglas no negociables, forma de trabajar y comandos; y una regla propia de ESLint hace cumplir las fronteras entre módulos aunque escriba el agente. Dominio con TDD a partir de los criterios de la especificación; los identificadores de requisitos aparecen en tests y en commits con Conventional Commits. 119 de los 120 commits, el 99 por ciento, llevan el trailer Co-Authored-By de Claude; el único sin él es el inicial. Hacia el final trabajé con agentes en paralelo, cada uno en su git worktree y rama, y luego integré; ahí aprendí que hace falta disciplina de integración. Y las decisiones sobre IA se tomaron midiendo: un conjunto de evaluación de 23 preguntas contra el modelo real y un benchmark de modelos locales, que se ve en la siguiente diapositiva.</a:t>
+              <a:t>Además de usar IA en el producto, el proyecto se ha construido con Claude Code y Spec Driven Development. Primero la especificación: visión, stack, plan por hitos y 56 historias de usuario con reglas de negocio y requisitos no funcionales, antes del código. CLAUDE.md es el contrato con el agente: reglas no negociables, forma de trabajar y comandos; y una regla propia de ESLint hace cumplir las fronteras entre módulos aunque escriba el agente. Dominio con TDD a partir de los criterios de la especificación; los identificadores de requisitos aparecen en tests y en commits con Conventional Commits. 160 de los 161 commits sin fusiones, el 99 por ciento, llevan el trailer Co-Authored-By de Claude; el único sin él es el inicial. Hacia el final trabajé con agentes en paralelo, cada uno en su git worktree y rama, y luego integré; ahí aprendí que hace falta disciplina de integración. También fijé en el repositorio skills de la comunidad (skills.sh, con su lock) para React Native, Vitest, Prisma, Supabase y Node, con una regla de precedencia en CLAUDE.md: CLAUDE.md, los ADR y las especificaciones mandan sobre las skills, y las desviaciones están documentadas; un registro de skills inyecta sus reglas compactas en cada subagente. La migración de la interfaz a react-native-paper (ADR-020) la hizo un agente orquestador que delegó en subagentes: uno de base, luego siete en paralelo sobre carpetas de funcionalidad disjuntas, uno de verificación y uno que lanzó la app en web con Playwright, hizo capturas y encontró errores visuales que se corrigieron. La memoria persistente entre sesiones, con Engram, mantiene el contexto. Y las decisiones sobre IA se tomaron midiendo: un conjunto de evaluación de 23 preguntas contra el modelo real y un benchmark de modelos locales, que se ve en la siguiente diapositiva.</a:t>
             </a:r>
           </a:p>
         </p:txBody>
@@ -2696,7 +2696,7 @@
                   <a:schemeClr val="accent2"/>
                 </a:solidFill>
               </a:rPr>
-              <a:t>941</a:t>
+              <a:t>1168</a:t>
             </a:r>
           </a:p>
         </p:txBody>
@@ -2730,7 +2730,7 @@
                   <a:schemeClr val="bg1"/>
                 </a:solidFill>
               </a:rPr>
-              <a:t>tests unitarios en 92 ficheros</a:t>
+              <a:t>tests unitarios en 113 ficheros</a:t>
             </a:r>
           </a:p>
         </p:txBody>
@@ -7602,6 +7602,17 @@
               <a:t>móvil y web</a:t>
             </a:r>
           </a:p>
+          <a:p>
+            <a:pPr algn="ctr"/>
+            <a:r>
+              <a:rPr sz="1300" b="1">
+                <a:solidFill>
+                  <a:schemeClr val="bg1"/>
+                </a:solidFill>
+              </a:rPr>
+              <a:t>Paper (MD3)</a:t>
+            </a:r>
+          </a:p>
         </p:txBody>
       </p:sp>
       <p:cxnSp>
@@ -9134,7 +9145,7 @@
                 </a:solidFill>
                 <a:latin typeface="Cambria"/>
               </a:rPr>
-              <a:t>Decisiones clave: 19 ADR</a:t>
+              <a:t>Decisiones clave: 20 ADR</a:t>
             </a:r>
           </a:p>
         </p:txBody>
@@ -11320,6 +11331,121 @@
                 </a:solidFill>
               </a:rPr>
               <a:t>Proveedor externo por cooperativa</a:t>
+            </a:r>
+          </a:p>
+        </p:txBody>
+      </p:sp>
+      <p:sp>
+        <p:nvSpPr>
+          <p:cNvPr id="84" name="Etiqueta"/>
+          <p:cNvSpPr/>
+          <p:nvPr/>
+        </p:nvSpPr>
+        <p:spPr>
+          <a:xfrm>
+            <a:off x="4663440" y="4137660"/>
+            <a:ext cx="548640" cy="283464"/>
+          </a:xfrm>
+          <a:prstGeom prst="roundRect">
+            <a:avLst>
+              <a:gd name="adj" fmla="val 17000"/>
+            </a:avLst>
+          </a:prstGeom>
+          <a:solidFill>
+            <a:schemeClr val="accent1"/>
+          </a:solidFill>
+          <a:ln w="12700">
+            <a:solidFill>
+              <a:schemeClr val="accent1"/>
+            </a:solidFill>
+          </a:ln>
+          <a:effectLst/>
+        </p:spPr>
+        <p:style>
+          <a:lnRef idx="1">
+            <a:schemeClr val="accent1"/>
+          </a:lnRef>
+          <a:fillRef idx="3">
+            <a:schemeClr val="accent1"/>
+          </a:fillRef>
+          <a:effectRef idx="2">
+            <a:schemeClr val="accent1"/>
+          </a:effectRef>
+          <a:fontRef idx="minor">
+            <a:schemeClr val="lt1"/>
+          </a:fontRef>
+        </p:style>
+        <p:txBody>
+          <a:bodyPr rtlCol="0" anchor="ctr"/>
+          <a:lstStyle/>
+          <a:p>
+            <a:pPr algn="ctr"/>
+          </a:p>
+        </p:txBody>
+      </p:sp>
+      <p:sp>
+        <p:nvSpPr>
+          <p:cNvPr id="85" name="TextBox 81"/>
+          <p:cNvSpPr txBox="1"/>
+          <p:nvPr/>
+        </p:nvSpPr>
+        <p:spPr>
+          <a:xfrm>
+            <a:off x="4663440" y="4137660"/>
+            <a:ext cx="548640" cy="283464"/>
+          </a:xfrm>
+          <a:prstGeom prst="rect">
+            <a:avLst/>
+          </a:prstGeom>
+          <a:noFill/>
+        </p:spPr>
+        <p:txBody>
+          <a:bodyPr wrap="square" lIns="0" rIns="0" tIns="0" bIns="0" anchor="ctr">
+            <a:spAutoFit/>
+          </a:bodyPr>
+          <a:lstStyle/>
+          <a:p>
+            <a:pPr algn="ctr"/>
+            <a:r>
+              <a:rPr sz="1200" b="1">
+                <a:solidFill>
+                  <a:schemeClr val="bg1"/>
+                </a:solidFill>
+              </a:rPr>
+              <a:t>020</a:t>
+            </a:r>
+          </a:p>
+        </p:txBody>
+      </p:sp>
+      <p:sp>
+        <p:nvSpPr>
+          <p:cNvPr id="86" name="TextBox 82"/>
+          <p:cNvSpPr txBox="1"/>
+          <p:nvPr/>
+        </p:nvSpPr>
+        <p:spPr>
+          <a:xfrm>
+            <a:off x="5321807" y="4137660"/>
+            <a:ext cx="3383280" cy="283464"/>
+          </a:xfrm>
+          <a:prstGeom prst="rect">
+            <a:avLst/>
+          </a:prstGeom>
+          <a:noFill/>
+        </p:spPr>
+        <p:txBody>
+          <a:bodyPr wrap="square" lIns="0" rIns="0" tIns="0" bIns="0" anchor="ctr">
+            <a:spAutoFit/>
+          </a:bodyPr>
+          <a:lstStyle/>
+          <a:p>
+            <a:r>
+              <a:rPr sz="1300" b="0">
+                <a:solidFill>
+                  <a:schemeClr val="tx1"/>
+                </a:solidFill>
+              </a:rPr>
+              <a:t>Interfaz con react-native-paper (MD3)</a:t>
             </a:r>
           </a:p>
         </p:txBody>
@@ -12886,7 +13012,7 @@
                   <a:schemeClr val="accent2"/>
                 </a:solidFill>
               </a:rPr>
-              <a:t>119 / 120</a:t>
+              <a:t>160 / 161</a:t>
             </a:r>
           </a:p>
         </p:txBody>
@@ -12965,7 +13091,7 @@
                   <a:schemeClr val="accent4"/>
                 </a:solidFill>
               </a:rPr>
-              <a:t>19 ADR</a:t>
+              <a:t>20 ADR</a:t>
             </a:r>
           </a:p>
         </p:txBody>
@@ -13057,6 +13183,40 @@
                 </a:solidFill>
               </a:rPr>
               <a:t>Agentes en paralelo, cada uno en su git worktree</a:t>
+            </a:r>
+          </a:p>
+          <a:p>
+            <a:pPr marL="228600" indent="-228600">
+              <a:spcAft>
+                <a:spcPts val="800"/>
+              </a:spcAft>
+              <a:buSzPct val="100000"/>
+              <a:buChar char="•"/>
+            </a:pPr>
+            <a:r>
+              <a:rPr sz="1500" b="0">
+                <a:solidFill>
+                  <a:schemeClr val="tx1"/>
+                </a:solidFill>
+              </a:rPr>
+              <a:t>Skills de la comunidad fijadas en el repo, con reglas de precedencia</a:t>
+            </a:r>
+          </a:p>
+          <a:p>
+            <a:pPr marL="228600" indent="-228600">
+              <a:spcAft>
+                <a:spcPts val="800"/>
+              </a:spcAft>
+              <a:buSzPct val="100000"/>
+              <a:buChar char="•"/>
+            </a:pPr>
+            <a:r>
+              <a:rPr sz="1500" b="0">
+                <a:solidFill>
+                  <a:schemeClr val="tx1"/>
+                </a:solidFill>
+              </a:rPr>
+              <a:t>Migración a Paper: un agente orquestador y subagentes en paralelo</a:t>
             </a:r>
           </a:p>
           <a:p>

</xml_diff>

<commit_message>
docs(slides): drop the cooperative logo from the deck, 21 ADR (ADR-021)
Adds the 021 tile and updates counts (21 ADR, 1148 unit and 523 integration
tests), removes the logo from the module, security and ADR slides and their
speaker notes. The PDF is exported with Microsoft PowerPoint.

Co-Authored-By: Claude Opus 5.5 <noreply@anthropic.com>
</commit_message>
<xml_diff>
--- a/docs/slides/multicooperativa-tfm.pptx
+++ b/docs/slides/multicooperativa-tfm.pptx
@@ -777,7 +777,7 @@
           <a:lstStyle/>
           <a:p>
             <a:r>
-              <a:t>Los números, medidos el 21 de octubre ejecutando pnpm test y pnpm test:integration: 1168 tests unitarios en 113 ficheros (852 de la API, 295 de la app y 21 de contratos) y 477 tests de integración en 25 ficheros, todos en verde. Los de integración corren contra PostgreSQL y S3 reales, e incluyen el aislamiento entre cooperativas. Husky ejecuta lint, typecheck y tests en el pre-commit, y la CI de GitHub Actions comprueba formato, lint, tipos, tests, migraciones e integración. A la derecha, el benchmark de modelos locales para el asistente, sobre el conjunto de evaluación de entonces, 22 preguntas, medido en un Mac con 12 CPU y sin GPU: qwen3:8b acierta 19, qwen3:4b-instruct 18, gemma4:e4b 15, llama3.2:3b 7, qwen2.5:3b 5 y phi4-mini 4. Hoy el conjunto tiene 23 preguntas. El servidor lleva qwen3:4b-instruct por defecto: pierde una pregunta frente al 8b pero responde más rápido en esa CPU; esa rapidez en el servidor la ha comprobado el autor, no se ha medido con el conjunto de evaluación.</a:t>
+              <a:t>Los números, medidos el 22 de octubre ejecutando pnpm test y pnpm test:integration: 1148 tests unitarios en 112 ficheros (832 de la API, 295 de la app y 21 de contratos) y 523 tests de integración en 27 ficheros, todos en verde. Los de integración corren contra PostgreSQL y S3 reales, e incluyen el aislamiento entre cooperativas. Husky ejecuta lint, typecheck y tests en el pre-commit, y la CI de GitHub Actions comprueba formato, lint, tipos, tests, migraciones e integración. A la derecha, el benchmark de modelos locales para el asistente, sobre el conjunto de evaluación de entonces, 22 preguntas, medido en un Mac con 12 CPU y sin GPU: qwen3:8b acierta 19, qwen3:4b-instruct 18, gemma4:e4b 15, llama3.2:3b 7, qwen2.5:3b 5 y phi4-mini 4. Hoy el conjunto tiene 23 preguntas. El servidor lleva qwen3:4b-instruct por defecto: pierde una pregunta frente al 8b pero responde más rápido en esa CPU; esa rapidez en el servidor la ha comprobado el autor, no se ha medido con el conjunto de evaluación.</a:t>
             </a:r>
           </a:p>
         </p:txBody>
@@ -1121,7 +1121,7 @@
           <a:lstStyle/>
           <a:p>
             <a:r>
-              <a:t>Muchas gracias. El código, la documentación y los 20 ADR están en el repositorio de GitHub; la demo está en cooperativa.chaparro2001.com, la API en api-cooperativa.chaparro2001.com y el vídeo en el enlace de la diapositiva. Quedo a disposición del tribunal para preguntas.</a:t>
+              <a:t>Muchas gracias. El código, la documentación y los 21 ADR están en el repositorio de GitHub; la demo está en cooperativa.chaparro2001.com, la API en api-cooperativa.chaparro2001.com y el vídeo en el enlace de la diapositiva. Quedo a disposición del tribunal para preguntas.</a:t>
             </a:r>
           </a:p>
         </p:txBody>
@@ -1295,7 +1295,7 @@
           <a:lstStyle/>
           <a:p>
             <a:r>
-              <a:t>La solución es una aplicación estándar, válida para cualquier tipo de cooperativa: agrícola, de vivienda, de trabajo o de consumo, sin funcionalidad sectorial. Un mismo usuario puede pertenecer a varias cooperativas con un perfil distinto en cada una, y los datos de cada cooperativa están aislados. Hay cuatro perfiles: el socio, que se informa, vota, lee documentos y consulta su capital; el consejo rector, que publica comunicados, convoca asambleas y vigila pagos y cobros; el gestor, que registra y concilia albaranes y facturas y puede no ser socio; y el administrador, que da acceso con invitaciones, asigna perfiles y personaliza el color y el logo de su cooperativa. Los permisos se definen por módulo, nivel y alcance; el backend decide y la app solo oculta.</a:t>
+              <a:t>La solución es una aplicación estándar, válida para cualquier tipo de cooperativa: agrícola, de vivienda, de trabajo o de consumo, sin funcionalidad sectorial. Un mismo usuario puede pertenecer a varias cooperativas con un perfil distinto en cada una, y los datos de cada cooperativa están aislados. Hay cuatro perfiles: el socio, que se informa, vota, lee documentos y consulta su capital; el consejo rector, que publica comunicados, convoca asambleas y vigila pagos y cobros; el gestor, que registra y concilia albaranes y facturas y puede no ser socio; y el administrador, que da acceso con invitaciones, asigna perfiles y personaliza el color de su cooperativa. Los permisos se definen por módulo, nivel y alcance; el backend decide y la app solo oculta.</a:t>
             </a:r>
           </a:p>
         </p:txBody>
@@ -1381,7 +1381,7 @@
           <a:lstStyle/>
           <a:p>
             <a:r>
-              <a:t>Esta es la foto honesta. Los siete módulos del MVP están implementados y funcionando: acceso y perfiles, con la administración de miembros y las invitaciones por enlace; comunicados; documentos con búsqueda semántica; asambleas con votación, quórum y mayorías; facturas y albaranes con captura, extracción por IA y explicación de discrepancias, con proveedores y clientes; el área del socio con su capital y aportaciones; y el asistente de IA con citas, historial de conversaciones y modelo local. Además, cada cooperativa puede personalizar su color y su logo. Lo que queda como trabajo futuro: notificaciones push, Sentry, pruebas E2E con Maestro, las reclamaciones de facturas, los binarios nativos con EAS Build y el envío de invitaciones por correo.</a:t>
+              <a:t>Esta es la foto honesta. Los siete módulos del MVP están implementados y funcionando: acceso y perfiles, con la administración de miembros y las invitaciones por enlace; comunicados; documentos con búsqueda semántica; asambleas con votación, quórum y mayorías; facturas y albaranes con captura, extracción por IA y explicación de discrepancias, con proveedores y clientes; el área del socio con su capital y aportaciones; y el asistente de IA con citas, historial de conversaciones y modelo local. Además, cada cooperativa puede personalizar su color. Lo que queda como trabajo futuro: notificaciones push, Sentry, pruebas E2E con Maestro, las reclamaciones de facturas, los binarios nativos con EAS Build y el envío de invitaciones por correo.</a:t>
             </a:r>
           </a:p>
         </p:txBody>
@@ -1553,7 +1553,7 @@
           <a:lstStyle/>
           <a:p>
             <a:r>
-              <a:t>Cada decisión importante está en un ADR inmutable: si una decisión cambia, se escribe otro ADR. Hay 20. Las primeras, de la 001 a la 005, fijan la base: Expo, monolito modular, multi-cooperativa con base de datos compartida, permisos por perfil y almacenamiento S3 tras un puerto. El 007 elegía Claude para visión y fue sustituido por el 009, con Gemini. Las últimas cuentan lo que pasó al desplegar: la 012 mueve la API a un servidor propio con Cloudflare Tunnel porque Render y Railway pedían tarjeta; la 013 pasa el asistente a un modelo local en Ollama por la cuota de Gemini; la 014 deja elegir el modelo por cooperativa; la 015 fija qwen3:4b-instruct como modelo por defecto tras medir; la 016 entrega las invitaciones como enlace; la 017 pone dominio propio a la web; la 018 permite color y logo por cooperativa; la 019 deja que una cooperativa use un proveedor externo de modelos con su propia clave, cifrada en el servidor; y la 020, la última, migra la interfaz a react-native-paper (Material Design 3), con el tema generado a partir del color de cada cooperativa.</a:t>
+              <a:t>Cada decisión importante está en un ADR inmutable: si una decisión cambia, se escribe otro ADR. Hay 21. Las primeras, de la 001 a la 005, fijan la base: Expo, monolito modular, multi-cooperativa con base de datos compartida, permisos por perfil y almacenamiento S3 tras un puerto. El 007 elegía Claude para visión y fue sustituido por el 009, con Gemini. Las últimas cuentan lo que pasó al desplegar: la 012 mueve la API a un servidor propio con Cloudflare Tunnel porque Render y Railway pedían tarjeta; la 013 pasa el asistente a un modelo local en Ollama por la cuota de Gemini; la 014 deja elegir el modelo por cooperativa; la 015 fija qwen3:4b-instruct como modelo por defecto tras medir; la 016 entrega las invitaciones como enlace; la 017 pone dominio propio a la web; la 018 permite color por cooperativa (su parte de logo la retira la 021); la 019 deja que una cooperativa use un proveedor externo de modelos con su propia clave, cifrada en el servidor; la 020 migra la interfaz a react-native-paper (Material Design 3), con el tema generado a partir del color de cada cooperativa; y la 021, la última, elimina el logo por cooperativa: solo se veía tras iniciar sesión y la subida de ficheros no compensaba antes de la entrega.</a:t>
             </a:r>
           </a:p>
         </p:txBody>
@@ -1639,7 +1639,7 @@
           <a:lstStyle/>
           <a:p>
             <a:r>
-              <a:t>La seguridad se decide en el backend. Cada caso de uso comprueba el permiso y deniega por defecto; la app solo oculta lo que el servidor dice que no está permitido. El aislamiento es por cooperativa, también en la búsqueda semántica y en las herramientas del asistente: un recurso de otra cooperativa responde 404 y un módulo sin permiso responde 403. Las contraseñas usan Argon2id con bloqueo por intentos fallidos, y las sesiones JWT con refresh rotatorio. Los ficheros se sirven con URLs firmadas que caducan; el logo de la cooperativa se valida por su contenido, no por la extensión, y se rechaza el SVG porque puede llevar scripts; el color elegido debe cumplir contraste WCAG AA con el texto blanco. CORS tiene una lista de orígenes permitidos y los secretos no están en el repositorio; la clave que una cooperativa aporta para un proveedor externo se guarda cifrada con AES-256-GCM, y el servidor solo llama a un catálogo fijo de proveedores, nunca a una URL enviada por el cliente, para evitar SSRF. Y todo esto está cubierto por tests: la matriz de perfiles por módulos y el aislamiento entre cooperativas.</a:t>
+              <a:t>La seguridad se decide en el backend. Cada caso de uso comprueba el permiso y deniega por defecto; la app solo oculta lo que el servidor dice que no está permitido. El aislamiento es por cooperativa, también en la búsqueda semántica y en las herramientas del asistente: un recurso de otra cooperativa responde 404 y un módulo sin permiso responde 403. Las contraseñas usan Argon2id con bloqueo por intentos fallidos, y las sesiones JWT con refresh rotatorio. Los ficheros se sirven con URLs firmadas que caducan; el color de marca elegido debe cumplir contraste WCAG AA con el texto blanco. CORS tiene una lista de orígenes permitidos y los secretos no están en el repositorio; la clave que una cooperativa aporta para un proveedor externo se guarda cifrada con AES-256-GCM, y el servidor solo llama a un catálogo fijo de proveedores, nunca a una URL enviada por el cliente, para evitar SSRF. Y todo esto está cubierto por tests: la matriz de perfiles por módulos y el aislamiento entre cooperativas.</a:t>
             </a:r>
           </a:p>
         </p:txBody>
@@ -2696,7 +2696,7 @@
                   <a:schemeClr val="accent2"/>
                 </a:solidFill>
               </a:rPr>
-              <a:t>1168</a:t>
+              <a:t>1148</a:t>
             </a:r>
           </a:p>
         </p:txBody>
@@ -2730,7 +2730,7 @@
                   <a:schemeClr val="bg1"/>
                 </a:solidFill>
               </a:rPr>
-              <a:t>tests unitarios en 113 ficheros</a:t>
+              <a:t>tests unitarios en 112 ficheros</a:t>
             </a:r>
           </a:p>
         </p:txBody>
@@ -2812,7 +2812,7 @@
                   <a:schemeClr val="accent2"/>
                 </a:solidFill>
               </a:rPr>
-              <a:t>477</a:t>
+              <a:t>523</a:t>
             </a:r>
           </a:p>
         </p:txBody>
@@ -2846,7 +2846,7 @@
                   <a:schemeClr val="bg1"/>
                 </a:solidFill>
               </a:rPr>
-              <a:t>tests de integración en 25 ficheros</a:t>
+              <a:t>tests de integración en 27 ficheros</a:t>
             </a:r>
           </a:p>
         </p:txBody>
@@ -7196,7 +7196,7 @@
                   <a:schemeClr val="bg1"/>
                 </a:solidFill>
               </a:rPr>
-              <a:t>Marca por cooperativa (color y logo)</a:t>
+              <a:t>Marca por cooperativa (color)</a:t>
             </a:r>
           </a:p>
         </p:txBody>
@@ -9145,7 +9145,7 @@
                 </a:solidFill>
                 <a:latin typeface="Cambria"/>
               </a:rPr>
-              <a:t>Decisiones clave: 20 ADR</a:t>
+              <a:t>Decisiones clave: 21 ADR</a:t>
             </a:r>
           </a:p>
         </p:txBody>
@@ -11215,7 +11215,7 @@
                   <a:schemeClr val="tx1"/>
                 </a:solidFill>
               </a:rPr>
-              <a:t>Color y logo por cooperativa</a:t>
+              <a:t>Color por cooperativa (logo: 021)</a:t>
             </a:r>
           </a:p>
         </p:txBody>
@@ -11446,6 +11446,121 @@
                 </a:solidFill>
               </a:rPr>
               <a:t>Interfaz con react-native-paper (MD3)</a:t>
+            </a:r>
+          </a:p>
+        </p:txBody>
+      </p:sp>
+      <p:sp>
+        <p:nvSpPr>
+          <p:cNvPr id="87" name="Etiqueta"/>
+          <p:cNvSpPr/>
+          <p:nvPr/>
+        </p:nvSpPr>
+        <p:spPr>
+          <a:xfrm>
+            <a:off x="4663440" y="4480560"/>
+            <a:ext cx="548640" cy="283464"/>
+          </a:xfrm>
+          <a:prstGeom prst="roundRect">
+            <a:avLst>
+              <a:gd name="adj" fmla="val 17000"/>
+            </a:avLst>
+          </a:prstGeom>
+          <a:solidFill>
+            <a:schemeClr val="accent1"/>
+          </a:solidFill>
+          <a:ln w="12700">
+            <a:solidFill>
+              <a:schemeClr val="accent1"/>
+            </a:solidFill>
+          </a:ln>
+          <a:effectLst/>
+        </p:spPr>
+        <p:style>
+          <a:lnRef idx="1">
+            <a:schemeClr val="accent1"/>
+          </a:lnRef>
+          <a:fillRef idx="3">
+            <a:schemeClr val="accent1"/>
+          </a:fillRef>
+          <a:effectRef idx="2">
+            <a:schemeClr val="accent1"/>
+          </a:effectRef>
+          <a:fontRef idx="minor">
+            <a:schemeClr val="lt1"/>
+          </a:fontRef>
+        </p:style>
+        <p:txBody>
+          <a:bodyPr rtlCol="0" anchor="ctr"/>
+          <a:lstStyle/>
+          <a:p>
+            <a:pPr algn="ctr"/>
+          </a:p>
+        </p:txBody>
+      </p:sp>
+      <p:sp>
+        <p:nvSpPr>
+          <p:cNvPr id="88" name="TextBox 81"/>
+          <p:cNvSpPr txBox="1"/>
+          <p:nvPr/>
+        </p:nvSpPr>
+        <p:spPr>
+          <a:xfrm>
+            <a:off x="4663440" y="4480560"/>
+            <a:ext cx="548640" cy="283464"/>
+          </a:xfrm>
+          <a:prstGeom prst="rect">
+            <a:avLst/>
+          </a:prstGeom>
+          <a:noFill/>
+        </p:spPr>
+        <p:txBody>
+          <a:bodyPr wrap="square" lIns="0" rIns="0" tIns="0" bIns="0" anchor="ctr">
+            <a:spAutoFit/>
+          </a:bodyPr>
+          <a:lstStyle/>
+          <a:p>
+            <a:pPr algn="ctr"/>
+            <a:r>
+              <a:rPr sz="1200" b="1">
+                <a:solidFill>
+                  <a:schemeClr val="bg1"/>
+                </a:solidFill>
+              </a:rPr>
+              <a:t>021</a:t>
+            </a:r>
+          </a:p>
+        </p:txBody>
+      </p:sp>
+      <p:sp>
+        <p:nvSpPr>
+          <p:cNvPr id="89" name="TextBox 82"/>
+          <p:cNvSpPr txBox="1"/>
+          <p:nvPr/>
+        </p:nvSpPr>
+        <p:spPr>
+          <a:xfrm>
+            <a:off x="5321807" y="4480560"/>
+            <a:ext cx="3383280" cy="283464"/>
+          </a:xfrm>
+          <a:prstGeom prst="rect">
+            <a:avLst/>
+          </a:prstGeom>
+          <a:noFill/>
+        </p:spPr>
+        <p:txBody>
+          <a:bodyPr wrap="square" lIns="0" rIns="0" tIns="0" bIns="0" anchor="ctr">
+            <a:spAutoFit/>
+          </a:bodyPr>
+          <a:lstStyle/>
+          <a:p>
+            <a:r>
+              <a:rPr sz="1300" b="0">
+                <a:solidFill>
+                  <a:schemeClr val="tx1"/>
+                </a:solidFill>
+              </a:rPr>
+              <a:t>Sin logo por cooperativa (el color se mantiene)</a:t>
             </a:r>
           </a:p>
         </p:txBody>
@@ -12005,7 +12120,7 @@
                   <a:schemeClr val="tx1"/>
                 </a:solidFill>
               </a:rPr>
-              <a:t>URLs firmadas; logo verificado por contenido, SVG rechazado; color con contraste AA</a:t>
+              <a:t>URLs firmadas que caducan; color de marca con contraste AA</a:t>
             </a:r>
           </a:p>
         </p:txBody>
@@ -13091,7 +13206,7 @@
                   <a:schemeClr val="accent4"/>
                 </a:solidFill>
               </a:rPr>
-              <a:t>20 ADR</a:t>
+              <a:t>21 ADR</a:t>
             </a:r>
           </a:p>
         </p:txBody>

</xml_diff>

<commit_message>
docs(slides): commit counts after removing the cooperative logo (166 of 167 co-authored)
Co-Authored-By: Claude Opus 5.5 <noreply@anthropic.com>
</commit_message>
<xml_diff>
--- a/docs/slides/multicooperativa-tfm.pptx
+++ b/docs/slides/multicooperativa-tfm.pptx
@@ -1811,7 +1811,7 @@
           <a:lstStyle/>
           <a:p>
             <a:r>
-              <a:t>Además de usar IA en el producto, el proyecto se ha construido con Claude Code y Spec Driven Development. Primero la especificación: visión, stack, plan por hitos y 56 historias de usuario con reglas de negocio y requisitos no funcionales, antes del código. CLAUDE.md es el contrato con el agente: reglas no negociables, forma de trabajar y comandos; y una regla propia de ESLint hace cumplir las fronteras entre módulos aunque escriba el agente. Dominio con TDD a partir de los criterios de la especificación; los identificadores de requisitos aparecen en tests y en commits con Conventional Commits. 160 de los 161 commits sin fusiones, el 99 por ciento, llevan el trailer Co-Authored-By de Claude; el único sin él es el inicial. Hacia el final trabajé con agentes en paralelo, cada uno en su git worktree y rama, y luego integré; ahí aprendí que hace falta disciplina de integración. También fijé en el repositorio skills de la comunidad (skills.sh, con su lock) para React Native, Vitest, Prisma, Supabase y Node, con una regla de precedencia en CLAUDE.md: CLAUDE.md, los ADR y las especificaciones mandan sobre las skills, y las desviaciones están documentadas; un registro de skills inyecta sus reglas compactas en cada subagente. La migración de la interfaz a react-native-paper (ADR-020) la hizo un agente orquestador que delegó en subagentes: uno de base, luego siete en paralelo sobre carpetas de funcionalidad disjuntas, uno de verificación y uno que lanzó la app en web con Playwright, hizo capturas y encontró errores visuales que se corrigieron. La memoria persistente entre sesiones, con Engram, mantiene el contexto. Y las decisiones sobre IA se tomaron midiendo: un conjunto de evaluación de 23 preguntas contra el modelo real y un benchmark de modelos locales, que se ve en la siguiente diapositiva.</a:t>
+              <a:t>Además de usar IA en el producto, el proyecto se ha construido con Claude Code y Spec Driven Development. Primero la especificación: visión, stack, plan por hitos y 56 historias de usuario con reglas de negocio y requisitos no funcionales, antes del código. CLAUDE.md es el contrato con el agente: reglas no negociables, forma de trabajar y comandos; y una regla propia de ESLint hace cumplir las fronteras entre módulos aunque escriba el agente. Dominio con TDD a partir de los criterios de la especificación; los identificadores de requisitos aparecen en tests y en commits con Conventional Commits. 166 de los 167 commits sin fusiones, el 99 por ciento, llevan el trailer Co-Authored-By de Claude; el único sin él es el inicial. Hacia el final trabajé con agentes en paralelo, cada uno en su git worktree y rama, y luego integré; ahí aprendí que hace falta disciplina de integración. También fijé en el repositorio skills de la comunidad (skills.sh, con su lock) para React Native, Vitest, Prisma, Supabase y Node, con una regla de precedencia en CLAUDE.md: CLAUDE.md, los ADR y las especificaciones mandan sobre las skills, y las desviaciones están documentadas; un registro de skills inyecta sus reglas compactas en cada subagente. La migración de la interfaz a react-native-paper (ADR-020) la hizo un agente orquestador que delegó en subagentes: uno de base, luego siete en paralelo sobre carpetas de funcionalidad disjuntas, uno de verificación y uno que lanzó la app en web con Playwright, hizo capturas y encontró errores visuales que se corrigieron. La memoria persistente entre sesiones, con Engram, mantiene el contexto. Y las decisiones sobre IA se tomaron midiendo: un conjunto de evaluación de 23 preguntas contra el modelo real y un benchmark de modelos locales, que se ve en la siguiente diapositiva.</a:t>
             </a:r>
           </a:p>
         </p:txBody>
@@ -13127,7 +13127,7 @@
                   <a:schemeClr val="accent2"/>
                 </a:solidFill>
               </a:rPr>
-              <a:t>160 / 161</a:t>
+              <a:t>166 / 167</a:t>
             </a:r>
           </a:p>
         </p:txBody>

</xml_diff>

<commit_message>
docs(slides): design system slide with screenshots, 24 ADR, current counts and demo flows; video script (ADR-024)
Co-Authored-By: Claude Opus 5.5 <noreply@anthropic.com>
</commit_message>
<xml_diff>
--- a/docs/slides/multicooperativa-tfm.pptx
+++ b/docs/slides/multicooperativa-tfm.pptx
@@ -10,6 +10,7 @@
     <p:sldId id="258" r:id="rId4"/>
     <p:sldId id="259" r:id="rId5"/>
     <p:sldId id="260" r:id="rId6"/>
+    <p:sldId id="270" r:id="rId21"/>
     <p:sldId id="261" r:id="rId7"/>
     <p:sldId id="262" r:id="rId8"/>
     <p:sldId id="263" r:id="rId9"/>
@@ -2525,6 +2526,430 @@
 
 <file path=ppt/slides/slide10.xml><?xml version="1.0" encoding="utf-8"?>
 <p:sld xmlns:a="http://schemas.openxmlformats.org/drawingml/2006/main" xmlns:r="http://schemas.openxmlformats.org/officeDocument/2006/relationships" xmlns:p="http://schemas.openxmlformats.org/presentationml/2006/main">
+  <p:cSld name="Slide 9">
+    <p:spTree>
+      <p:nvGrpSpPr>
+        <p:cNvPr id="1" name=""/>
+        <p:cNvGrpSpPr/>
+        <p:nvPr/>
+      </p:nvGrpSpPr>
+      <p:grpSpPr>
+        <a:xfrm>
+          <a:off x="0" y="0"/>
+          <a:ext cx="0" cy="0"/>
+          <a:chOff x="0" y="0"/>
+          <a:chExt cx="0" cy="0"/>
+        </a:xfrm>
+      </p:grpSpPr>
+      <p:sp>
+        <p:nvSpPr>
+          <p:cNvPr id="25" name="Slide Number Placeholder 0"/>
+          <p:cNvSpPr>
+            <a:spLocks noGrp="1"/>
+          </p:cNvSpPr>
+          <p:nvPr>
+            <p:ph type="sldNum" sz="quarter" idx="4294967295"/>
+          </p:nvPr>
+        </p:nvSpPr>
+        <p:spPr>
+          <a:xfrm>
+            <a:off x="8229600" y="4754880"/>
+            <a:ext cx="457200" cy="274320"/>
+          </a:xfrm>
+          <a:prstGeom prst="rect">
+            <a:avLst/>
+          </a:prstGeom>
+          <a:extLst>
+            <a:ext uri="{C572A759-6A51-4108-AA02-DFA0A04FC94B}">
+              <ma14:wrappingTextBoxFlag xmlns:ma14="http://schemas.microsoft.com/office/mac/drawingml/2011/main" val="0"/>
+            </a:ext>
+          </a:extLst>
+        </p:spPr>
+        <p:txBody>
+          <a:bodyPr/>
+          <a:lstStyle>
+            <a:lvl1pPr>
+              <a:defRPr sz="1000">
+                <a:solidFill>
+                  <a:schemeClr val="accent6"/>
+                </a:solidFill>
+              </a:defRPr>
+            </a:lvl1pPr>
+          </a:lstStyle>
+          <a:p>
+            <a:pPr algn="r"/>
+            <a:fld id="{F7021451-1387-4CA6-816F-3879F97B5CBC}" type="slidenum">
+              <a:rPr b="0" lang="en-US"/>
+              <a:t>9</a:t>
+            </a:fld>
+            <a:endParaRPr lang="en-US"/>
+          </a:p>
+        </p:txBody>
+      </p:sp>
+      <p:sp>
+        <p:nvSpPr>
+          <p:cNvPr id="26" name="Titulo"/>
+          <p:cNvSpPr txBox="1"/>
+          <p:nvPr/>
+        </p:nvSpPr>
+        <p:spPr>
+          <a:xfrm>
+            <a:off x="457200" y="274320"/>
+            <a:ext cx="8229600" cy="685800"/>
+          </a:xfrm>
+          <a:prstGeom prst="rect">
+            <a:avLst/>
+          </a:prstGeom>
+          <a:noFill/>
+        </p:spPr>
+        <p:txBody>
+          <a:bodyPr wrap="square" lIns="0" rIns="0" tIns="0" bIns="0" anchor="ctr">
+            <a:spAutoFit/>
+          </a:bodyPr>
+          <a:lstStyle/>
+          <a:p>
+            <a:r>
+              <a:rPr sz="2800" b="1">
+                <a:solidFill>
+                  <a:schemeClr val="tx2"/>
+                </a:solidFill>
+                <a:latin typeface="Cambria"/>
+              </a:rPr>
+              <a:t>IA en el desarrollo</a:t>
+            </a:r>
+          </a:p>
+        </p:txBody>
+      </p:sp>
+      <p:sp>
+        <p:nvSpPr>
+          <p:cNvPr id="27" name="Panel cifras"/>
+          <p:cNvSpPr/>
+          <p:nvPr/>
+        </p:nvSpPr>
+        <p:spPr>
+          <a:xfrm>
+            <a:off x="457200" y="1188720"/>
+            <a:ext cx="2834640" cy="3246120"/>
+          </a:xfrm>
+          <a:prstGeom prst="roundRect">
+            <a:avLst>
+              <a:gd name="adj" fmla="val 5000"/>
+            </a:avLst>
+          </a:prstGeom>
+          <a:solidFill>
+            <a:schemeClr val="accent1"/>
+          </a:solidFill>
+          <a:ln w="12700">
+            <a:solidFill>
+              <a:schemeClr val="accent1"/>
+            </a:solidFill>
+          </a:ln>
+          <a:effectLst/>
+        </p:spPr>
+        <p:style>
+          <a:lnRef idx="1">
+            <a:schemeClr val="accent1"/>
+          </a:lnRef>
+          <a:fillRef idx="3">
+            <a:schemeClr val="accent1"/>
+          </a:fillRef>
+          <a:effectRef idx="2">
+            <a:schemeClr val="accent1"/>
+          </a:effectRef>
+          <a:fontRef idx="minor">
+            <a:schemeClr val="lt1"/>
+          </a:fontRef>
+        </p:style>
+        <p:txBody>
+          <a:bodyPr rtlCol="0" anchor="ctr"/>
+          <a:lstStyle/>
+          <a:p>
+            <a:pPr algn="ctr"/>
+          </a:p>
+        </p:txBody>
+      </p:sp>
+      <p:sp>
+        <p:nvSpPr>
+          <p:cNvPr id="28" name="TextBox 27"/>
+          <p:cNvSpPr txBox="1"/>
+          <p:nvPr/>
+        </p:nvSpPr>
+        <p:spPr>
+          <a:xfrm>
+            <a:off x="457200" y="1371600"/>
+            <a:ext cx="2834640" cy="868680"/>
+          </a:xfrm>
+          <a:prstGeom prst="rect">
+            <a:avLst/>
+          </a:prstGeom>
+          <a:noFill/>
+        </p:spPr>
+        <p:txBody>
+          <a:bodyPr wrap="square" lIns="0" rIns="0" tIns="0" bIns="0" anchor="ctr">
+            <a:spAutoFit/>
+          </a:bodyPr>
+          <a:lstStyle/>
+          <a:p>
+            <a:pPr algn="ctr"/>
+            <a:r>
+              <a:rPr sz="4000" b="1">
+                <a:solidFill>
+                  <a:schemeClr val="accent2"/>
+                </a:solidFill>
+              </a:rPr>
+              <a:t>236 / 237</a:t>
+            </a:r>
+          </a:p>
+        </p:txBody>
+      </p:sp>
+      <p:sp>
+        <p:nvSpPr>
+          <p:cNvPr id="29" name="TextBox 28"/>
+          <p:cNvSpPr txBox="1"/>
+          <p:nvPr/>
+        </p:nvSpPr>
+        <p:spPr>
+          <a:xfrm>
+            <a:off x="640080" y="2286000"/>
+            <a:ext cx="2468880" cy="731520"/>
+          </a:xfrm>
+          <a:prstGeom prst="rect">
+            <a:avLst/>
+          </a:prstGeom>
+          <a:noFill/>
+        </p:spPr>
+        <p:txBody>
+          <a:bodyPr wrap="square" lIns="0" rIns="0" tIns="0" bIns="0" anchor="ctr">
+            <a:spAutoFit/>
+          </a:bodyPr>
+          <a:lstStyle/>
+          <a:p>
+            <a:pPr algn="ctr"/>
+            <a:r>
+              <a:rPr sz="1600" b="0">
+                <a:solidFill>
+                  <a:schemeClr val="bg1"/>
+                </a:solidFill>
+              </a:rPr>
+              <a:t>commits co-autorados con Claude (99 %)</a:t>
+            </a:r>
+          </a:p>
+        </p:txBody>
+      </p:sp>
+      <p:sp>
+        <p:nvSpPr>
+          <p:cNvPr id="30" name="TextBox 29"/>
+          <p:cNvSpPr txBox="1"/>
+          <p:nvPr/>
+        </p:nvSpPr>
+        <p:spPr>
+          <a:xfrm>
+            <a:off x="640080" y="3200400"/>
+            <a:ext cx="2468880" cy="822960"/>
+          </a:xfrm>
+          <a:prstGeom prst="rect">
+            <a:avLst/>
+          </a:prstGeom>
+          <a:noFill/>
+        </p:spPr>
+        <p:txBody>
+          <a:bodyPr wrap="square" lIns="0" rIns="0" tIns="0" bIns="0" anchor="ctr">
+            <a:spAutoFit/>
+          </a:bodyPr>
+          <a:lstStyle/>
+          <a:p>
+            <a:pPr algn="ctr"/>
+            <a:r>
+              <a:rPr sz="1400" b="0">
+                <a:solidFill>
+                  <a:schemeClr val="accent4"/>
+                </a:solidFill>
+              </a:rPr>
+              <a:t>59 historias de usuario</a:t>
+            </a:r>
+          </a:p>
+          <a:p>
+            <a:pPr algn="ctr"/>
+            <a:r>
+              <a:rPr sz="1400" b="0">
+                <a:solidFill>
+                  <a:schemeClr val="accent4"/>
+                </a:solidFill>
+              </a:rPr>
+              <a:t>24 ADR</a:t>
+            </a:r>
+          </a:p>
+        </p:txBody>
+      </p:sp>
+      <p:sp>
+        <p:nvSpPr>
+          <p:cNvPr id="31" name="TextBox 30"/>
+          <p:cNvSpPr txBox="1"/>
+          <p:nvPr/>
+        </p:nvSpPr>
+        <p:spPr>
+          <a:xfrm>
+            <a:off x="3611880" y="1188720"/>
+            <a:ext cx="5074920" cy="3291840"/>
+          </a:xfrm>
+          <a:prstGeom prst="rect">
+            <a:avLst/>
+          </a:prstGeom>
+          <a:noFill/>
+        </p:spPr>
+        <p:txBody>
+          <a:bodyPr wrap="square" lIns="0" rIns="0" tIns="0" bIns="0">
+            <a:spAutoFit/>
+          </a:bodyPr>
+          <a:lstStyle/>
+          <a:p>
+            <a:pPr marL="228600" indent="-228600">
+              <a:spcAft>
+                <a:spcPts val="800"/>
+              </a:spcAft>
+              <a:buSzPct val="100000"/>
+              <a:buChar char="•"/>
+            </a:pPr>
+            <a:r>
+              <a:rPr sz="1500" b="0">
+                <a:solidFill>
+                  <a:schemeClr val="tx1"/>
+                </a:solidFill>
+              </a:rPr>
+              <a:t>Spec Driven Development: especificación antes del código</a:t>
+            </a:r>
+          </a:p>
+          <a:p>
+            <a:pPr marL="228600" indent="-228600">
+              <a:spcAft>
+                <a:spcPts val="800"/>
+              </a:spcAft>
+              <a:buSzPct val="100000"/>
+              <a:buChar char="•"/>
+            </a:pPr>
+            <a:r>
+              <a:rPr sz="1500" b="0">
+                <a:solidFill>
+                  <a:schemeClr val="tx1"/>
+                </a:solidFill>
+              </a:rPr>
+              <a:t>CLAUDE.md como contrato con el agente; ESLint protege las fronteras</a:t>
+            </a:r>
+          </a:p>
+          <a:p>
+            <a:pPr marL="228600" indent="-228600">
+              <a:spcAft>
+                <a:spcPts val="800"/>
+              </a:spcAft>
+              <a:buSzPct val="100000"/>
+              <a:buChar char="•"/>
+            </a:pPr>
+            <a:r>
+              <a:rPr sz="1500" b="0">
+                <a:solidFill>
+                  <a:schemeClr val="tx1"/>
+                </a:solidFill>
+              </a:rPr>
+              <a:t>TDD en el dominio; IDs de requisitos en tests y commits</a:t>
+            </a:r>
+          </a:p>
+          <a:p>
+            <a:pPr marL="228600" indent="-228600">
+              <a:spcAft>
+                <a:spcPts val="800"/>
+              </a:spcAft>
+              <a:buSzPct val="100000"/>
+              <a:buChar char="•"/>
+            </a:pPr>
+            <a:r>
+              <a:rPr sz="1500" b="0">
+                <a:solidFill>
+                  <a:schemeClr val="tx1"/>
+                </a:solidFill>
+              </a:rPr>
+              <a:t>Agentes en paralelo, cada uno en su git worktree</a:t>
+            </a:r>
+          </a:p>
+          <a:p>
+            <a:pPr marL="228600" indent="-228600">
+              <a:spcAft>
+                <a:spcPts val="800"/>
+              </a:spcAft>
+              <a:buSzPct val="100000"/>
+              <a:buChar char="•"/>
+            </a:pPr>
+            <a:r>
+              <a:rPr sz="1500" b="0">
+                <a:solidFill>
+                  <a:schemeClr val="tx1"/>
+                </a:solidFill>
+              </a:rPr>
+              <a:t>Skills de la comunidad fijadas en el repo, con reglas de precedencia</a:t>
+            </a:r>
+          </a:p>
+          <a:p>
+            <a:pPr marL="228600" indent="-228600">
+              <a:spcAft>
+                <a:spcPts val="800"/>
+              </a:spcAft>
+              <a:buSzPct val="100000"/>
+              <a:buChar char="•"/>
+            </a:pPr>
+            <a:r>
+              <a:rPr sz="1500" b="0">
+                <a:solidFill>
+                  <a:schemeClr val="tx1"/>
+                </a:solidFill>
+              </a:rPr>
+              <a:t>Diseño con IA: brief, herramienta de diseño, análisis de brechas y migración con orquestador y 7 subagentes</a:t>
+            </a:r>
+          </a:p>
+          <a:p>
+            <a:pPr marL="228600" indent="-228600">
+              <a:spcAft>
+                <a:spcPts val="800"/>
+              </a:spcAft>
+              <a:buSzPct val="100000"/>
+              <a:buChar char="•"/>
+            </a:pPr>
+            <a:r>
+              <a:rPr sz="1500" b="0">
+                <a:solidFill>
+                  <a:schemeClr val="tx1"/>
+                </a:solidFill>
+              </a:rPr>
+              <a:t>Evaluaciones con el modelo real (26 preguntas)</a:t>
+            </a:r>
+          </a:p>
+          <a:p>
+            <a:pPr marL="228600" indent="-228600">
+              <a:spcAft>
+                <a:spcPts val="800"/>
+              </a:spcAft>
+              <a:buSzPct val="100000"/>
+              <a:buChar char="•"/>
+            </a:pPr>
+            <a:r>
+              <a:rPr sz="1500" b="0">
+                <a:solidFill>
+                  <a:schemeClr val="tx1"/>
+                </a:solidFill>
+              </a:rPr>
+              <a:t>Benchmark de modelos locales antes de decidir</a:t>
+            </a:r>
+          </a:p>
+        </p:txBody>
+      </p:sp>
+    </p:spTree>
+  </p:cSld>
+  <p:clrMapOvr>
+    <a:masterClrMapping/>
+  </p:clrMapOvr>
+</p:sld>
+</file>
+
+<file path=ppt/slides/slide11.xml><?xml version="1.0" encoding="utf-8"?>
+<p:sld xmlns:a="http://schemas.openxmlformats.org/drawingml/2006/main" xmlns:r="http://schemas.openxmlformats.org/officeDocument/2006/relationships" xmlns:p="http://schemas.openxmlformats.org/presentationml/2006/main">
   <p:cSld name="Slide 10">
     <p:spTree>
       <p:nvGrpSpPr>
@@ -2696,7 +3121,7 @@
                   <a:schemeClr val="accent2"/>
                 </a:solidFill>
               </a:rPr>
-              <a:t>1148</a:t>
+              <a:t>1338</a:t>
             </a:r>
           </a:p>
         </p:txBody>
@@ -2730,7 +3155,7 @@
                   <a:schemeClr val="bg1"/>
                 </a:solidFill>
               </a:rPr>
-              <a:t>tests unitarios en 112 ficheros</a:t>
+              <a:t>tests unitarios en 133 ficheros</a:t>
             </a:r>
           </a:p>
         </p:txBody>
@@ -2812,7 +3237,7 @@
                   <a:schemeClr val="accent2"/>
                 </a:solidFill>
               </a:rPr>
-              <a:t>523</a:t>
+              <a:t>574</a:t>
             </a:r>
           </a:p>
         </p:txBody>
@@ -2846,7 +3271,7 @@
                   <a:schemeClr val="bg1"/>
                 </a:solidFill>
               </a:rPr>
-              <a:t>tests de integración en 27 ficheros</a:t>
+              <a:t>tests de integración en 30 ficheros</a:t>
             </a:r>
           </a:p>
         </p:txBody>
@@ -3092,7 +3517,7 @@
                   <a:schemeClr val="accent6"/>
                 </a:solidFill>
               </a:rPr>
-              <a:t>Mac de 12 CPU, solo CPU · el conjunto tiene hoy 23 preguntas</a:t>
+              <a:t>Mac de 12 CPU, solo CPU · el conjunto tiene hoy 26 preguntas</a:t>
             </a:r>
           </a:p>
         </p:txBody>
@@ -3105,7 +3530,7 @@
 </p:sld>
 </file>
 
-<file path=ppt/slides/slide11.xml><?xml version="1.0" encoding="utf-8"?>
+<file path=ppt/slides/slide12.xml><?xml version="1.0" encoding="utf-8"?>
 <p:sld xmlns:a="http://schemas.openxmlformats.org/drawingml/2006/main" xmlns:r="http://schemas.openxmlformats.org/officeDocument/2006/relationships" xmlns:p="http://schemas.openxmlformats.org/presentationml/2006/main">
   <p:cSld name="Slide 11">
     <p:spTree>
@@ -4253,7 +4678,7 @@
 </p:sld>
 </file>
 
-<file path=ppt/slides/slide12.xml><?xml version="1.0" encoding="utf-8"?>
+<file path=ppt/slides/slide13.xml><?xml version="1.0" encoding="utf-8"?>
 <p:sld xmlns:a="http://schemas.openxmlformats.org/drawingml/2006/main" xmlns:r="http://schemas.openxmlformats.org/officeDocument/2006/relationships" xmlns:p="http://schemas.openxmlformats.org/presentationml/2006/main">
   <p:cSld name="Slide 12">
     <p:spTree>
@@ -4663,7 +5088,7 @@
                             <a:schemeClr val="tx1"/>
                           </a:solidFill>
                         </a:rPr>
-                        <a:t>Comunicados, documentos, asamblea y voto, área del socio, asistente</a:t>
+                        <a:t>"Pendiente para ti", comunicados, documentos, asamblea (Cómo llegar, quórum) y voto, área del socio, asistente</a:t>
                       </a:r>
                     </a:p>
                   </a:txBody>
@@ -5038,7 +5463,7 @@
                             <a:schemeClr val="tx1"/>
                           </a:solidFill>
                         </a:rPr>
-                        <a:t>Miembros e invitación, apariencia, modelo del asistente</a:t>
+                        <a:t>Miembros e invitación, ajustes (apariencia, facturación, asistente IA), historial</a:t>
                       </a:r>
                     </a:p>
                   </a:txBody>
@@ -5081,7 +5506,7 @@
 </p:sld>
 </file>
 
-<file path=ppt/slides/slide13.xml><?xml version="1.0" encoding="utf-8"?>
+<file path=ppt/slides/slide14.xml><?xml version="1.0" encoding="utf-8"?>
 <p:sld xmlns:a="http://schemas.openxmlformats.org/drawingml/2006/main" xmlns:r="http://schemas.openxmlformats.org/officeDocument/2006/relationships" xmlns:p="http://schemas.openxmlformats.org/presentationml/2006/main">
   <p:cSld name="Slide 13">
     <p:spTree>
@@ -5381,6 +5806,23 @@
               <a:t>Especificar primero, CLAUDE.md y ESLint protegen la arquitectura</a:t>
             </a:r>
           </a:p>
+          <a:p>
+            <a:pPr marL="228600" indent="-228600">
+              <a:spcAft>
+                <a:spcPts val="500"/>
+              </a:spcAft>
+              <a:buSzPct val="100000"/>
+              <a:buChar char="•"/>
+            </a:pPr>
+            <a:r>
+              <a:rPr sz="1300" b="0">
+                <a:solidFill>
+                  <a:schemeClr val="tx1"/>
+                </a:solidFill>
+              </a:rPr>
+              <a:t>Un diseño generado con IA se adopta mejor con un análisis de brechas antes de migrar</a:t>
+            </a:r>
+          </a:p>
         </p:txBody>
       </p:sp>
       <p:sp>
@@ -5597,7 +6039,7 @@
 </p:sld>
 </file>
 
-<file path=ppt/slides/slide14.xml><?xml version="1.0" encoding="utf-8"?>
+<file path=ppt/slides/slide15.xml><?xml version="1.0" encoding="utf-8"?>
 <p:sld xmlns:a="http://schemas.openxmlformats.org/drawingml/2006/main" xmlns:r="http://schemas.openxmlformats.org/officeDocument/2006/relationships" xmlns:p="http://schemas.openxmlformats.org/presentationml/2006/main">
   <p:cSld name="Slide 14">
     <p:spTree>
@@ -7196,7 +7638,7 @@
                   <a:schemeClr val="bg1"/>
                 </a:solidFill>
               </a:rPr>
-              <a:t>Marca por cooperativa (color)</a:t>
+              <a:t>Marca por cooperativa (color) y sistema de diseño</a:t>
             </a:r>
           </a:p>
         </p:txBody>
@@ -7610,7 +8052,7 @@
                   <a:schemeClr val="bg1"/>
                 </a:solidFill>
               </a:rPr>
-              <a:t>Paper (MD3)</a:t>
+              <a:t>Paper + diseño</a:t>
             </a:r>
           </a:p>
         </p:txBody>
@@ -9055,6 +9497,540 @@
 </file>
 
 <file path=ppt/slides/slide6.xml><?xml version="1.0" encoding="utf-8"?>
+<p:sld xmlns:a="http://schemas.openxmlformats.org/drawingml/2006/main" xmlns:p="http://schemas.openxmlformats.org/presentationml/2006/main" xmlns:r="http://schemas.openxmlformats.org/officeDocument/2006/relationships">
+  <p:cSld>
+    <p:spTree>
+      <p:nvGrpSpPr>
+        <p:cNvPr id="1" name=""/>
+        <p:cNvGrpSpPr/>
+        <p:nvPr/>
+      </p:nvGrpSpPr>
+      <p:grpSpPr/>
+      <p:sp>
+        <p:nvSpPr>
+          <p:cNvPr id="2" name="Slide Number Placeholder 0"/>
+          <p:cNvSpPr>
+            <a:spLocks noGrp="1"/>
+          </p:cNvSpPr>
+          <p:nvPr>
+            <p:ph type="sldNum" sz="quarter" idx="4294967295"/>
+          </p:nvPr>
+        </p:nvSpPr>
+        <p:spPr>
+          <a:xfrm>
+            <a:off x="8229600" y="4754880"/>
+            <a:ext cx="457200" cy="274320"/>
+          </a:xfrm>
+          <a:prstGeom prst="rect">
+            <a:avLst/>
+          </a:prstGeom>
+          <a:extLst>
+            <a:ext uri="{C572A759-6A51-4108-AA02-DFA0A04FC94B}">
+              <ma14:wrappingTextBoxFlag xmlns:ma14="http://schemas.microsoft.com/office/mac/drawingml/2011/main" val="0"/>
+            </a:ext>
+          </a:extLst>
+        </p:spPr>
+        <p:txBody>
+          <a:bodyPr/>
+          <a:lstStyle>
+            <a:lvl1pPr>
+              <a:defRPr sz="1000">
+                <a:solidFill>
+                  <a:schemeClr val="accent6"/>
+                </a:solidFill>
+              </a:defRPr>
+            </a:lvl1pPr>
+          </a:lstStyle>
+          <a:p>
+            <a:pPr algn="r"/>
+            <a:fld id="{F7021451-1387-4CA6-816F-3879F97B5CBC}" type="slidenum">
+              <a:rPr b="0" lang="en-US"/>
+              <a:t>8</a:t>
+            </a:fld>
+            <a:endParaRPr lang="en-US"/>
+          </a:p>
+        </p:txBody>
+      </p:sp>
+      <p:sp>
+        <p:nvSpPr>
+          <p:cNvPr id="3" name="Titulo"/>
+          <p:cNvSpPr txBox="1"/>
+          <p:nvPr/>
+        </p:nvSpPr>
+        <p:spPr>
+          <a:xfrm>
+            <a:off x="457200" y="274320"/>
+            <a:ext cx="8229600" cy="685800"/>
+          </a:xfrm>
+          <a:prstGeom prst="rect">
+            <a:avLst/>
+          </a:prstGeom>
+          <a:noFill/>
+        </p:spPr>
+        <p:txBody>
+          <a:bodyPr wrap="square" lIns="0" rIns="0" tIns="0" bIns="0" anchor="ctr">
+            <a:spAutoFit/>
+          </a:bodyPr>
+          <a:lstStyle/>
+          <a:p>
+            <a:r>
+              <a:rPr sz="2800" b="1">
+                <a:solidFill>
+                  <a:schemeClr val="tx2"/>
+                </a:solidFill>
+                <a:latin typeface="Cambria"/>
+              </a:rPr>
+              <a:t>Interfaz: del brief al sistema de diseño</a:t>
+            </a:r>
+          </a:p>
+        </p:txBody>
+      </p:sp>
+      <p:sp>
+        <p:nvSpPr>
+          <p:cNvPr id="4" name="Tarjeta"/>
+          <p:cNvSpPr/>
+          <p:nvPr/>
+        </p:nvSpPr>
+        <p:spPr>
+          <a:xfrm>
+            <a:off x="6126480" y="1143000"/>
+            <a:ext cx="2560320" cy="3474720"/>
+          </a:xfrm>
+          <a:prstGeom prst="roundRect">
+            <a:avLst>
+              <a:gd name="adj" fmla="val 4000"/>
+            </a:avLst>
+          </a:prstGeom>
+          <a:solidFill>
+            <a:schemeClr val="accent1"/>
+          </a:solidFill>
+          <a:ln w="12700">
+            <a:solidFill>
+              <a:schemeClr val="accent1"/>
+            </a:solidFill>
+          </a:ln>
+          <a:effectLst/>
+        </p:spPr>
+        <p:style>
+          <a:lnRef idx="1">
+            <a:schemeClr val="accent1"/>
+          </a:lnRef>
+          <a:fillRef idx="3">
+            <a:schemeClr val="accent1"/>
+          </a:fillRef>
+          <a:effectRef idx="2">
+            <a:schemeClr val="accent1"/>
+          </a:effectRef>
+          <a:fontRef idx="minor">
+            <a:schemeClr val="lt1"/>
+          </a:fontRef>
+        </p:style>
+        <p:txBody>
+          <a:bodyPr rtlCol="0" anchor="ctr"/>
+          <a:lstStyle/>
+          <a:p>
+            <a:pPr algn="ctr"/>
+          </a:p>
+        </p:txBody>
+      </p:sp>
+      <p:sp>
+        <p:nvSpPr>
+          <p:cNvPr id="5" name="TextBox 27"/>
+          <p:cNvSpPr txBox="1"/>
+          <p:nvPr/>
+        </p:nvSpPr>
+        <p:spPr>
+          <a:xfrm>
+            <a:off x="6309360" y="1234440"/>
+            <a:ext cx="2240280" cy="365760"/>
+          </a:xfrm>
+          <a:prstGeom prst="rect">
+            <a:avLst/>
+          </a:prstGeom>
+          <a:noFill/>
+        </p:spPr>
+        <p:txBody>
+          <a:bodyPr wrap="square" lIns="0" rIns="0" tIns="0" bIns="0" anchor="t">
+            <a:spAutoFit/>
+          </a:bodyPr>
+          <a:lstStyle/>
+          <a:p>
+            <a:r>
+              <a:rPr sz="1800" b="1">
+                <a:solidFill>
+                  <a:schemeClr val="bg1"/>
+                </a:solidFill>
+              </a:rPr>
+              <a:t>Del brief a la app</a:t>
+            </a:r>
+          </a:p>
+        </p:txBody>
+      </p:sp>
+      <p:sp>
+        <p:nvSpPr>
+          <p:cNvPr id="6" name="TextBox 28"/>
+          <p:cNvSpPr txBox="1"/>
+          <p:nvPr/>
+        </p:nvSpPr>
+        <p:spPr>
+          <a:xfrm>
+            <a:off x="6309360" y="1645920"/>
+            <a:ext cx="2240280" cy="2743200"/>
+          </a:xfrm>
+          <a:prstGeom prst="rect">
+            <a:avLst/>
+          </a:prstGeom>
+          <a:noFill/>
+        </p:spPr>
+        <p:txBody>
+          <a:bodyPr wrap="square" lIns="0" rIns="0" tIns="0" bIns="0">
+            <a:spAutoFit/>
+          </a:bodyPr>
+          <a:lstStyle/>
+          <a:p>
+            <a:pPr marL="228600" indent="-228600">
+              <a:spcAft>
+                <a:spcPts val="400"/>
+              </a:spcAft>
+              <a:buSzPct val="100000"/>
+              <a:buChar char="•"/>
+            </a:pPr>
+            <a:r>
+              <a:rPr sz="1100" b="0">
+                <a:solidFill>
+                  <a:schemeClr val="bg1"/>
+                </a:solidFill>
+              </a:rPr>
+              <a:t>Brief de interfaz (docs/05)</a:t>
+            </a:r>
+          </a:p>
+          <a:p>
+            <a:pPr marL="228600" indent="-228600">
+              <a:spcAft>
+                <a:spcPts val="400"/>
+              </a:spcAft>
+              <a:buSzPct val="100000"/>
+              <a:buChar char="•"/>
+            </a:pPr>
+            <a:r>
+              <a:rPr sz="1100" b="0">
+                <a:solidFill>
+                  <a:schemeClr val="bg1"/>
+                </a:solidFill>
+              </a:rPr>
+              <a:t>Herramienta de diseño con IA: tokens, 8 colores, unos 40 componentes</a:t>
+            </a:r>
+          </a:p>
+          <a:p>
+            <a:pPr marL="228600" indent="-228600">
+              <a:spcAft>
+                <a:spcPts val="400"/>
+              </a:spcAft>
+              <a:buSzPct val="100000"/>
+              <a:buChar char="•"/>
+            </a:pPr>
+            <a:r>
+              <a:rPr sz="1100" b="0">
+                <a:solidFill>
+                  <a:schemeClr val="bg1"/>
+                </a:solidFill>
+              </a:rPr>
+              <a:t>Análisis de brechas (docs/06)</a:t>
+            </a:r>
+          </a:p>
+          <a:p>
+            <a:pPr marL="228600" indent="-228600">
+              <a:spcAft>
+                <a:spcPts val="400"/>
+              </a:spcAft>
+              <a:buSzPct val="100000"/>
+              <a:buChar char="•"/>
+            </a:pPr>
+            <a:r>
+              <a:rPr sz="1100" b="0">
+                <a:solidFill>
+                  <a:schemeClr val="bg1"/>
+                </a:solidFill>
+              </a:rPr>
+              <a:t>Orquestador y 7 subagentes en paralelo, uno por módulo</a:t>
+            </a:r>
+          </a:p>
+          <a:p>
+            <a:pPr marL="228600" indent="-228600">
+              <a:spcAft>
+                <a:spcPts val="400"/>
+              </a:spcAft>
+              <a:buSzPct val="100000"/>
+              <a:buChar char="•"/>
+            </a:pPr>
+            <a:r>
+              <a:rPr sz="1100" b="0">
+                <a:solidFill>
+                  <a:schemeClr val="bg1"/>
+                </a:solidFill>
+              </a:rPr>
+              <a:t>Kit en src/ui; las pantallas no usan Paper directamente</a:t>
+            </a:r>
+          </a:p>
+        </p:txBody>
+      </p:sp>
+      <p:pic>
+        <p:nvPicPr>
+          <p:cNvPr id="7" name="Picture 6" descr="lucia-selector.png"/>
+          <p:cNvPicPr>
+            <a:picLocks noChangeAspect="1"/>
+          </p:cNvPicPr>
+          <p:nvPr/>
+        </p:nvPicPr>
+        <p:blipFill>
+          <a:blip r:embed="rId2"/>
+          <a:stretch>
+            <a:fillRect/>
+          </a:stretch>
+        </p:blipFill>
+        <p:spPr>
+          <a:xfrm>
+            <a:off x="457200" y="1143000"/>
+            <a:ext cx="1280160" cy="2770397"/>
+          </a:xfrm>
+          <a:prstGeom prst="rect">
+            <a:avLst/>
+          </a:prstGeom>
+          <a:ln w="9525">
+            <a:solidFill>
+              <a:srgbClr val="C8D2CC"/>
+            </a:solidFill>
+          </a:ln>
+        </p:spPr>
+      </p:pic>
+      <p:sp>
+        <p:nvSpPr>
+          <p:cNvPr id="20" name="TextBox 28"/>
+          <p:cNvSpPr txBox="1"/>
+          <p:nvPr/>
+        </p:nvSpPr>
+        <p:spPr>
+          <a:xfrm>
+            <a:off x="457200" y="3959117"/>
+            <a:ext cx="1280160" cy="320040"/>
+          </a:xfrm>
+          <a:prstGeom prst="rect">
+            <a:avLst/>
+          </a:prstGeom>
+          <a:noFill/>
+        </p:spPr>
+        <p:txBody>
+          <a:bodyPr wrap="square" lIns="0" rIns="0" tIns="0" bIns="0" anchor="t">
+            <a:spAutoFit/>
+          </a:bodyPr>
+          <a:lstStyle/>
+          <a:p>
+            <a:r>
+              <a:rPr sz="800" b="0">
+                <a:solidFill>
+                  <a:schemeClr val="tx1"/>
+                </a:solidFill>
+              </a:rPr>
+              <a:t>Selector: color de cada cooperativa</a:t>
+            </a:r>
+          </a:p>
+        </p:txBody>
+      </p:sp>
+      <p:pic>
+        <p:nvPicPr>
+          <p:cNvPr id="21" name="Picture 20" descr="socio-home.png"/>
+          <p:cNvPicPr>
+            <a:picLocks noChangeAspect="1"/>
+          </p:cNvPicPr>
+          <p:nvPr/>
+        </p:nvPicPr>
+        <p:blipFill>
+          <a:blip r:embed="rId3"/>
+          <a:stretch>
+            <a:fillRect/>
+          </a:stretch>
+        </p:blipFill>
+        <p:spPr>
+          <a:xfrm>
+            <a:off x="1851660" y="1143000"/>
+            <a:ext cx="1280160" cy="2770397"/>
+          </a:xfrm>
+          <a:prstGeom prst="rect">
+            <a:avLst/>
+          </a:prstGeom>
+          <a:ln w="9525">
+            <a:solidFill>
+              <a:srgbClr val="C8D2CC"/>
+            </a:solidFill>
+          </a:ln>
+        </p:spPr>
+      </p:pic>
+      <p:sp>
+        <p:nvSpPr>
+          <p:cNvPr id="21" name="TextBox 28"/>
+          <p:cNvSpPr txBox="1"/>
+          <p:nvPr/>
+        </p:nvSpPr>
+        <p:spPr>
+          <a:xfrm>
+            <a:off x="1851660" y="3959117"/>
+            <a:ext cx="1280160" cy="320040"/>
+          </a:xfrm>
+          <a:prstGeom prst="rect">
+            <a:avLst/>
+          </a:prstGeom>
+          <a:noFill/>
+        </p:spPr>
+        <p:txBody>
+          <a:bodyPr wrap="square" lIns="0" rIns="0" tIns="0" bIns="0" anchor="t">
+            <a:spAutoFit/>
+          </a:bodyPr>
+          <a:lstStyle/>
+          <a:p>
+            <a:r>
+              <a:rPr sz="800" b="0">
+                <a:solidFill>
+                  <a:schemeClr val="tx1"/>
+                </a:solidFill>
+              </a:rPr>
+              <a:t>Inicio: "Pendiente para ti"</a:t>
+            </a:r>
+          </a:p>
+        </p:txBody>
+      </p:sp>
+      <p:pic>
+        <p:nvPicPr>
+          <p:cNvPr id="22" name="Picture 21" descr="asm1.png"/>
+          <p:cNvPicPr>
+            <a:picLocks noChangeAspect="1"/>
+          </p:cNvPicPr>
+          <p:nvPr/>
+        </p:nvPicPr>
+        <p:blipFill>
+          <a:blip r:embed="rId4"/>
+          <a:stretch>
+            <a:fillRect/>
+          </a:stretch>
+        </p:blipFill>
+        <p:spPr>
+          <a:xfrm>
+            <a:off x="3246120" y="1143000"/>
+            <a:ext cx="1280160" cy="2770397"/>
+          </a:xfrm>
+          <a:prstGeom prst="rect">
+            <a:avLst/>
+          </a:prstGeom>
+          <a:ln w="9525">
+            <a:solidFill>
+              <a:srgbClr val="C8D2CC"/>
+            </a:solidFill>
+          </a:ln>
+        </p:spPr>
+      </p:pic>
+      <p:sp>
+        <p:nvSpPr>
+          <p:cNvPr id="22" name="TextBox 28"/>
+          <p:cNvSpPr txBox="1"/>
+          <p:nvPr/>
+        </p:nvSpPr>
+        <p:spPr>
+          <a:xfrm>
+            <a:off x="3246120" y="3959117"/>
+            <a:ext cx="1280160" cy="320040"/>
+          </a:xfrm>
+          <a:prstGeom prst="rect">
+            <a:avLst/>
+          </a:prstGeom>
+          <a:noFill/>
+        </p:spPr>
+        <p:txBody>
+          <a:bodyPr wrap="square" lIns="0" rIns="0" tIns="0" bIns="0" anchor="t">
+            <a:spAutoFit/>
+          </a:bodyPr>
+          <a:lstStyle/>
+          <a:p>
+            <a:r>
+              <a:rPr sz="800" b="0">
+                <a:solidFill>
+                  <a:schemeClr val="tx1"/>
+                </a:solidFill>
+              </a:rPr>
+              <a:t>Asamblea: mapa y quórum</a:t>
+            </a:r>
+          </a:p>
+        </p:txBody>
+      </p:sp>
+      <p:pic>
+        <p:nvPicPr>
+          <p:cNvPr id="23" name="Picture 22" descr="invoices.png"/>
+          <p:cNvPicPr>
+            <a:picLocks noChangeAspect="1"/>
+          </p:cNvPicPr>
+          <p:nvPr/>
+        </p:nvPicPr>
+        <p:blipFill>
+          <a:blip r:embed="rId5"/>
+          <a:stretch>
+            <a:fillRect/>
+          </a:stretch>
+        </p:blipFill>
+        <p:spPr>
+          <a:xfrm>
+            <a:off x="4640580" y="1143000"/>
+            <a:ext cx="1280160" cy="2770397"/>
+          </a:xfrm>
+          <a:prstGeom prst="rect">
+            <a:avLst/>
+          </a:prstGeom>
+          <a:ln w="9525">
+            <a:solidFill>
+              <a:srgbClr val="C8D2CC"/>
+            </a:solidFill>
+          </a:ln>
+        </p:spPr>
+      </p:pic>
+      <p:sp>
+        <p:nvSpPr>
+          <p:cNvPr id="23" name="TextBox 28"/>
+          <p:cNvSpPr txBox="1"/>
+          <p:nvPr/>
+        </p:nvSpPr>
+        <p:spPr>
+          <a:xfrm>
+            <a:off x="4640580" y="3959117"/>
+            <a:ext cx="1280160" cy="320040"/>
+          </a:xfrm>
+          <a:prstGeom prst="rect">
+            <a:avLst/>
+          </a:prstGeom>
+          <a:noFill/>
+        </p:spPr>
+        <p:txBody>
+          <a:bodyPr wrap="square" lIns="0" rIns="0" tIns="0" bIns="0" anchor="t">
+            <a:spAutoFit/>
+          </a:bodyPr>
+          <a:lstStyle/>
+          <a:p>
+            <a:r>
+              <a:rPr sz="800" b="0">
+                <a:solidFill>
+                  <a:schemeClr val="tx1"/>
+                </a:solidFill>
+              </a:rPr>
+              <a:t>Facturas y albaranes</a:t>
+            </a:r>
+          </a:p>
+        </p:txBody>
+      </p:sp>
+    </p:spTree>
+  </p:cSld>
+  <p:clrMapOvr>
+    <a:masterClrMapping/>
+  </p:clrMapOvr>
+</p:sld>
+</file>
+
+<file path=ppt/slides/slide7.xml><?xml version="1.0" encoding="utf-8"?>
 <p:sld xmlns:a="http://schemas.openxmlformats.org/drawingml/2006/main" xmlns:r="http://schemas.openxmlformats.org/officeDocument/2006/relationships" xmlns:p="http://schemas.openxmlformats.org/presentationml/2006/main">
   <p:cSld name="Slide 6">
     <p:spTree>
@@ -9145,7 +10121,7 @@
                 </a:solidFill>
                 <a:latin typeface="Cambria"/>
               </a:rPr>
-              <a:t>Decisiones clave: 21 ADR</a:t>
+              <a:t>Decisiones clave: 24 ADR</a:t>
             </a:r>
           </a:p>
         </p:txBody>
@@ -9273,7 +10249,7 @@
         </p:nvSpPr>
         <p:spPr>
           <a:xfrm>
-            <a:off x="457200" y="1394460"/>
+            <a:off x="457200" y="1356360"/>
             <a:ext cx="548640" cy="283464"/>
           </a:xfrm>
           <a:prstGeom prst="roundRect">
@@ -9321,7 +10297,7 @@
         </p:nvSpPr>
         <p:spPr>
           <a:xfrm>
-            <a:off x="457200" y="1394460"/>
+            <a:off x="457200" y="1356360"/>
             <a:ext cx="548640" cy="283464"/>
           </a:xfrm>
           <a:prstGeom prst="rect">
@@ -9355,7 +10331,7 @@
         </p:nvSpPr>
         <p:spPr>
           <a:xfrm>
-            <a:off x="1115568" y="1394460"/>
+            <a:off x="1115568" y="1356360"/>
             <a:ext cx="3383280" cy="283464"/>
           </a:xfrm>
           <a:prstGeom prst="rect">
@@ -9388,7 +10364,7 @@
         </p:nvSpPr>
         <p:spPr>
           <a:xfrm>
-            <a:off x="457200" y="1737360"/>
+            <a:off x="457200" y="1661160"/>
             <a:ext cx="548640" cy="283464"/>
           </a:xfrm>
           <a:prstGeom prst="roundRect">
@@ -9436,7 +10412,7 @@
         </p:nvSpPr>
         <p:spPr>
           <a:xfrm>
-            <a:off x="457200" y="1737360"/>
+            <a:off x="457200" y="1661160"/>
             <a:ext cx="548640" cy="283464"/>
           </a:xfrm>
           <a:prstGeom prst="rect">
@@ -9470,7 +10446,7 @@
         </p:nvSpPr>
         <p:spPr>
           <a:xfrm>
-            <a:off x="1115568" y="1737360"/>
+            <a:off x="1115568" y="1661160"/>
             <a:ext cx="3383280" cy="283464"/>
           </a:xfrm>
           <a:prstGeom prst="rect">
@@ -9503,7 +10479,7 @@
         </p:nvSpPr>
         <p:spPr>
           <a:xfrm>
-            <a:off x="457200" y="2080260"/>
+            <a:off x="457200" y="1965960"/>
             <a:ext cx="548640" cy="283464"/>
           </a:xfrm>
           <a:prstGeom prst="roundRect">
@@ -9551,7 +10527,7 @@
         </p:nvSpPr>
         <p:spPr>
           <a:xfrm>
-            <a:off x="457200" y="2080260"/>
+            <a:off x="457200" y="1965960"/>
             <a:ext cx="548640" cy="283464"/>
           </a:xfrm>
           <a:prstGeom prst="rect">
@@ -9585,7 +10561,7 @@
         </p:nvSpPr>
         <p:spPr>
           <a:xfrm>
-            <a:off x="1115568" y="2080260"/>
+            <a:off x="1115568" y="1965960"/>
             <a:ext cx="3383280" cy="283464"/>
           </a:xfrm>
           <a:prstGeom prst="rect">
@@ -9618,7 +10594,7 @@
         </p:nvSpPr>
         <p:spPr>
           <a:xfrm>
-            <a:off x="457200" y="2423160"/>
+            <a:off x="457200" y="2270760"/>
             <a:ext cx="548640" cy="283464"/>
           </a:xfrm>
           <a:prstGeom prst="roundRect">
@@ -9666,7 +10642,7 @@
         </p:nvSpPr>
         <p:spPr>
           <a:xfrm>
-            <a:off x="457200" y="2423160"/>
+            <a:off x="457200" y="2270760"/>
             <a:ext cx="548640" cy="283464"/>
           </a:xfrm>
           <a:prstGeom prst="rect">
@@ -9700,7 +10676,7 @@
         </p:nvSpPr>
         <p:spPr>
           <a:xfrm>
-            <a:off x="1115568" y="2423160"/>
+            <a:off x="1115568" y="2270760"/>
             <a:ext cx="3383280" cy="283464"/>
           </a:xfrm>
           <a:prstGeom prst="rect">
@@ -9733,7 +10709,7 @@
         </p:nvSpPr>
         <p:spPr>
           <a:xfrm>
-            <a:off x="457200" y="2766060"/>
+            <a:off x="457200" y="2575560"/>
             <a:ext cx="548640" cy="283464"/>
           </a:xfrm>
           <a:prstGeom prst="roundRect">
@@ -9781,7 +10757,7 @@
         </p:nvSpPr>
         <p:spPr>
           <a:xfrm>
-            <a:off x="457200" y="2766060"/>
+            <a:off x="457200" y="2575560"/>
             <a:ext cx="548640" cy="283464"/>
           </a:xfrm>
           <a:prstGeom prst="rect">
@@ -9815,7 +10791,7 @@
         </p:nvSpPr>
         <p:spPr>
           <a:xfrm>
-            <a:off x="1115568" y="2766060"/>
+            <a:off x="1115568" y="2575560"/>
             <a:ext cx="3383280" cy="283464"/>
           </a:xfrm>
           <a:prstGeom prst="rect">
@@ -9848,7 +10824,7 @@
         </p:nvSpPr>
         <p:spPr>
           <a:xfrm>
-            <a:off x="457200" y="3108960"/>
+            <a:off x="457200" y="2880360"/>
             <a:ext cx="548640" cy="283464"/>
           </a:xfrm>
           <a:prstGeom prst="roundRect">
@@ -9896,7 +10872,7 @@
         </p:nvSpPr>
         <p:spPr>
           <a:xfrm>
-            <a:off x="457200" y="3108960"/>
+            <a:off x="457200" y="2880360"/>
             <a:ext cx="548640" cy="283464"/>
           </a:xfrm>
           <a:prstGeom prst="rect">
@@ -9930,7 +10906,7 @@
         </p:nvSpPr>
         <p:spPr>
           <a:xfrm>
-            <a:off x="1115568" y="3108960"/>
+            <a:off x="1115568" y="2880360"/>
             <a:ext cx="3383280" cy="283464"/>
           </a:xfrm>
           <a:prstGeom prst="rect">
@@ -9963,7 +10939,7 @@
         </p:nvSpPr>
         <p:spPr>
           <a:xfrm>
-            <a:off x="457200" y="3451860"/>
+            <a:off x="457200" y="3185160"/>
             <a:ext cx="548640" cy="283464"/>
           </a:xfrm>
           <a:prstGeom prst="roundRect">
@@ -10011,7 +10987,7 @@
         </p:nvSpPr>
         <p:spPr>
           <a:xfrm>
-            <a:off x="457200" y="3451860"/>
+            <a:off x="457200" y="3185160"/>
             <a:ext cx="548640" cy="283464"/>
           </a:xfrm>
           <a:prstGeom prst="rect">
@@ -10045,7 +11021,7 @@
         </p:nvSpPr>
         <p:spPr>
           <a:xfrm>
-            <a:off x="1115568" y="3451860"/>
+            <a:off x="1115568" y="3185160"/>
             <a:ext cx="3383280" cy="283464"/>
           </a:xfrm>
           <a:prstGeom prst="rect">
@@ -10078,7 +11054,7 @@
         </p:nvSpPr>
         <p:spPr>
           <a:xfrm>
-            <a:off x="457200" y="3794760"/>
+            <a:off x="457200" y="3489960"/>
             <a:ext cx="548640" cy="283464"/>
           </a:xfrm>
           <a:prstGeom prst="roundRect">
@@ -10126,7 +11102,7 @@
         </p:nvSpPr>
         <p:spPr>
           <a:xfrm>
-            <a:off x="457200" y="3794760"/>
+            <a:off x="457200" y="3489960"/>
             <a:ext cx="548640" cy="283464"/>
           </a:xfrm>
           <a:prstGeom prst="rect">
@@ -10160,7 +11136,7 @@
         </p:nvSpPr>
         <p:spPr>
           <a:xfrm>
-            <a:off x="1115568" y="3794760"/>
+            <a:off x="1115568" y="3489960"/>
             <a:ext cx="3383280" cy="283464"/>
           </a:xfrm>
           <a:prstGeom prst="rect">
@@ -10193,7 +11169,7 @@
         </p:nvSpPr>
         <p:spPr>
           <a:xfrm>
-            <a:off x="457200" y="4137660"/>
+            <a:off x="457200" y="3794760"/>
             <a:ext cx="548640" cy="283464"/>
           </a:xfrm>
           <a:prstGeom prst="roundRect">
@@ -10241,7 +11217,7 @@
         </p:nvSpPr>
         <p:spPr>
           <a:xfrm>
-            <a:off x="457200" y="4137660"/>
+            <a:off x="457200" y="3794760"/>
             <a:ext cx="548640" cy="283464"/>
           </a:xfrm>
           <a:prstGeom prst="rect">
@@ -10275,7 +11251,7 @@
         </p:nvSpPr>
         <p:spPr>
           <a:xfrm>
-            <a:off x="1115568" y="4137660"/>
+            <a:off x="1115568" y="3794760"/>
             <a:ext cx="3383280" cy="283464"/>
           </a:xfrm>
           <a:prstGeom prst="rect">
@@ -10308,7 +11284,7 @@
         </p:nvSpPr>
         <p:spPr>
           <a:xfrm>
-            <a:off x="4663440" y="1051560"/>
+            <a:off x="457200" y="4099560"/>
             <a:ext cx="548640" cy="283464"/>
           </a:xfrm>
           <a:prstGeom prst="roundRect">
@@ -10356,7 +11332,7 @@
         </p:nvSpPr>
         <p:spPr>
           <a:xfrm>
-            <a:off x="4663440" y="1051560"/>
+            <a:off x="457200" y="4099560"/>
             <a:ext cx="548640" cy="283464"/>
           </a:xfrm>
           <a:prstGeom prst="rect">
@@ -10390,7 +11366,7 @@
         </p:nvSpPr>
         <p:spPr>
           <a:xfrm>
-            <a:off x="5321807" y="1051560"/>
+            <a:off x="1115568" y="4099560"/>
             <a:ext cx="3383280" cy="283464"/>
           </a:xfrm>
           <a:prstGeom prst="rect">
@@ -10423,7 +11399,7 @@
         </p:nvSpPr>
         <p:spPr>
           <a:xfrm>
-            <a:off x="4663440" y="1394460"/>
+            <a:off x="457200" y="4404360"/>
             <a:ext cx="548640" cy="283464"/>
           </a:xfrm>
           <a:prstGeom prst="roundRect">
@@ -10471,7 +11447,7 @@
         </p:nvSpPr>
         <p:spPr>
           <a:xfrm>
-            <a:off x="4663440" y="1394460"/>
+            <a:off x="457200" y="4404360"/>
             <a:ext cx="548640" cy="283464"/>
           </a:xfrm>
           <a:prstGeom prst="rect">
@@ -10505,7 +11481,7 @@
         </p:nvSpPr>
         <p:spPr>
           <a:xfrm>
-            <a:off x="5321807" y="1394460"/>
+            <a:off x="1115568" y="4404360"/>
             <a:ext cx="3383280" cy="283464"/>
           </a:xfrm>
           <a:prstGeom prst="rect">
@@ -10538,7 +11514,7 @@
         </p:nvSpPr>
         <p:spPr>
           <a:xfrm>
-            <a:off x="4663440" y="1737360"/>
+            <a:off x="4663440" y="1051560"/>
             <a:ext cx="548640" cy="283464"/>
           </a:xfrm>
           <a:prstGeom prst="roundRect">
@@ -10586,7 +11562,7 @@
         </p:nvSpPr>
         <p:spPr>
           <a:xfrm>
-            <a:off x="4663440" y="1737360"/>
+            <a:off x="4663440" y="1051560"/>
             <a:ext cx="548640" cy="283464"/>
           </a:xfrm>
           <a:prstGeom prst="rect">
@@ -10620,8 +11596,8 @@
         </p:nvSpPr>
         <p:spPr>
           <a:xfrm>
-            <a:off x="5321807" y="1737360"/>
-            <a:ext cx="3383280" cy="283464"/>
+            <a:off x="5321807" y="1051560"/>
+            <a:ext cx="3566160" cy="283464"/>
           </a:xfrm>
           <a:prstGeom prst="rect">
             <a:avLst/>
@@ -10653,7 +11629,7 @@
         </p:nvSpPr>
         <p:spPr>
           <a:xfrm>
-            <a:off x="4663440" y="2080260"/>
+            <a:off x="4663440" y="1356360"/>
             <a:ext cx="548640" cy="283464"/>
           </a:xfrm>
           <a:prstGeom prst="roundRect">
@@ -10701,7 +11677,7 @@
         </p:nvSpPr>
         <p:spPr>
           <a:xfrm>
-            <a:off x="4663440" y="2080260"/>
+            <a:off x="4663440" y="1356360"/>
             <a:ext cx="548640" cy="283464"/>
           </a:xfrm>
           <a:prstGeom prst="rect">
@@ -10735,8 +11711,8 @@
         </p:nvSpPr>
         <p:spPr>
           <a:xfrm>
-            <a:off x="5321807" y="2080260"/>
-            <a:ext cx="3383280" cy="283464"/>
+            <a:off x="5321807" y="1356360"/>
+            <a:ext cx="3566160" cy="283464"/>
           </a:xfrm>
           <a:prstGeom prst="rect">
             <a:avLst/>
@@ -10768,7 +11744,7 @@
         </p:nvSpPr>
         <p:spPr>
           <a:xfrm>
-            <a:off x="4663440" y="2423160"/>
+            <a:off x="4663440" y="1661160"/>
             <a:ext cx="548640" cy="283464"/>
           </a:xfrm>
           <a:prstGeom prst="roundRect">
@@ -10816,7 +11792,7 @@
         </p:nvSpPr>
         <p:spPr>
           <a:xfrm>
-            <a:off x="4663440" y="2423160"/>
+            <a:off x="4663440" y="1661160"/>
             <a:ext cx="548640" cy="283464"/>
           </a:xfrm>
           <a:prstGeom prst="rect">
@@ -10850,8 +11826,8 @@
         </p:nvSpPr>
         <p:spPr>
           <a:xfrm>
-            <a:off x="5321807" y="2423160"/>
-            <a:ext cx="3383280" cy="283464"/>
+            <a:off x="5321807" y="1661160"/>
+            <a:ext cx="3566160" cy="283464"/>
           </a:xfrm>
           <a:prstGeom prst="rect">
             <a:avLst/>
@@ -10883,7 +11859,7 @@
         </p:nvSpPr>
         <p:spPr>
           <a:xfrm>
-            <a:off x="4663440" y="2766060"/>
+            <a:off x="4663440" y="1965960"/>
             <a:ext cx="548640" cy="283464"/>
           </a:xfrm>
           <a:prstGeom prst="roundRect">
@@ -10931,7 +11907,7 @@
         </p:nvSpPr>
         <p:spPr>
           <a:xfrm>
-            <a:off x="4663440" y="2766060"/>
+            <a:off x="4663440" y="1965960"/>
             <a:ext cx="548640" cy="283464"/>
           </a:xfrm>
           <a:prstGeom prst="rect">
@@ -10965,8 +11941,8 @@
         </p:nvSpPr>
         <p:spPr>
           <a:xfrm>
-            <a:off x="5321807" y="2766060"/>
-            <a:ext cx="3383280" cy="283464"/>
+            <a:off x="5321807" y="1965960"/>
+            <a:ext cx="3566160" cy="283464"/>
           </a:xfrm>
           <a:prstGeom prst="rect">
             <a:avLst/>
@@ -10998,7 +11974,7 @@
         </p:nvSpPr>
         <p:spPr>
           <a:xfrm>
-            <a:off x="4663440" y="3108960"/>
+            <a:off x="4663440" y="2270760"/>
             <a:ext cx="548640" cy="283464"/>
           </a:xfrm>
           <a:prstGeom prst="roundRect">
@@ -11046,7 +12022,7 @@
         </p:nvSpPr>
         <p:spPr>
           <a:xfrm>
-            <a:off x="4663440" y="3108960"/>
+            <a:off x="4663440" y="2270760"/>
             <a:ext cx="548640" cy="283464"/>
           </a:xfrm>
           <a:prstGeom prst="rect">
@@ -11080,8 +12056,8 @@
         </p:nvSpPr>
         <p:spPr>
           <a:xfrm>
-            <a:off x="5321807" y="3108960"/>
-            <a:ext cx="3383280" cy="283464"/>
+            <a:off x="5321807" y="2270760"/>
+            <a:ext cx="3566160" cy="283464"/>
           </a:xfrm>
           <a:prstGeom prst="rect">
             <a:avLst/>
@@ -11113,7 +12089,7 @@
         </p:nvSpPr>
         <p:spPr>
           <a:xfrm>
-            <a:off x="4663440" y="3451860"/>
+            <a:off x="4663440" y="2575560"/>
             <a:ext cx="548640" cy="283464"/>
           </a:xfrm>
           <a:prstGeom prst="roundRect">
@@ -11161,7 +12137,7 @@
         </p:nvSpPr>
         <p:spPr>
           <a:xfrm>
-            <a:off x="4663440" y="3451860"/>
+            <a:off x="4663440" y="2575560"/>
             <a:ext cx="548640" cy="283464"/>
           </a:xfrm>
           <a:prstGeom prst="rect">
@@ -11195,8 +12171,8 @@
         </p:nvSpPr>
         <p:spPr>
           <a:xfrm>
-            <a:off x="5321807" y="3451860"/>
-            <a:ext cx="3383280" cy="283464"/>
+            <a:off x="5321807" y="2575560"/>
+            <a:ext cx="3566160" cy="283464"/>
           </a:xfrm>
           <a:prstGeom prst="rect">
             <a:avLst/>
@@ -11228,7 +12204,7 @@
         </p:nvSpPr>
         <p:spPr>
           <a:xfrm>
-            <a:off x="4663440" y="3794760"/>
+            <a:off x="4663440" y="2880360"/>
             <a:ext cx="548640" cy="283464"/>
           </a:xfrm>
           <a:prstGeom prst="roundRect">
@@ -11276,7 +12252,7 @@
         </p:nvSpPr>
         <p:spPr>
           <a:xfrm>
-            <a:off x="4663440" y="3794760"/>
+            <a:off x="4663440" y="2880360"/>
             <a:ext cx="548640" cy="283464"/>
           </a:xfrm>
           <a:prstGeom prst="rect">
@@ -11310,8 +12286,8 @@
         </p:nvSpPr>
         <p:spPr>
           <a:xfrm>
-            <a:off x="5321807" y="3794760"/>
-            <a:ext cx="3383280" cy="283464"/>
+            <a:off x="5321807" y="2880360"/>
+            <a:ext cx="3566160" cy="283464"/>
           </a:xfrm>
           <a:prstGeom prst="rect">
             <a:avLst/>
@@ -11343,7 +12319,7 @@
         </p:nvSpPr>
         <p:spPr>
           <a:xfrm>
-            <a:off x="4663440" y="4137660"/>
+            <a:off x="4663440" y="3185160"/>
             <a:ext cx="548640" cy="283464"/>
           </a:xfrm>
           <a:prstGeom prst="roundRect">
@@ -11391,7 +12367,7 @@
         </p:nvSpPr>
         <p:spPr>
           <a:xfrm>
-            <a:off x="4663440" y="4137660"/>
+            <a:off x="4663440" y="3185160"/>
             <a:ext cx="548640" cy="283464"/>
           </a:xfrm>
           <a:prstGeom prst="rect">
@@ -11425,8 +12401,8 @@
         </p:nvSpPr>
         <p:spPr>
           <a:xfrm>
-            <a:off x="5321807" y="4137660"/>
-            <a:ext cx="3383280" cy="283464"/>
+            <a:off x="5321807" y="3185160"/>
+            <a:ext cx="3566160" cy="283464"/>
           </a:xfrm>
           <a:prstGeom prst="rect">
             <a:avLst/>
@@ -11458,7 +12434,7 @@
         </p:nvSpPr>
         <p:spPr>
           <a:xfrm>
-            <a:off x="4663440" y="4480560"/>
+            <a:off x="4663440" y="3489960"/>
             <a:ext cx="548640" cy="283464"/>
           </a:xfrm>
           <a:prstGeom prst="roundRect">
@@ -11506,7 +12482,7 @@
         </p:nvSpPr>
         <p:spPr>
           <a:xfrm>
-            <a:off x="4663440" y="4480560"/>
+            <a:off x="4663440" y="3489960"/>
             <a:ext cx="548640" cy="283464"/>
           </a:xfrm>
           <a:prstGeom prst="rect">
@@ -11540,8 +12516,8 @@
         </p:nvSpPr>
         <p:spPr>
           <a:xfrm>
-            <a:off x="5321807" y="4480560"/>
-            <a:ext cx="3383280" cy="283464"/>
+            <a:off x="5321807" y="3489960"/>
+            <a:ext cx="3566160" cy="283464"/>
           </a:xfrm>
           <a:prstGeom prst="rect">
             <a:avLst/>
@@ -11561,6 +12537,351 @@
                 </a:solidFill>
               </a:rPr>
               <a:t>Sin logo por cooperativa (el color se mantiene)</a:t>
+            </a:r>
+          </a:p>
+        </p:txBody>
+      </p:sp>
+      <p:sp>
+        <p:nvSpPr>
+          <p:cNvPr id="90" name="Etiqueta"/>
+          <p:cNvSpPr/>
+          <p:nvPr/>
+        </p:nvSpPr>
+        <p:spPr>
+          <a:xfrm>
+            <a:off x="4663440" y="3794760"/>
+            <a:ext cx="548640" cy="283464"/>
+          </a:xfrm>
+          <a:prstGeom prst="roundRect">
+            <a:avLst>
+              <a:gd name="adj" fmla="val 17000"/>
+            </a:avLst>
+          </a:prstGeom>
+          <a:solidFill>
+            <a:schemeClr val="accent1"/>
+          </a:solidFill>
+          <a:ln w="12700">
+            <a:solidFill>
+              <a:schemeClr val="accent1"/>
+            </a:solidFill>
+          </a:ln>
+          <a:effectLst/>
+        </p:spPr>
+        <p:style>
+          <a:lnRef idx="1">
+            <a:schemeClr val="accent1"/>
+          </a:lnRef>
+          <a:fillRef idx="3">
+            <a:schemeClr val="accent1"/>
+          </a:fillRef>
+          <a:effectRef idx="2">
+            <a:schemeClr val="accent1"/>
+          </a:effectRef>
+          <a:fontRef idx="minor">
+            <a:schemeClr val="lt1"/>
+          </a:fontRef>
+        </p:style>
+        <p:txBody>
+          <a:bodyPr rtlCol="0" anchor="ctr"/>
+          <a:lstStyle/>
+          <a:p>
+            <a:pPr algn="ctr"/>
+          </a:p>
+        </p:txBody>
+      </p:sp>
+      <p:sp>
+        <p:nvSpPr>
+          <p:cNvPr id="91" name="TextBox 81"/>
+          <p:cNvSpPr txBox="1"/>
+          <p:nvPr/>
+        </p:nvSpPr>
+        <p:spPr>
+          <a:xfrm>
+            <a:off x="4663440" y="3794760"/>
+            <a:ext cx="548640" cy="283464"/>
+          </a:xfrm>
+          <a:prstGeom prst="rect">
+            <a:avLst/>
+          </a:prstGeom>
+          <a:noFill/>
+        </p:spPr>
+        <p:txBody>
+          <a:bodyPr wrap="square" lIns="0" rIns="0" tIns="0" bIns="0" anchor="ctr">
+            <a:spAutoFit/>
+          </a:bodyPr>
+          <a:lstStyle/>
+          <a:p>
+            <a:pPr algn="ctr"/>
+            <a:r>
+              <a:rPr sz="1200" b="1">
+                <a:solidFill>
+                  <a:schemeClr val="bg1"/>
+                </a:solidFill>
+              </a:rPr>
+              <a:t>022</a:t>
+            </a:r>
+          </a:p>
+        </p:txBody>
+      </p:sp>
+      <p:sp>
+        <p:nvSpPr>
+          <p:cNvPr id="92" name="TextBox 82"/>
+          <p:cNvSpPr txBox="1"/>
+          <p:nvPr/>
+        </p:nvSpPr>
+        <p:spPr>
+          <a:xfrm>
+            <a:off x="5321807" y="3794760"/>
+            <a:ext cx="3566160" cy="283464"/>
+          </a:xfrm>
+          <a:prstGeom prst="rect">
+            <a:avLst/>
+          </a:prstGeom>
+          <a:noFill/>
+        </p:spPr>
+        <p:txBody>
+          <a:bodyPr wrap="square" lIns="0" rIns="0" tIns="0" bIns="0" anchor="ctr">
+            <a:spAutoFit/>
+          </a:bodyPr>
+          <a:lstStyle/>
+          <a:p>
+            <a:r>
+              <a:rPr sz="1300" b="0">
+                <a:solidFill>
+                  <a:schemeClr val="tx1"/>
+                </a:solidFill>
+              </a:rPr>
+              <a:t>Búsqueda híbrida y umbral de similitud</a:t>
+            </a:r>
+          </a:p>
+        </p:txBody>
+      </p:sp>
+      <p:sp>
+        <p:nvSpPr>
+          <p:cNvPr id="93" name="Etiqueta"/>
+          <p:cNvSpPr/>
+          <p:nvPr/>
+        </p:nvSpPr>
+        <p:spPr>
+          <a:xfrm>
+            <a:off x="4663440" y="4099560"/>
+            <a:ext cx="548640" cy="283464"/>
+          </a:xfrm>
+          <a:prstGeom prst="roundRect">
+            <a:avLst>
+              <a:gd name="adj" fmla="val 17000"/>
+            </a:avLst>
+          </a:prstGeom>
+          <a:solidFill>
+            <a:schemeClr val="accent1"/>
+          </a:solidFill>
+          <a:ln w="12700">
+            <a:solidFill>
+              <a:schemeClr val="accent1"/>
+            </a:solidFill>
+          </a:ln>
+          <a:effectLst/>
+        </p:spPr>
+        <p:style>
+          <a:lnRef idx="1">
+            <a:schemeClr val="accent1"/>
+          </a:lnRef>
+          <a:fillRef idx="3">
+            <a:schemeClr val="accent1"/>
+          </a:fillRef>
+          <a:effectRef idx="2">
+            <a:schemeClr val="accent1"/>
+          </a:effectRef>
+          <a:fontRef idx="minor">
+            <a:schemeClr val="lt1"/>
+          </a:fontRef>
+        </p:style>
+        <p:txBody>
+          <a:bodyPr rtlCol="0" anchor="ctr"/>
+          <a:lstStyle/>
+          <a:p>
+            <a:pPr algn="ctr"/>
+          </a:p>
+        </p:txBody>
+      </p:sp>
+      <p:sp>
+        <p:nvSpPr>
+          <p:cNvPr id="94" name="TextBox 81"/>
+          <p:cNvSpPr txBox="1"/>
+          <p:nvPr/>
+        </p:nvSpPr>
+        <p:spPr>
+          <a:xfrm>
+            <a:off x="4663440" y="4099560"/>
+            <a:ext cx="548640" cy="283464"/>
+          </a:xfrm>
+          <a:prstGeom prst="rect">
+            <a:avLst/>
+          </a:prstGeom>
+          <a:noFill/>
+        </p:spPr>
+        <p:txBody>
+          <a:bodyPr wrap="square" lIns="0" rIns="0" tIns="0" bIns="0" anchor="ctr">
+            <a:spAutoFit/>
+          </a:bodyPr>
+          <a:lstStyle/>
+          <a:p>
+            <a:pPr algn="ctr"/>
+            <a:r>
+              <a:rPr sz="1200" b="1">
+                <a:solidFill>
+                  <a:schemeClr val="bg1"/>
+                </a:solidFill>
+              </a:rPr>
+              <a:t>023</a:t>
+            </a:r>
+          </a:p>
+        </p:txBody>
+      </p:sp>
+      <p:sp>
+        <p:nvSpPr>
+          <p:cNvPr id="95" name="TextBox 82"/>
+          <p:cNvSpPr txBox="1"/>
+          <p:nvPr/>
+        </p:nvSpPr>
+        <p:spPr>
+          <a:xfrm>
+            <a:off x="5321807" y="4099560"/>
+            <a:ext cx="3566160" cy="283464"/>
+          </a:xfrm>
+          <a:prstGeom prst="rect">
+            <a:avLst/>
+          </a:prstGeom>
+          <a:noFill/>
+        </p:spPr>
+        <p:txBody>
+          <a:bodyPr wrap="square" lIns="0" rIns="0" tIns="0" bIns="0" anchor="ctr">
+            <a:spAutoFit/>
+          </a:bodyPr>
+          <a:lstStyle/>
+          <a:p>
+            <a:r>
+              <a:rPr sz="1300" b="0">
+                <a:solidFill>
+                  <a:schemeClr val="tx1"/>
+                </a:solidFill>
+              </a:rPr>
+              <a:t>Calidad RAG: benchmark y recuperación</a:t>
+            </a:r>
+          </a:p>
+        </p:txBody>
+      </p:sp>
+      <p:sp>
+        <p:nvSpPr>
+          <p:cNvPr id="96" name="Etiqueta"/>
+          <p:cNvSpPr/>
+          <p:nvPr/>
+        </p:nvSpPr>
+        <p:spPr>
+          <a:xfrm>
+            <a:off x="4663440" y="4404360"/>
+            <a:ext cx="548640" cy="283464"/>
+          </a:xfrm>
+          <a:prstGeom prst="roundRect">
+            <a:avLst>
+              <a:gd name="adj" fmla="val 17000"/>
+            </a:avLst>
+          </a:prstGeom>
+          <a:solidFill>
+            <a:schemeClr val="accent1"/>
+          </a:solidFill>
+          <a:ln w="12700">
+            <a:solidFill>
+              <a:schemeClr val="accent1"/>
+            </a:solidFill>
+          </a:ln>
+          <a:effectLst/>
+        </p:spPr>
+        <p:style>
+          <a:lnRef idx="1">
+            <a:schemeClr val="accent1"/>
+          </a:lnRef>
+          <a:fillRef idx="3">
+            <a:schemeClr val="accent1"/>
+          </a:fillRef>
+          <a:effectRef idx="2">
+            <a:schemeClr val="accent1"/>
+          </a:effectRef>
+          <a:fontRef idx="minor">
+            <a:schemeClr val="lt1"/>
+          </a:fontRef>
+        </p:style>
+        <p:txBody>
+          <a:bodyPr rtlCol="0" anchor="ctr"/>
+          <a:lstStyle/>
+          <a:p>
+            <a:pPr algn="ctr"/>
+          </a:p>
+        </p:txBody>
+      </p:sp>
+      <p:sp>
+        <p:nvSpPr>
+          <p:cNvPr id="97" name="TextBox 81"/>
+          <p:cNvSpPr txBox="1"/>
+          <p:nvPr/>
+        </p:nvSpPr>
+        <p:spPr>
+          <a:xfrm>
+            <a:off x="4663440" y="4404360"/>
+            <a:ext cx="548640" cy="283464"/>
+          </a:xfrm>
+          <a:prstGeom prst="rect">
+            <a:avLst/>
+          </a:prstGeom>
+          <a:noFill/>
+        </p:spPr>
+        <p:txBody>
+          <a:bodyPr wrap="square" lIns="0" rIns="0" tIns="0" bIns="0" anchor="ctr">
+            <a:spAutoFit/>
+          </a:bodyPr>
+          <a:lstStyle/>
+          <a:p>
+            <a:pPr algn="ctr"/>
+            <a:r>
+              <a:rPr sz="1200" b="1">
+                <a:solidFill>
+                  <a:schemeClr val="bg1"/>
+                </a:solidFill>
+              </a:rPr>
+              <a:t>024</a:t>
+            </a:r>
+          </a:p>
+        </p:txBody>
+      </p:sp>
+      <p:sp>
+        <p:nvSpPr>
+          <p:cNvPr id="98" name="TextBox 82"/>
+          <p:cNvSpPr txBox="1"/>
+          <p:nvPr/>
+        </p:nvSpPr>
+        <p:spPr>
+          <a:xfrm>
+            <a:off x="5321807" y="4404360"/>
+            <a:ext cx="3566160" cy="283464"/>
+          </a:xfrm>
+          <a:prstGeom prst="rect">
+            <a:avLst/>
+          </a:prstGeom>
+          <a:noFill/>
+        </p:spPr>
+        <p:txBody>
+          <a:bodyPr wrap="square" lIns="0" rIns="0" tIns="0" bIns="0" anchor="ctr">
+            <a:spAutoFit/>
+          </a:bodyPr>
+          <a:lstStyle/>
+          <a:p>
+            <a:r>
+              <a:rPr sz="1300" b="0">
+                <a:solidFill>
+                  <a:schemeClr val="tx1"/>
+                </a:solidFill>
+              </a:rPr>
+              <a:t>Sistema de diseño de la interfaz</a:t>
             </a:r>
           </a:p>
         </p:txBody>
@@ -11573,7 +12894,7 @@
 </p:sld>
 </file>
 
-<file path=ppt/slides/slide7.xml><?xml version="1.0" encoding="utf-8"?>
+<file path=ppt/slides/slide8.xml><?xml version="1.0" encoding="utf-8"?>
 <p:sld xmlns:a="http://schemas.openxmlformats.org/drawingml/2006/main" xmlns:r="http://schemas.openxmlformats.org/officeDocument/2006/relationships" xmlns:p="http://schemas.openxmlformats.org/presentationml/2006/main">
   <p:cSld name="Slide 7">
     <p:spTree>
@@ -12361,7 +13682,7 @@
 </p:sld>
 </file>
 
-<file path=ppt/slides/slide8.xml><?xml version="1.0" encoding="utf-8"?>
+<file path=ppt/slides/slide9.xml><?xml version="1.0" encoding="utf-8"?>
 <p:sld xmlns:a="http://schemas.openxmlformats.org/drawingml/2006/main" xmlns:r="http://schemas.openxmlformats.org/officeDocument/2006/relationships" xmlns:p="http://schemas.openxmlformats.org/presentationml/2006/main">
   <p:cSld name="Slide 8">
     <p:spTree>
@@ -12942,430 +14263,6 @@
                 </a:solidFill>
               </a:rPr>
               <a:t>Embeddings locales con bge-m3 (Ollama) · Gemini solo para visión y explicaciones</a:t>
-            </a:r>
-          </a:p>
-        </p:txBody>
-      </p:sp>
-    </p:spTree>
-  </p:cSld>
-  <p:clrMapOvr>
-    <a:masterClrMapping/>
-  </p:clrMapOvr>
-</p:sld>
-</file>
-
-<file path=ppt/slides/slide9.xml><?xml version="1.0" encoding="utf-8"?>
-<p:sld xmlns:a="http://schemas.openxmlformats.org/drawingml/2006/main" xmlns:r="http://schemas.openxmlformats.org/officeDocument/2006/relationships" xmlns:p="http://schemas.openxmlformats.org/presentationml/2006/main">
-  <p:cSld name="Slide 9">
-    <p:spTree>
-      <p:nvGrpSpPr>
-        <p:cNvPr id="1" name=""/>
-        <p:cNvGrpSpPr/>
-        <p:nvPr/>
-      </p:nvGrpSpPr>
-      <p:grpSpPr>
-        <a:xfrm>
-          <a:off x="0" y="0"/>
-          <a:ext cx="0" cy="0"/>
-          <a:chOff x="0" y="0"/>
-          <a:chExt cx="0" cy="0"/>
-        </a:xfrm>
-      </p:grpSpPr>
-      <p:sp>
-        <p:nvSpPr>
-          <p:cNvPr id="25" name="Slide Number Placeholder 0"/>
-          <p:cNvSpPr>
-            <a:spLocks noGrp="1"/>
-          </p:cNvSpPr>
-          <p:nvPr>
-            <p:ph type="sldNum" sz="quarter" idx="4294967295"/>
-          </p:nvPr>
-        </p:nvSpPr>
-        <p:spPr>
-          <a:xfrm>
-            <a:off x="8229600" y="4754880"/>
-            <a:ext cx="457200" cy="274320"/>
-          </a:xfrm>
-          <a:prstGeom prst="rect">
-            <a:avLst/>
-          </a:prstGeom>
-          <a:extLst>
-            <a:ext uri="{C572A759-6A51-4108-AA02-DFA0A04FC94B}">
-              <ma14:wrappingTextBoxFlag xmlns:ma14="http://schemas.microsoft.com/office/mac/drawingml/2011/main" val="0"/>
-            </a:ext>
-          </a:extLst>
-        </p:spPr>
-        <p:txBody>
-          <a:bodyPr/>
-          <a:lstStyle>
-            <a:lvl1pPr>
-              <a:defRPr sz="1000">
-                <a:solidFill>
-                  <a:schemeClr val="accent6"/>
-                </a:solidFill>
-              </a:defRPr>
-            </a:lvl1pPr>
-          </a:lstStyle>
-          <a:p>
-            <a:pPr algn="r"/>
-            <a:fld id="{F7021451-1387-4CA6-816F-3879F97B5CBC}" type="slidenum">
-              <a:rPr b="0" lang="en-US"/>
-              <a:t>9</a:t>
-            </a:fld>
-            <a:endParaRPr lang="en-US"/>
-          </a:p>
-        </p:txBody>
-      </p:sp>
-      <p:sp>
-        <p:nvSpPr>
-          <p:cNvPr id="26" name="Titulo"/>
-          <p:cNvSpPr txBox="1"/>
-          <p:nvPr/>
-        </p:nvSpPr>
-        <p:spPr>
-          <a:xfrm>
-            <a:off x="457200" y="274320"/>
-            <a:ext cx="8229600" cy="685800"/>
-          </a:xfrm>
-          <a:prstGeom prst="rect">
-            <a:avLst/>
-          </a:prstGeom>
-          <a:noFill/>
-        </p:spPr>
-        <p:txBody>
-          <a:bodyPr wrap="square" lIns="0" rIns="0" tIns="0" bIns="0" anchor="ctr">
-            <a:spAutoFit/>
-          </a:bodyPr>
-          <a:lstStyle/>
-          <a:p>
-            <a:r>
-              <a:rPr sz="2800" b="1">
-                <a:solidFill>
-                  <a:schemeClr val="tx2"/>
-                </a:solidFill>
-                <a:latin typeface="Cambria"/>
-              </a:rPr>
-              <a:t>IA en el desarrollo</a:t>
-            </a:r>
-          </a:p>
-        </p:txBody>
-      </p:sp>
-      <p:sp>
-        <p:nvSpPr>
-          <p:cNvPr id="27" name="Panel cifras"/>
-          <p:cNvSpPr/>
-          <p:nvPr/>
-        </p:nvSpPr>
-        <p:spPr>
-          <a:xfrm>
-            <a:off x="457200" y="1188720"/>
-            <a:ext cx="2834640" cy="3246120"/>
-          </a:xfrm>
-          <a:prstGeom prst="roundRect">
-            <a:avLst>
-              <a:gd name="adj" fmla="val 5000"/>
-            </a:avLst>
-          </a:prstGeom>
-          <a:solidFill>
-            <a:schemeClr val="accent1"/>
-          </a:solidFill>
-          <a:ln w="12700">
-            <a:solidFill>
-              <a:schemeClr val="accent1"/>
-            </a:solidFill>
-          </a:ln>
-          <a:effectLst/>
-        </p:spPr>
-        <p:style>
-          <a:lnRef idx="1">
-            <a:schemeClr val="accent1"/>
-          </a:lnRef>
-          <a:fillRef idx="3">
-            <a:schemeClr val="accent1"/>
-          </a:fillRef>
-          <a:effectRef idx="2">
-            <a:schemeClr val="accent1"/>
-          </a:effectRef>
-          <a:fontRef idx="minor">
-            <a:schemeClr val="lt1"/>
-          </a:fontRef>
-        </p:style>
-        <p:txBody>
-          <a:bodyPr rtlCol="0" anchor="ctr"/>
-          <a:lstStyle/>
-          <a:p>
-            <a:pPr algn="ctr"/>
-          </a:p>
-        </p:txBody>
-      </p:sp>
-      <p:sp>
-        <p:nvSpPr>
-          <p:cNvPr id="28" name="TextBox 27"/>
-          <p:cNvSpPr txBox="1"/>
-          <p:nvPr/>
-        </p:nvSpPr>
-        <p:spPr>
-          <a:xfrm>
-            <a:off x="457200" y="1371600"/>
-            <a:ext cx="2834640" cy="868680"/>
-          </a:xfrm>
-          <a:prstGeom prst="rect">
-            <a:avLst/>
-          </a:prstGeom>
-          <a:noFill/>
-        </p:spPr>
-        <p:txBody>
-          <a:bodyPr wrap="square" lIns="0" rIns="0" tIns="0" bIns="0" anchor="ctr">
-            <a:spAutoFit/>
-          </a:bodyPr>
-          <a:lstStyle/>
-          <a:p>
-            <a:pPr algn="ctr"/>
-            <a:r>
-              <a:rPr sz="4000" b="1">
-                <a:solidFill>
-                  <a:schemeClr val="accent2"/>
-                </a:solidFill>
-              </a:rPr>
-              <a:t>166 / 167</a:t>
-            </a:r>
-          </a:p>
-        </p:txBody>
-      </p:sp>
-      <p:sp>
-        <p:nvSpPr>
-          <p:cNvPr id="29" name="TextBox 28"/>
-          <p:cNvSpPr txBox="1"/>
-          <p:nvPr/>
-        </p:nvSpPr>
-        <p:spPr>
-          <a:xfrm>
-            <a:off x="640080" y="2286000"/>
-            <a:ext cx="2468880" cy="731520"/>
-          </a:xfrm>
-          <a:prstGeom prst="rect">
-            <a:avLst/>
-          </a:prstGeom>
-          <a:noFill/>
-        </p:spPr>
-        <p:txBody>
-          <a:bodyPr wrap="square" lIns="0" rIns="0" tIns="0" bIns="0" anchor="ctr">
-            <a:spAutoFit/>
-          </a:bodyPr>
-          <a:lstStyle/>
-          <a:p>
-            <a:pPr algn="ctr"/>
-            <a:r>
-              <a:rPr sz="1600" b="0">
-                <a:solidFill>
-                  <a:schemeClr val="bg1"/>
-                </a:solidFill>
-              </a:rPr>
-              <a:t>commits co-autorados con Claude (99 %)</a:t>
-            </a:r>
-          </a:p>
-        </p:txBody>
-      </p:sp>
-      <p:sp>
-        <p:nvSpPr>
-          <p:cNvPr id="30" name="TextBox 29"/>
-          <p:cNvSpPr txBox="1"/>
-          <p:nvPr/>
-        </p:nvSpPr>
-        <p:spPr>
-          <a:xfrm>
-            <a:off x="640080" y="3200400"/>
-            <a:ext cx="2468880" cy="822960"/>
-          </a:xfrm>
-          <a:prstGeom prst="rect">
-            <a:avLst/>
-          </a:prstGeom>
-          <a:noFill/>
-        </p:spPr>
-        <p:txBody>
-          <a:bodyPr wrap="square" lIns="0" rIns="0" tIns="0" bIns="0" anchor="ctr">
-            <a:spAutoFit/>
-          </a:bodyPr>
-          <a:lstStyle/>
-          <a:p>
-            <a:pPr algn="ctr"/>
-            <a:r>
-              <a:rPr sz="1400" b="0">
-                <a:solidFill>
-                  <a:schemeClr val="accent4"/>
-                </a:solidFill>
-              </a:rPr>
-              <a:t>56 historias de usuario</a:t>
-            </a:r>
-          </a:p>
-          <a:p>
-            <a:pPr algn="ctr"/>
-            <a:r>
-              <a:rPr sz="1400" b="0">
-                <a:solidFill>
-                  <a:schemeClr val="accent4"/>
-                </a:solidFill>
-              </a:rPr>
-              <a:t>21 ADR</a:t>
-            </a:r>
-          </a:p>
-        </p:txBody>
-      </p:sp>
-      <p:sp>
-        <p:nvSpPr>
-          <p:cNvPr id="31" name="TextBox 30"/>
-          <p:cNvSpPr txBox="1"/>
-          <p:nvPr/>
-        </p:nvSpPr>
-        <p:spPr>
-          <a:xfrm>
-            <a:off x="3611880" y="1188720"/>
-            <a:ext cx="5074920" cy="3291840"/>
-          </a:xfrm>
-          <a:prstGeom prst="rect">
-            <a:avLst/>
-          </a:prstGeom>
-          <a:noFill/>
-        </p:spPr>
-        <p:txBody>
-          <a:bodyPr wrap="square" lIns="0" rIns="0" tIns="0" bIns="0">
-            <a:spAutoFit/>
-          </a:bodyPr>
-          <a:lstStyle/>
-          <a:p>
-            <a:pPr marL="228600" indent="-228600">
-              <a:spcAft>
-                <a:spcPts val="800"/>
-              </a:spcAft>
-              <a:buSzPct val="100000"/>
-              <a:buChar char="•"/>
-            </a:pPr>
-            <a:r>
-              <a:rPr sz="1500" b="0">
-                <a:solidFill>
-                  <a:schemeClr val="tx1"/>
-                </a:solidFill>
-              </a:rPr>
-              <a:t>Spec Driven Development: especificación antes del código</a:t>
-            </a:r>
-          </a:p>
-          <a:p>
-            <a:pPr marL="228600" indent="-228600">
-              <a:spcAft>
-                <a:spcPts val="800"/>
-              </a:spcAft>
-              <a:buSzPct val="100000"/>
-              <a:buChar char="•"/>
-            </a:pPr>
-            <a:r>
-              <a:rPr sz="1500" b="0">
-                <a:solidFill>
-                  <a:schemeClr val="tx1"/>
-                </a:solidFill>
-              </a:rPr>
-              <a:t>CLAUDE.md como contrato con el agente; ESLint protege las fronteras</a:t>
-            </a:r>
-          </a:p>
-          <a:p>
-            <a:pPr marL="228600" indent="-228600">
-              <a:spcAft>
-                <a:spcPts val="800"/>
-              </a:spcAft>
-              <a:buSzPct val="100000"/>
-              <a:buChar char="•"/>
-            </a:pPr>
-            <a:r>
-              <a:rPr sz="1500" b="0">
-                <a:solidFill>
-                  <a:schemeClr val="tx1"/>
-                </a:solidFill>
-              </a:rPr>
-              <a:t>TDD en el dominio; IDs de requisitos en tests y commits</a:t>
-            </a:r>
-          </a:p>
-          <a:p>
-            <a:pPr marL="228600" indent="-228600">
-              <a:spcAft>
-                <a:spcPts val="800"/>
-              </a:spcAft>
-              <a:buSzPct val="100000"/>
-              <a:buChar char="•"/>
-            </a:pPr>
-            <a:r>
-              <a:rPr sz="1500" b="0">
-                <a:solidFill>
-                  <a:schemeClr val="tx1"/>
-                </a:solidFill>
-              </a:rPr>
-              <a:t>Agentes en paralelo, cada uno en su git worktree</a:t>
-            </a:r>
-          </a:p>
-          <a:p>
-            <a:pPr marL="228600" indent="-228600">
-              <a:spcAft>
-                <a:spcPts val="800"/>
-              </a:spcAft>
-              <a:buSzPct val="100000"/>
-              <a:buChar char="•"/>
-            </a:pPr>
-            <a:r>
-              <a:rPr sz="1500" b="0">
-                <a:solidFill>
-                  <a:schemeClr val="tx1"/>
-                </a:solidFill>
-              </a:rPr>
-              <a:t>Skills de la comunidad fijadas en el repo, con reglas de precedencia</a:t>
-            </a:r>
-          </a:p>
-          <a:p>
-            <a:pPr marL="228600" indent="-228600">
-              <a:spcAft>
-                <a:spcPts val="800"/>
-              </a:spcAft>
-              <a:buSzPct val="100000"/>
-              <a:buChar char="•"/>
-            </a:pPr>
-            <a:r>
-              <a:rPr sz="1500" b="0">
-                <a:solidFill>
-                  <a:schemeClr val="tx1"/>
-                </a:solidFill>
-              </a:rPr>
-              <a:t>Migración a Paper: un agente orquestador y subagentes en paralelo</a:t>
-            </a:r>
-          </a:p>
-          <a:p>
-            <a:pPr marL="228600" indent="-228600">
-              <a:spcAft>
-                <a:spcPts val="800"/>
-              </a:spcAft>
-              <a:buSzPct val="100000"/>
-              <a:buChar char="•"/>
-            </a:pPr>
-            <a:r>
-              <a:rPr sz="1500" b="0">
-                <a:solidFill>
-                  <a:schemeClr val="tx1"/>
-                </a:solidFill>
-              </a:rPr>
-              <a:t>Evaluaciones con el modelo real (23 preguntas)</a:t>
-            </a:r>
-          </a:p>
-          <a:p>
-            <a:pPr marL="228600" indent="-228600">
-              <a:spcAft>
-                <a:spcPts val="800"/>
-              </a:spcAft>
-              <a:buSzPct val="100000"/>
-              <a:buChar char="•"/>
-            </a:pPr>
-            <a:r>
-              <a:rPr sz="1500" b="0">
-                <a:solidFill>
-                  <a:schemeClr val="tx1"/>
-                </a:solidFill>
-              </a:rPr>
-              <a:t>Benchmark de modelos locales antes de decidir</a:t>
             </a:r>
           </a:p>
         </p:txBody>

</xml_diff>

<commit_message>
docs(slides): 26 ADR, 63 stories, current test and commit counts, 60-question evaluation, Gemini for the demo assistant (ADR-025, ADR-026)
Co-Authored-By: Claude Opus 5.5 <noreply@anthropic.com>
</commit_message>
<xml_diff>
--- a/docs/slides/multicooperativa-tfm.pptx
+++ b/docs/slides/multicooperativa-tfm.pptx
@@ -2697,7 +2697,7 @@
                   <a:schemeClr val="accent2"/>
                 </a:solidFill>
               </a:rPr>
-              <a:t>236 / 237</a:t>
+              <a:t>244 / 245</a:t>
             </a:r>
           </a:p>
         </p:txBody>
@@ -2765,7 +2765,7 @@
                   <a:schemeClr val="accent4"/>
                 </a:solidFill>
               </a:rPr>
-              <a:t>59 historias de usuario</a:t>
+              <a:t>63 historias de usuario</a:t>
             </a:r>
           </a:p>
           <a:p>
@@ -2776,7 +2776,7 @@
                   <a:schemeClr val="accent4"/>
                 </a:solidFill>
               </a:rPr>
-              <a:t>24 ADR</a:t>
+              <a:t>26 ADR</a:t>
             </a:r>
           </a:p>
         </p:txBody>
@@ -2918,7 +2918,7 @@
                   <a:schemeClr val="tx1"/>
                 </a:solidFill>
               </a:rPr>
-              <a:t>Evaluaciones con el modelo real (26 preguntas)</a:t>
+              <a:t>Evaluaciones con el modelo real (60 preguntas)</a:t>
             </a:r>
           </a:p>
           <a:p>
@@ -3121,7 +3121,7 @@
                   <a:schemeClr val="accent2"/>
                 </a:solidFill>
               </a:rPr>
-              <a:t>1338</a:t>
+              <a:t>1504</a:t>
             </a:r>
           </a:p>
         </p:txBody>
@@ -3155,7 +3155,7 @@
                   <a:schemeClr val="bg1"/>
                 </a:solidFill>
               </a:rPr>
-              <a:t>tests unitarios en 133 ficheros</a:t>
+              <a:t>tests unitarios en 136 ficheros</a:t>
             </a:r>
           </a:p>
         </p:txBody>
@@ -3237,7 +3237,7 @@
                   <a:schemeClr val="accent2"/>
                 </a:solidFill>
               </a:rPr>
-              <a:t>574</a:t>
+              <a:t>611</a:t>
             </a:r>
           </a:p>
         </p:txBody>
@@ -3271,7 +3271,7 @@
                   <a:schemeClr val="bg1"/>
                 </a:solidFill>
               </a:rPr>
-              <a:t>tests de integración en 30 ficheros</a:t>
+              <a:t>tests de integración en 32 ficheros</a:t>
             </a:r>
           </a:p>
         </p:txBody>
@@ -3481,7 +3481,7 @@
         </p:nvGraphicFramePr>
         <p:xfrm>
           <a:off x="3840480" y="2514600"/>
-          <a:ext cx="4754880" cy="1719072"/>
+          <a:ext cx="4754880" cy="1480000"/>
         </p:xfrm>
         <a:graphic>
           <a:graphicData uri="http://schemas.openxmlformats.org/drawingml/2006/chart">
@@ -3497,7 +3497,7 @@
         </p:nvSpPr>
         <p:spPr>
           <a:xfrm>
-            <a:off x="3931920" y="4224528"/>
+            <a:off x="3931920" y="4020000"/>
             <a:ext cx="4572000" cy="274320"/>
           </a:xfrm>
           <a:prstGeom prst="rect">
@@ -3517,7 +3517,17 @@
                   <a:schemeClr val="accent6"/>
                 </a:solidFill>
               </a:rPr>
-              <a:t>Mac de 12 CPU, solo CPU · el conjunto tiene hoy 26 preguntas</a:t>
+              <a:t>Benchmark de 22 preguntas con el que se eligió el modelo local · Mac de 12 CPU</a:t>
+            </a:r>
+          </a:p>
+          <a:p>
+            <a:r>
+              <a:rPr sz="1000" b="0">
+                <a:solidFill>
+                  <a:schemeClr val="accent6"/>
+                </a:solidFill>
+              </a:rPr>
+              <a:t>Conjunto actual: 60 preguntas · qwen3:4b-instruct 47/60 · Gemini Flash-Lite 53/60</a:t>
             </a:r>
           </a:p>
         </p:txBody>
@@ -4333,7 +4343,7 @@
                   <a:schemeClr val="bg1"/>
                 </a:solidFill>
               </a:rPr>
-              <a:t>qwen3 · bge-m3</a:t>
+              <a:t>bge-m3 · qwen3 (por defecto)</a:t>
             </a:r>
           </a:p>
         </p:txBody>
@@ -4426,7 +4436,7 @@
                   <a:schemeClr val="tx2"/>
                 </a:solidFill>
               </a:rPr>
-              <a:t>visión y explicaciones</a:t>
+              <a:t>visión, explicaciones y asistente de la demo</a:t>
             </a:r>
           </a:p>
         </p:txBody>
@@ -5213,7 +5223,7 @@
                             <a:schemeClr val="tx1"/>
                           </a:solidFill>
                         </a:rPr>
-                        <a:t>Facturas, escaneo con IA, discrepancias, proveedores y clientes</a:t>
+                        <a:t>Facturas, escaneo con IA, discrepancias, proveedores y clientes; asistente: "mayores proveedores del año"</a:t>
                       </a:r>
                     </a:p>
                   </a:txBody>
@@ -5338,7 +5348,7 @@
                             <a:schemeClr val="tx1"/>
                           </a:solidFill>
                         </a:rPr>
-                        <a:t>Comunicados, asambleas, vigilar pagos y cobros</a:t>
+                        <a:t>Comunicados, asambleas, vigilar pagos y cobros; asistente: capital y censo de socios</a:t>
                       </a:r>
                     </a:p>
                   </a:txBody>
@@ -5735,7 +5745,7 @@
                   <a:schemeClr val="tx1"/>
                 </a:solidFill>
               </a:rPr>
-              <a:t>La cuota de Gemini (~20 peticiones/día en Flash) llevó al modelo local</a:t>
+              <a:t>La cuota de Gemini llevó al modelo local; en el servidor, la CPU lo hizo inviable (&gt;30 s) y la demo volvió a Gemini</a:t>
             </a:r>
           </a:p>
           <a:p>
@@ -5786,7 +5796,7 @@
                   <a:schemeClr val="tx1"/>
                 </a:solidFill>
               </a:rPr>
-              <a:t>Evaluar con el modelo real encontró errores reales</a:t>
+              <a:t>La evaluación offline no basta: medir con el modelo real (32/60 → 47/60 tras ajustar)</a:t>
             </a:r>
           </a:p>
           <a:p>
@@ -7621,7 +7631,7 @@
                   <a:schemeClr val="bg1"/>
                 </a:solidFill>
               </a:rPr>
-              <a:t>Asistente de IA con citas, historial y modelo local o externo</a:t>
+              <a:t>Asistente de IA con citas, historial, facturación agregada y socios; modelo local o externo</a:t>
             </a:r>
           </a:p>
           <a:p>
@@ -9178,7 +9188,7 @@
                   <a:schemeClr val="tx2"/>
                 </a:solidFill>
               </a:rPr>
-              <a:t>Ollama (local): asistente y embeddings</a:t>
+              <a:t>Ollama (local): embeddings y asistente por defecto</a:t>
             </a:r>
           </a:p>
         </p:txBody>
@@ -9296,7 +9306,7 @@
                   <a:schemeClr val="tx2"/>
                 </a:solidFill>
               </a:rPr>
-              <a:t>Gemini: visión y explicaciones</a:t>
+              <a:t>Gemini: visión, explicaciones y asistente de la demo</a:t>
             </a:r>
           </a:p>
         </p:txBody>
@@ -10121,7 +10131,7 @@
                 </a:solidFill>
                 <a:latin typeface="Cambria"/>
               </a:rPr>
-              <a:t>Decisiones clave: 24 ADR</a:t>
+              <a:t>Decisiones clave: 26 ADR</a:t>
             </a:r>
           </a:p>
         </p:txBody>
@@ -10135,7 +10145,7 @@
         <p:spPr>
           <a:xfrm>
             <a:off x="457200" y="1051560"/>
-            <a:ext cx="548640" cy="283464"/>
+            <a:ext cx="548640" cy="256032"/>
           </a:xfrm>
           <a:prstGeom prst="roundRect">
             <a:avLst>
@@ -10183,7 +10193,7 @@
         <p:spPr>
           <a:xfrm>
             <a:off x="457200" y="1051560"/>
-            <a:ext cx="548640" cy="283464"/>
+            <a:ext cx="548640" cy="256032"/>
           </a:xfrm>
           <a:prstGeom prst="rect">
             <a:avLst/>
@@ -10217,7 +10227,7 @@
         <p:spPr>
           <a:xfrm>
             <a:off x="1115568" y="1051560"/>
-            <a:ext cx="3383280" cy="283464"/>
+            <a:ext cx="3383280" cy="256032"/>
           </a:xfrm>
           <a:prstGeom prst="rect">
             <a:avLst/>
@@ -10249,8 +10259,8 @@
         </p:nvSpPr>
         <p:spPr>
           <a:xfrm>
-            <a:off x="457200" y="1356360"/>
-            <a:ext cx="548640" cy="283464"/>
+            <a:off x="457200" y="1330960"/>
+            <a:ext cx="548640" cy="256032"/>
           </a:xfrm>
           <a:prstGeom prst="roundRect">
             <a:avLst>
@@ -10297,8 +10307,8 @@
         </p:nvSpPr>
         <p:spPr>
           <a:xfrm>
-            <a:off x="457200" y="1356360"/>
-            <a:ext cx="548640" cy="283464"/>
+            <a:off x="457200" y="1330960"/>
+            <a:ext cx="548640" cy="256032"/>
           </a:xfrm>
           <a:prstGeom prst="rect">
             <a:avLst/>
@@ -10331,8 +10341,8 @@
         </p:nvSpPr>
         <p:spPr>
           <a:xfrm>
-            <a:off x="1115568" y="1356360"/>
-            <a:ext cx="3383280" cy="283464"/>
+            <a:off x="1115568" y="1330960"/>
+            <a:ext cx="3383280" cy="256032"/>
           </a:xfrm>
           <a:prstGeom prst="rect">
             <a:avLst/>
@@ -10364,8 +10374,8 @@
         </p:nvSpPr>
         <p:spPr>
           <a:xfrm>
-            <a:off x="457200" y="1661160"/>
-            <a:ext cx="548640" cy="283464"/>
+            <a:off x="457200" y="1610360"/>
+            <a:ext cx="548640" cy="256032"/>
           </a:xfrm>
           <a:prstGeom prst="roundRect">
             <a:avLst>
@@ -10412,8 +10422,8 @@
         </p:nvSpPr>
         <p:spPr>
           <a:xfrm>
-            <a:off x="457200" y="1661160"/>
-            <a:ext cx="548640" cy="283464"/>
+            <a:off x="457200" y="1610360"/>
+            <a:ext cx="548640" cy="256032"/>
           </a:xfrm>
           <a:prstGeom prst="rect">
             <a:avLst/>
@@ -10446,8 +10456,8 @@
         </p:nvSpPr>
         <p:spPr>
           <a:xfrm>
-            <a:off x="1115568" y="1661160"/>
-            <a:ext cx="3383280" cy="283464"/>
+            <a:off x="1115568" y="1610360"/>
+            <a:ext cx="3383280" cy="256032"/>
           </a:xfrm>
           <a:prstGeom prst="rect">
             <a:avLst/>
@@ -10479,8 +10489,8 @@
         </p:nvSpPr>
         <p:spPr>
           <a:xfrm>
-            <a:off x="457200" y="1965960"/>
-            <a:ext cx="548640" cy="283464"/>
+            <a:off x="457200" y="1889760"/>
+            <a:ext cx="548640" cy="256032"/>
           </a:xfrm>
           <a:prstGeom prst="roundRect">
             <a:avLst>
@@ -10527,8 +10537,8 @@
         </p:nvSpPr>
         <p:spPr>
           <a:xfrm>
-            <a:off x="457200" y="1965960"/>
-            <a:ext cx="548640" cy="283464"/>
+            <a:off x="457200" y="1889760"/>
+            <a:ext cx="548640" cy="256032"/>
           </a:xfrm>
           <a:prstGeom prst="rect">
             <a:avLst/>
@@ -10561,8 +10571,8 @@
         </p:nvSpPr>
         <p:spPr>
           <a:xfrm>
-            <a:off x="1115568" y="1965960"/>
-            <a:ext cx="3383280" cy="283464"/>
+            <a:off x="1115568" y="1889760"/>
+            <a:ext cx="3383280" cy="256032"/>
           </a:xfrm>
           <a:prstGeom prst="rect">
             <a:avLst/>
@@ -10594,8 +10604,8 @@
         </p:nvSpPr>
         <p:spPr>
           <a:xfrm>
-            <a:off x="457200" y="2270760"/>
-            <a:ext cx="548640" cy="283464"/>
+            <a:off x="457200" y="2169160"/>
+            <a:ext cx="548640" cy="256032"/>
           </a:xfrm>
           <a:prstGeom prst="roundRect">
             <a:avLst>
@@ -10642,8 +10652,8 @@
         </p:nvSpPr>
         <p:spPr>
           <a:xfrm>
-            <a:off x="457200" y="2270760"/>
-            <a:ext cx="548640" cy="283464"/>
+            <a:off x="457200" y="2169160"/>
+            <a:ext cx="548640" cy="256032"/>
           </a:xfrm>
           <a:prstGeom prst="rect">
             <a:avLst/>
@@ -10676,8 +10686,8 @@
         </p:nvSpPr>
         <p:spPr>
           <a:xfrm>
-            <a:off x="1115568" y="2270760"/>
-            <a:ext cx="3383280" cy="283464"/>
+            <a:off x="1115568" y="2169160"/>
+            <a:ext cx="3383280" cy="256032"/>
           </a:xfrm>
           <a:prstGeom prst="rect">
             <a:avLst/>
@@ -10709,8 +10719,8 @@
         </p:nvSpPr>
         <p:spPr>
           <a:xfrm>
-            <a:off x="457200" y="2575560"/>
-            <a:ext cx="548640" cy="283464"/>
+            <a:off x="457200" y="2448560"/>
+            <a:ext cx="548640" cy="256032"/>
           </a:xfrm>
           <a:prstGeom prst="roundRect">
             <a:avLst>
@@ -10757,8 +10767,8 @@
         </p:nvSpPr>
         <p:spPr>
           <a:xfrm>
-            <a:off x="457200" y="2575560"/>
-            <a:ext cx="548640" cy="283464"/>
+            <a:off x="457200" y="2448560"/>
+            <a:ext cx="548640" cy="256032"/>
           </a:xfrm>
           <a:prstGeom prst="rect">
             <a:avLst/>
@@ -10791,8 +10801,8 @@
         </p:nvSpPr>
         <p:spPr>
           <a:xfrm>
-            <a:off x="1115568" y="2575560"/>
-            <a:ext cx="3383280" cy="283464"/>
+            <a:off x="1115568" y="2448560"/>
+            <a:ext cx="3383280" cy="256032"/>
           </a:xfrm>
           <a:prstGeom prst="rect">
             <a:avLst/>
@@ -10824,8 +10834,8 @@
         </p:nvSpPr>
         <p:spPr>
           <a:xfrm>
-            <a:off x="457200" y="2880360"/>
-            <a:ext cx="548640" cy="283464"/>
+            <a:off x="457200" y="2727960"/>
+            <a:ext cx="548640" cy="256032"/>
           </a:xfrm>
           <a:prstGeom prst="roundRect">
             <a:avLst>
@@ -10872,8 +10882,8 @@
         </p:nvSpPr>
         <p:spPr>
           <a:xfrm>
-            <a:off x="457200" y="2880360"/>
-            <a:ext cx="548640" cy="283464"/>
+            <a:off x="457200" y="2727960"/>
+            <a:ext cx="548640" cy="256032"/>
           </a:xfrm>
           <a:prstGeom prst="rect">
             <a:avLst/>
@@ -10906,8 +10916,8 @@
         </p:nvSpPr>
         <p:spPr>
           <a:xfrm>
-            <a:off x="1115568" y="2880360"/>
-            <a:ext cx="3383280" cy="283464"/>
+            <a:off x="1115568" y="2727960"/>
+            <a:ext cx="3383280" cy="256032"/>
           </a:xfrm>
           <a:prstGeom prst="rect">
             <a:avLst/>
@@ -10939,8 +10949,8 @@
         </p:nvSpPr>
         <p:spPr>
           <a:xfrm>
-            <a:off x="457200" y="3185160"/>
-            <a:ext cx="548640" cy="283464"/>
+            <a:off x="457200" y="3007360"/>
+            <a:ext cx="548640" cy="256032"/>
           </a:xfrm>
           <a:prstGeom prst="roundRect">
             <a:avLst>
@@ -10987,8 +10997,8 @@
         </p:nvSpPr>
         <p:spPr>
           <a:xfrm>
-            <a:off x="457200" y="3185160"/>
-            <a:ext cx="548640" cy="283464"/>
+            <a:off x="457200" y="3007360"/>
+            <a:ext cx="548640" cy="256032"/>
           </a:xfrm>
           <a:prstGeom prst="rect">
             <a:avLst/>
@@ -11021,8 +11031,8 @@
         </p:nvSpPr>
         <p:spPr>
           <a:xfrm>
-            <a:off x="1115568" y="3185160"/>
-            <a:ext cx="3383280" cy="283464"/>
+            <a:off x="1115568" y="3007360"/>
+            <a:ext cx="3383280" cy="256032"/>
           </a:xfrm>
           <a:prstGeom prst="rect">
             <a:avLst/>
@@ -11054,8 +11064,8 @@
         </p:nvSpPr>
         <p:spPr>
           <a:xfrm>
-            <a:off x="457200" y="3489960"/>
-            <a:ext cx="548640" cy="283464"/>
+            <a:off x="457200" y="3286760"/>
+            <a:ext cx="548640" cy="256032"/>
           </a:xfrm>
           <a:prstGeom prst="roundRect">
             <a:avLst>
@@ -11102,8 +11112,8 @@
         </p:nvSpPr>
         <p:spPr>
           <a:xfrm>
-            <a:off x="457200" y="3489960"/>
-            <a:ext cx="548640" cy="283464"/>
+            <a:off x="457200" y="3286760"/>
+            <a:ext cx="548640" cy="256032"/>
           </a:xfrm>
           <a:prstGeom prst="rect">
             <a:avLst/>
@@ -11136,8 +11146,8 @@
         </p:nvSpPr>
         <p:spPr>
           <a:xfrm>
-            <a:off x="1115568" y="3489960"/>
-            <a:ext cx="3383280" cy="283464"/>
+            <a:off x="1115568" y="3286760"/>
+            <a:ext cx="3383280" cy="256032"/>
           </a:xfrm>
           <a:prstGeom prst="rect">
             <a:avLst/>
@@ -11169,8 +11179,8 @@
         </p:nvSpPr>
         <p:spPr>
           <a:xfrm>
-            <a:off x="457200" y="3794760"/>
-            <a:ext cx="548640" cy="283464"/>
+            <a:off x="457200" y="3566160"/>
+            <a:ext cx="548640" cy="256032"/>
           </a:xfrm>
           <a:prstGeom prst="roundRect">
             <a:avLst>
@@ -11217,8 +11227,8 @@
         </p:nvSpPr>
         <p:spPr>
           <a:xfrm>
-            <a:off x="457200" y="3794760"/>
-            <a:ext cx="548640" cy="283464"/>
+            <a:off x="457200" y="3566160"/>
+            <a:ext cx="548640" cy="256032"/>
           </a:xfrm>
           <a:prstGeom prst="rect">
             <a:avLst/>
@@ -11251,8 +11261,8 @@
         </p:nvSpPr>
         <p:spPr>
           <a:xfrm>
-            <a:off x="1115568" y="3794760"/>
-            <a:ext cx="3383280" cy="283464"/>
+            <a:off x="1115568" y="3566160"/>
+            <a:ext cx="3383280" cy="256032"/>
           </a:xfrm>
           <a:prstGeom prst="rect">
             <a:avLst/>
@@ -11284,8 +11294,8 @@
         </p:nvSpPr>
         <p:spPr>
           <a:xfrm>
-            <a:off x="457200" y="4099560"/>
-            <a:ext cx="548640" cy="283464"/>
+            <a:off x="457200" y="3845560"/>
+            <a:ext cx="548640" cy="256032"/>
           </a:xfrm>
           <a:prstGeom prst="roundRect">
             <a:avLst>
@@ -11332,8 +11342,8 @@
         </p:nvSpPr>
         <p:spPr>
           <a:xfrm>
-            <a:off x="457200" y="4099560"/>
-            <a:ext cx="548640" cy="283464"/>
+            <a:off x="457200" y="3845560"/>
+            <a:ext cx="548640" cy="256032"/>
           </a:xfrm>
           <a:prstGeom prst="rect">
             <a:avLst/>
@@ -11366,8 +11376,8 @@
         </p:nvSpPr>
         <p:spPr>
           <a:xfrm>
-            <a:off x="1115568" y="4099560"/>
-            <a:ext cx="3383280" cy="283464"/>
+            <a:off x="1115568" y="3845560"/>
+            <a:ext cx="3383280" cy="256032"/>
           </a:xfrm>
           <a:prstGeom prst="rect">
             <a:avLst/>
@@ -11399,8 +11409,8 @@
         </p:nvSpPr>
         <p:spPr>
           <a:xfrm>
-            <a:off x="457200" y="4404360"/>
-            <a:ext cx="548640" cy="283464"/>
+            <a:off x="457200" y="4124960"/>
+            <a:ext cx="548640" cy="256032"/>
           </a:xfrm>
           <a:prstGeom prst="roundRect">
             <a:avLst>
@@ -11447,8 +11457,8 @@
         </p:nvSpPr>
         <p:spPr>
           <a:xfrm>
-            <a:off x="457200" y="4404360"/>
-            <a:ext cx="548640" cy="283464"/>
+            <a:off x="457200" y="4124960"/>
+            <a:ext cx="548640" cy="256032"/>
           </a:xfrm>
           <a:prstGeom prst="rect">
             <a:avLst/>
@@ -11481,8 +11491,8 @@
         </p:nvSpPr>
         <p:spPr>
           <a:xfrm>
-            <a:off x="1115568" y="4404360"/>
-            <a:ext cx="3383280" cy="283464"/>
+            <a:off x="1115568" y="4124960"/>
+            <a:ext cx="3383280" cy="256032"/>
           </a:xfrm>
           <a:prstGeom prst="rect">
             <a:avLst/>
@@ -11514,8 +11524,8 @@
         </p:nvSpPr>
         <p:spPr>
           <a:xfrm>
-            <a:off x="4663440" y="1051560"/>
-            <a:ext cx="548640" cy="283464"/>
+            <a:off x="457200" y="4404360"/>
+            <a:ext cx="548640" cy="256032"/>
           </a:xfrm>
           <a:prstGeom prst="roundRect">
             <a:avLst>
@@ -11562,8 +11572,8 @@
         </p:nvSpPr>
         <p:spPr>
           <a:xfrm>
-            <a:off x="4663440" y="1051560"/>
-            <a:ext cx="548640" cy="283464"/>
+            <a:off x="457200" y="4404360"/>
+            <a:ext cx="548640" cy="256032"/>
           </a:xfrm>
           <a:prstGeom prst="rect">
             <a:avLst/>
@@ -11596,8 +11606,8 @@
         </p:nvSpPr>
         <p:spPr>
           <a:xfrm>
-            <a:off x="5321807" y="1051560"/>
-            <a:ext cx="3566160" cy="283464"/>
+            <a:off x="1115568" y="4404360"/>
+            <a:ext cx="3383280" cy="256032"/>
           </a:xfrm>
           <a:prstGeom prst="rect">
             <a:avLst/>
@@ -11629,8 +11639,8 @@
         </p:nvSpPr>
         <p:spPr>
           <a:xfrm>
-            <a:off x="4663440" y="1356360"/>
-            <a:ext cx="548640" cy="283464"/>
+            <a:off x="4663440" y="1051560"/>
+            <a:ext cx="548640" cy="256032"/>
           </a:xfrm>
           <a:prstGeom prst="roundRect">
             <a:avLst>
@@ -11677,8 +11687,8 @@
         </p:nvSpPr>
         <p:spPr>
           <a:xfrm>
-            <a:off x="4663440" y="1356360"/>
-            <a:ext cx="548640" cy="283464"/>
+            <a:off x="4663440" y="1051560"/>
+            <a:ext cx="548640" cy="256032"/>
           </a:xfrm>
           <a:prstGeom prst="rect">
             <a:avLst/>
@@ -11711,8 +11721,8 @@
         </p:nvSpPr>
         <p:spPr>
           <a:xfrm>
-            <a:off x="5321807" y="1356360"/>
-            <a:ext cx="3566160" cy="283464"/>
+            <a:off x="5321807" y="1051560"/>
+            <a:ext cx="3566160" cy="256032"/>
           </a:xfrm>
           <a:prstGeom prst="rect">
             <a:avLst/>
@@ -11744,8 +11754,8 @@
         </p:nvSpPr>
         <p:spPr>
           <a:xfrm>
-            <a:off x="4663440" y="1661160"/>
-            <a:ext cx="548640" cy="283464"/>
+            <a:off x="4663440" y="1330960"/>
+            <a:ext cx="548640" cy="256032"/>
           </a:xfrm>
           <a:prstGeom prst="roundRect">
             <a:avLst>
@@ -11792,8 +11802,8 @@
         </p:nvSpPr>
         <p:spPr>
           <a:xfrm>
-            <a:off x="4663440" y="1661160"/>
-            <a:ext cx="548640" cy="283464"/>
+            <a:off x="4663440" y="1330960"/>
+            <a:ext cx="548640" cy="256032"/>
           </a:xfrm>
           <a:prstGeom prst="rect">
             <a:avLst/>
@@ -11826,8 +11836,8 @@
         </p:nvSpPr>
         <p:spPr>
           <a:xfrm>
-            <a:off x="5321807" y="1661160"/>
-            <a:ext cx="3566160" cy="283464"/>
+            <a:off x="5321807" y="1330960"/>
+            <a:ext cx="3566160" cy="256032"/>
           </a:xfrm>
           <a:prstGeom prst="rect">
             <a:avLst/>
@@ -11859,8 +11869,8 @@
         </p:nvSpPr>
         <p:spPr>
           <a:xfrm>
-            <a:off x="4663440" y="1965960"/>
-            <a:ext cx="548640" cy="283464"/>
+            <a:off x="4663440" y="1610360"/>
+            <a:ext cx="548640" cy="256032"/>
           </a:xfrm>
           <a:prstGeom prst="roundRect">
             <a:avLst>
@@ -11907,8 +11917,8 @@
         </p:nvSpPr>
         <p:spPr>
           <a:xfrm>
-            <a:off x="4663440" y="1965960"/>
-            <a:ext cx="548640" cy="283464"/>
+            <a:off x="4663440" y="1610360"/>
+            <a:ext cx="548640" cy="256032"/>
           </a:xfrm>
           <a:prstGeom prst="rect">
             <a:avLst/>
@@ -11941,8 +11951,8 @@
         </p:nvSpPr>
         <p:spPr>
           <a:xfrm>
-            <a:off x="5321807" y="1965960"/>
-            <a:ext cx="3566160" cy="283464"/>
+            <a:off x="5321807" y="1610360"/>
+            <a:ext cx="3566160" cy="256032"/>
           </a:xfrm>
           <a:prstGeom prst="rect">
             <a:avLst/>
@@ -11974,8 +11984,8 @@
         </p:nvSpPr>
         <p:spPr>
           <a:xfrm>
-            <a:off x="4663440" y="2270760"/>
-            <a:ext cx="548640" cy="283464"/>
+            <a:off x="4663440" y="1889760"/>
+            <a:ext cx="548640" cy="256032"/>
           </a:xfrm>
           <a:prstGeom prst="roundRect">
             <a:avLst>
@@ -12022,8 +12032,8 @@
         </p:nvSpPr>
         <p:spPr>
           <a:xfrm>
-            <a:off x="4663440" y="2270760"/>
-            <a:ext cx="548640" cy="283464"/>
+            <a:off x="4663440" y="1889760"/>
+            <a:ext cx="548640" cy="256032"/>
           </a:xfrm>
           <a:prstGeom prst="rect">
             <a:avLst/>
@@ -12056,8 +12066,8 @@
         </p:nvSpPr>
         <p:spPr>
           <a:xfrm>
-            <a:off x="5321807" y="2270760"/>
-            <a:ext cx="3566160" cy="283464"/>
+            <a:off x="5321807" y="1889760"/>
+            <a:ext cx="3566160" cy="256032"/>
           </a:xfrm>
           <a:prstGeom prst="rect">
             <a:avLst/>
@@ -12089,8 +12099,8 @@
         </p:nvSpPr>
         <p:spPr>
           <a:xfrm>
-            <a:off x="4663440" y="2575560"/>
-            <a:ext cx="548640" cy="283464"/>
+            <a:off x="4663440" y="2169160"/>
+            <a:ext cx="548640" cy="256032"/>
           </a:xfrm>
           <a:prstGeom prst="roundRect">
             <a:avLst>
@@ -12137,8 +12147,8 @@
         </p:nvSpPr>
         <p:spPr>
           <a:xfrm>
-            <a:off x="4663440" y="2575560"/>
-            <a:ext cx="548640" cy="283464"/>
+            <a:off x="4663440" y="2169160"/>
+            <a:ext cx="548640" cy="256032"/>
           </a:xfrm>
           <a:prstGeom prst="rect">
             <a:avLst/>
@@ -12171,8 +12181,8 @@
         </p:nvSpPr>
         <p:spPr>
           <a:xfrm>
-            <a:off x="5321807" y="2575560"/>
-            <a:ext cx="3566160" cy="283464"/>
+            <a:off x="5321807" y="2169160"/>
+            <a:ext cx="3566160" cy="256032"/>
           </a:xfrm>
           <a:prstGeom prst="rect">
             <a:avLst/>
@@ -12204,8 +12214,8 @@
         </p:nvSpPr>
         <p:spPr>
           <a:xfrm>
-            <a:off x="4663440" y="2880360"/>
-            <a:ext cx="548640" cy="283464"/>
+            <a:off x="4663440" y="2448560"/>
+            <a:ext cx="548640" cy="256032"/>
           </a:xfrm>
           <a:prstGeom prst="roundRect">
             <a:avLst>
@@ -12252,8 +12262,8 @@
         </p:nvSpPr>
         <p:spPr>
           <a:xfrm>
-            <a:off x="4663440" y="2880360"/>
-            <a:ext cx="548640" cy="283464"/>
+            <a:off x="4663440" y="2448560"/>
+            <a:ext cx="548640" cy="256032"/>
           </a:xfrm>
           <a:prstGeom prst="rect">
             <a:avLst/>
@@ -12286,8 +12296,8 @@
         </p:nvSpPr>
         <p:spPr>
           <a:xfrm>
-            <a:off x="5321807" y="2880360"/>
-            <a:ext cx="3566160" cy="283464"/>
+            <a:off x="5321807" y="2448560"/>
+            <a:ext cx="3566160" cy="256032"/>
           </a:xfrm>
           <a:prstGeom prst="rect">
             <a:avLst/>
@@ -12319,8 +12329,8 @@
         </p:nvSpPr>
         <p:spPr>
           <a:xfrm>
-            <a:off x="4663440" y="3185160"/>
-            <a:ext cx="548640" cy="283464"/>
+            <a:off x="4663440" y="2727960"/>
+            <a:ext cx="548640" cy="256032"/>
           </a:xfrm>
           <a:prstGeom prst="roundRect">
             <a:avLst>
@@ -12367,8 +12377,8 @@
         </p:nvSpPr>
         <p:spPr>
           <a:xfrm>
-            <a:off x="4663440" y="3185160"/>
-            <a:ext cx="548640" cy="283464"/>
+            <a:off x="4663440" y="2727960"/>
+            <a:ext cx="548640" cy="256032"/>
           </a:xfrm>
           <a:prstGeom prst="rect">
             <a:avLst/>
@@ -12401,8 +12411,8 @@
         </p:nvSpPr>
         <p:spPr>
           <a:xfrm>
-            <a:off x="5321807" y="3185160"/>
-            <a:ext cx="3566160" cy="283464"/>
+            <a:off x="5321807" y="2727960"/>
+            <a:ext cx="3566160" cy="256032"/>
           </a:xfrm>
           <a:prstGeom prst="rect">
             <a:avLst/>
@@ -12434,8 +12444,8 @@
         </p:nvSpPr>
         <p:spPr>
           <a:xfrm>
-            <a:off x="4663440" y="3489960"/>
-            <a:ext cx="548640" cy="283464"/>
+            <a:off x="4663440" y="3007360"/>
+            <a:ext cx="548640" cy="256032"/>
           </a:xfrm>
           <a:prstGeom prst="roundRect">
             <a:avLst>
@@ -12482,8 +12492,8 @@
         </p:nvSpPr>
         <p:spPr>
           <a:xfrm>
-            <a:off x="4663440" y="3489960"/>
-            <a:ext cx="548640" cy="283464"/>
+            <a:off x="4663440" y="3007360"/>
+            <a:ext cx="548640" cy="256032"/>
           </a:xfrm>
           <a:prstGeom prst="rect">
             <a:avLst/>
@@ -12516,8 +12526,8 @@
         </p:nvSpPr>
         <p:spPr>
           <a:xfrm>
-            <a:off x="5321807" y="3489960"/>
-            <a:ext cx="3566160" cy="283464"/>
+            <a:off x="5321807" y="3007360"/>
+            <a:ext cx="3566160" cy="256032"/>
           </a:xfrm>
           <a:prstGeom prst="rect">
             <a:avLst/>
@@ -12549,8 +12559,8 @@
         </p:nvSpPr>
         <p:spPr>
           <a:xfrm>
-            <a:off x="4663440" y="3794760"/>
-            <a:ext cx="548640" cy="283464"/>
+            <a:off x="4663440" y="3286760"/>
+            <a:ext cx="548640" cy="256032"/>
           </a:xfrm>
           <a:prstGeom prst="roundRect">
             <a:avLst>
@@ -12597,8 +12607,8 @@
         </p:nvSpPr>
         <p:spPr>
           <a:xfrm>
-            <a:off x="4663440" y="3794760"/>
-            <a:ext cx="548640" cy="283464"/>
+            <a:off x="4663440" y="3286760"/>
+            <a:ext cx="548640" cy="256032"/>
           </a:xfrm>
           <a:prstGeom prst="rect">
             <a:avLst/>
@@ -12631,8 +12641,8 @@
         </p:nvSpPr>
         <p:spPr>
           <a:xfrm>
-            <a:off x="5321807" y="3794760"/>
-            <a:ext cx="3566160" cy="283464"/>
+            <a:off x="5321807" y="3286760"/>
+            <a:ext cx="3566160" cy="256032"/>
           </a:xfrm>
           <a:prstGeom prst="rect">
             <a:avLst/>
@@ -12664,8 +12674,8 @@
         </p:nvSpPr>
         <p:spPr>
           <a:xfrm>
-            <a:off x="4663440" y="4099560"/>
-            <a:ext cx="548640" cy="283464"/>
+            <a:off x="4663440" y="3566160"/>
+            <a:ext cx="548640" cy="256032"/>
           </a:xfrm>
           <a:prstGeom prst="roundRect">
             <a:avLst>
@@ -12712,8 +12722,8 @@
         </p:nvSpPr>
         <p:spPr>
           <a:xfrm>
-            <a:off x="4663440" y="4099560"/>
-            <a:ext cx="548640" cy="283464"/>
+            <a:off x="4663440" y="3566160"/>
+            <a:ext cx="548640" cy="256032"/>
           </a:xfrm>
           <a:prstGeom prst="rect">
             <a:avLst/>
@@ -12746,8 +12756,8 @@
         </p:nvSpPr>
         <p:spPr>
           <a:xfrm>
-            <a:off x="5321807" y="4099560"/>
-            <a:ext cx="3566160" cy="283464"/>
+            <a:off x="5321807" y="3566160"/>
+            <a:ext cx="3566160" cy="256032"/>
           </a:xfrm>
           <a:prstGeom prst="rect">
             <a:avLst/>
@@ -12779,8 +12789,8 @@
         </p:nvSpPr>
         <p:spPr>
           <a:xfrm>
-            <a:off x="4663440" y="4404360"/>
-            <a:ext cx="548640" cy="283464"/>
+            <a:off x="4663440" y="3845560"/>
+            <a:ext cx="548640" cy="256032"/>
           </a:xfrm>
           <a:prstGeom prst="roundRect">
             <a:avLst>
@@ -12827,8 +12837,8 @@
         </p:nvSpPr>
         <p:spPr>
           <a:xfrm>
-            <a:off x="4663440" y="4404360"/>
-            <a:ext cx="548640" cy="283464"/>
+            <a:off x="4663440" y="3845560"/>
+            <a:ext cx="548640" cy="256032"/>
           </a:xfrm>
           <a:prstGeom prst="rect">
             <a:avLst/>
@@ -12861,8 +12871,8 @@
         </p:nvSpPr>
         <p:spPr>
           <a:xfrm>
-            <a:off x="5321807" y="4404360"/>
-            <a:ext cx="3566160" cy="283464"/>
+            <a:off x="5321807" y="3845560"/>
+            <a:ext cx="3566160" cy="256032"/>
           </a:xfrm>
           <a:prstGeom prst="rect">
             <a:avLst/>
@@ -12882,6 +12892,236 @@
                 </a:solidFill>
               </a:rPr>
               <a:t>Sistema de diseño de la interfaz</a:t>
+            </a:r>
+          </a:p>
+        </p:txBody>
+      </p:sp>
+      <p:sp>
+        <p:nvSpPr>
+          <p:cNvPr id="200" name="Etiqueta"/>
+          <p:cNvSpPr/>
+          <p:nvPr/>
+        </p:nvSpPr>
+        <p:spPr>
+          <a:xfrm>
+            <a:off x="4663440" y="4124960"/>
+            <a:ext cx="548640" cy="256032"/>
+          </a:xfrm>
+          <a:prstGeom prst="roundRect">
+            <a:avLst>
+              <a:gd name="adj" fmla="val 17000"/>
+            </a:avLst>
+          </a:prstGeom>
+          <a:solidFill>
+            <a:schemeClr val="accent1"/>
+          </a:solidFill>
+          <a:ln w="12700">
+            <a:solidFill>
+              <a:schemeClr val="accent1"/>
+            </a:solidFill>
+          </a:ln>
+          <a:effectLst/>
+        </p:spPr>
+        <p:style>
+          <a:lnRef idx="1">
+            <a:schemeClr val="accent1"/>
+          </a:lnRef>
+          <a:fillRef idx="3">
+            <a:schemeClr val="accent1"/>
+          </a:fillRef>
+          <a:effectRef idx="2">
+            <a:schemeClr val="accent1"/>
+          </a:effectRef>
+          <a:fontRef idx="minor">
+            <a:schemeClr val="lt1"/>
+          </a:fontRef>
+        </p:style>
+        <p:txBody>
+          <a:bodyPr rtlCol="0" anchor="ctr"/>
+          <a:lstStyle/>
+          <a:p>
+            <a:pPr algn="ctr"/>
+          </a:p>
+        </p:txBody>
+      </p:sp>
+      <p:sp>
+        <p:nvSpPr>
+          <p:cNvPr id="201" name="TextBox 81"/>
+          <p:cNvSpPr txBox="1"/>
+          <p:nvPr/>
+        </p:nvSpPr>
+        <p:spPr>
+          <a:xfrm>
+            <a:off x="4663440" y="4124960"/>
+            <a:ext cx="548640" cy="256032"/>
+          </a:xfrm>
+          <a:prstGeom prst="rect">
+            <a:avLst/>
+          </a:prstGeom>
+          <a:noFill/>
+        </p:spPr>
+        <p:txBody>
+          <a:bodyPr wrap="square" lIns="0" rIns="0" tIns="0" bIns="0" anchor="ctr">
+            <a:spAutoFit/>
+          </a:bodyPr>
+          <a:lstStyle/>
+          <a:p>
+            <a:pPr algn="ctr"/>
+            <a:r>
+              <a:rPr sz="1200" b="1">
+                <a:solidFill>
+                  <a:schemeClr val="bg1"/>
+                </a:solidFill>
+              </a:rPr>
+              <a:t>025</a:t>
+            </a:r>
+          </a:p>
+        </p:txBody>
+      </p:sp>
+      <p:sp>
+        <p:nvSpPr>
+          <p:cNvPr id="202" name="TextBox 82"/>
+          <p:cNvSpPr txBox="1"/>
+          <p:nvPr/>
+        </p:nvSpPr>
+        <p:spPr>
+          <a:xfrm>
+            <a:off x="5321807" y="4124960"/>
+            <a:ext cx="3566160" cy="256032"/>
+          </a:xfrm>
+          <a:prstGeom prst="rect">
+            <a:avLst/>
+          </a:prstGeom>
+          <a:noFill/>
+        </p:spPr>
+        <p:txBody>
+          <a:bodyPr wrap="square" lIns="0" rIns="0" tIns="0" bIns="0" anchor="ctr">
+            <a:spAutoFit/>
+          </a:bodyPr>
+          <a:lstStyle/>
+          <a:p>
+            <a:r>
+              <a:rPr sz="1300" b="0">
+                <a:solidFill>
+                  <a:schemeClr val="tx1"/>
+                </a:solidFill>
+              </a:rPr>
+              <a:t>NIF del socio y cruce socio–tercero</a:t>
+            </a:r>
+          </a:p>
+        </p:txBody>
+      </p:sp>
+      <p:sp>
+        <p:nvSpPr>
+          <p:cNvPr id="203" name="Etiqueta"/>
+          <p:cNvSpPr/>
+          <p:nvPr/>
+        </p:nvSpPr>
+        <p:spPr>
+          <a:xfrm>
+            <a:off x="4663440" y="4404360"/>
+            <a:ext cx="548640" cy="256032"/>
+          </a:xfrm>
+          <a:prstGeom prst="roundRect">
+            <a:avLst>
+              <a:gd name="adj" fmla="val 17000"/>
+            </a:avLst>
+          </a:prstGeom>
+          <a:solidFill>
+            <a:schemeClr val="accent1"/>
+          </a:solidFill>
+          <a:ln w="12700">
+            <a:solidFill>
+              <a:schemeClr val="accent1"/>
+            </a:solidFill>
+          </a:ln>
+          <a:effectLst/>
+        </p:spPr>
+        <p:style>
+          <a:lnRef idx="1">
+            <a:schemeClr val="accent1"/>
+          </a:lnRef>
+          <a:fillRef idx="3">
+            <a:schemeClr val="accent1"/>
+          </a:fillRef>
+          <a:effectRef idx="2">
+            <a:schemeClr val="accent1"/>
+          </a:effectRef>
+          <a:fontRef idx="minor">
+            <a:schemeClr val="lt1"/>
+          </a:fontRef>
+        </p:style>
+        <p:txBody>
+          <a:bodyPr rtlCol="0" anchor="ctr"/>
+          <a:lstStyle/>
+          <a:p>
+            <a:pPr algn="ctr"/>
+          </a:p>
+        </p:txBody>
+      </p:sp>
+      <p:sp>
+        <p:nvSpPr>
+          <p:cNvPr id="204" name="TextBox 81"/>
+          <p:cNvSpPr txBox="1"/>
+          <p:nvPr/>
+        </p:nvSpPr>
+        <p:spPr>
+          <a:xfrm>
+            <a:off x="4663440" y="4404360"/>
+            <a:ext cx="548640" cy="256032"/>
+          </a:xfrm>
+          <a:prstGeom prst="rect">
+            <a:avLst/>
+          </a:prstGeom>
+          <a:noFill/>
+        </p:spPr>
+        <p:txBody>
+          <a:bodyPr wrap="square" lIns="0" rIns="0" tIns="0" bIns="0" anchor="ctr">
+            <a:spAutoFit/>
+          </a:bodyPr>
+          <a:lstStyle/>
+          <a:p>
+            <a:pPr algn="ctr"/>
+            <a:r>
+              <a:rPr sz="1200" b="1">
+                <a:solidFill>
+                  <a:schemeClr val="bg1"/>
+                </a:solidFill>
+              </a:rPr>
+              <a:t>026</a:t>
+            </a:r>
+          </a:p>
+        </p:txBody>
+      </p:sp>
+      <p:sp>
+        <p:nvSpPr>
+          <p:cNvPr id="205" name="TextBox 82"/>
+          <p:cNvSpPr txBox="1"/>
+          <p:nvPr/>
+        </p:nvSpPr>
+        <p:spPr>
+          <a:xfrm>
+            <a:off x="5321807" y="4404360"/>
+            <a:ext cx="3566160" cy="256032"/>
+          </a:xfrm>
+          <a:prstGeom prst="rect">
+            <a:avLst/>
+          </a:prstGeom>
+          <a:noFill/>
+        </p:spPr>
+        <p:txBody>
+          <a:bodyPr wrap="square" lIns="0" rIns="0" tIns="0" bIns="0" anchor="ctr">
+            <a:spAutoFit/>
+          </a:bodyPr>
+          <a:lstStyle/>
+          <a:p>
+            <a:r>
+              <a:rPr sz="1300" b="0">
+                <a:solidFill>
+                  <a:schemeClr val="tx1"/>
+                </a:solidFill>
+              </a:rPr>
+              <a:t>Gemini para el asistente de la demo</a:t>
             </a:r>
           </a:p>
         </p:txBody>
@@ -13887,7 +14127,7 @@
                   <a:schemeClr val="tx1"/>
                 </a:solidFill>
               </a:rPr>
-              <a:t>Ollama en el servidor propio (qwen3:4b-instruct); modelo elegible por cooperativa, o proveedor externo con su clave</a:t>
+              <a:t>Ollama en el servidor propio (qwen3:4b-instruct) por defecto; Gemini Flash-Lite en la demo publicada (ADR-026); modelo elegible por cooperativa o proveedor externo</a:t>
             </a:r>
           </a:p>
         </p:txBody>
@@ -14001,7 +14241,7 @@
                   <a:schemeClr val="tx1"/>
                 </a:solidFill>
               </a:rPr>
-              <a:t>pgvector filtrado por cooperativa; herramientas de solo lectura con los permisos del usuario</a:t>
+              <a:t>18 herramientas de solo lectura con los permisos del usuario: facturación agregada en BD, socios y cruce socio–tercero por NIF; cifras citadas</a:t>
             </a:r>
           </a:p>
         </p:txBody>
@@ -14262,7 +14502,7 @@
                   <a:schemeClr val="accent6"/>
                 </a:solidFill>
               </a:rPr>
-              <a:t>Embeddings locales con bge-m3 (Ollama) · Gemini solo para visión y explicaciones</a:t>
+              <a:t>Embeddings locales con bge-m3 (Ollama) · Gemini para visión, explicaciones y el asistente de la demo</a:t>
             </a:r>
           </a:p>
         </p:txBody>

</xml_diff>

<commit_message>
docs(slides): lesson on learning the whole stack coming from native iOS, replaces the credit-card lesson
Co-Authored-By: Claude Opus 5.5 <noreply@anthropic.com>
</commit_message>
<xml_diff>
--- a/docs/slides/multicooperativa-tfm.pptx
+++ b/docs/slides/multicooperativa-tfm.pptx
@@ -2697,7 +2697,7 @@
                   <a:schemeClr val="accent2"/>
                 </a:solidFill>
               </a:rPr>
-              <a:t>244 / 245</a:t>
+              <a:t>245 / 246</a:t>
             </a:r>
           </a:p>
         </p:txBody>
@@ -5728,7 +5728,7 @@
                   <a:schemeClr val="tx1"/>
                 </a:solidFill>
               </a:rPr>
-              <a:t>Sin tarjeta no hay nube gratuita: servidor propio con Cloudflare Tunnel</a:t>
+              <a:t>Desde casi 15 años de iOS nativo: aprendizaje de todo el stack, de Docker al backend, la base de datos y la IA</a:t>
             </a:r>
           </a:p>
           <a:p>

</xml_diff>

<commit_message>
docs(slides): lesson on extending the official AI master's degree (UNIR) to AI-driven development
Co-Authored-By: Claude Opus 5.5 <noreply@anthropic.com>
</commit_message>
<xml_diff>
--- a/docs/slides/multicooperativa-tfm.pptx
+++ b/docs/slides/multicooperativa-tfm.pptx
@@ -2697,7 +2697,7 @@
                   <a:schemeClr val="accent2"/>
                 </a:solidFill>
               </a:rPr>
-              <a:t>245 / 246</a:t>
+              <a:t>246 / 247</a:t>
             </a:r>
           </a:p>
         </p:txBody>
@@ -5745,7 +5745,7 @@
                   <a:schemeClr val="tx1"/>
                 </a:solidFill>
               </a:rPr>
-              <a:t>La cuota de Gemini llevó al modelo local; en el servidor, la CPU lo hizo inviable (&gt;30 s) y la demo volvió a Gemini</a:t>
+              <a:t>Tras el Máster oficial en IA de UNIR, este máster amplió ese conocimiento al desarrollo con IA</a:t>
             </a:r>
           </a:p>
           <a:p>
@@ -5762,7 +5762,7 @@
                   <a:schemeClr val="tx1"/>
                 </a:solidFill>
               </a:rPr>
-              <a:t>Latencia en CPU medida: el 4b es más rápido; el 8b, algo más preciso</a:t>
+              <a:t>La cuota de Gemini llevó al modelo local; en el servidor, la CPU lo hizo inviable (&gt;30 s) y la demo volvió a Gemini</a:t>
             </a:r>
           </a:p>
           <a:p>
@@ -5779,7 +5779,7 @@
                   <a:schemeClr val="tx1"/>
                 </a:solidFill>
               </a:rPr>
-              <a:t>Agentes en paralelo exigen disciplina de integración</a:t>
+              <a:t>Latencia en CPU medida: el 4b es más rápido; el 8b, algo más preciso</a:t>
             </a:r>
           </a:p>
           <a:p>
@@ -5796,7 +5796,7 @@
                   <a:schemeClr val="tx1"/>
                 </a:solidFill>
               </a:rPr>
-              <a:t>La evaluación offline no basta: medir con el modelo real (32/60 → 47/60 tras ajustar)</a:t>
+              <a:t>Agentes en paralelo exigen disciplina de integración</a:t>
             </a:r>
           </a:p>
           <a:p>
@@ -5813,7 +5813,7 @@
                   <a:schemeClr val="tx1"/>
                 </a:solidFill>
               </a:rPr>
-              <a:t>Especificar primero, CLAUDE.md y ESLint protegen la arquitectura</a:t>
+              <a:t>Evaluar con el modelo real, no solo offline (32/60 → 47/60)</a:t>
             </a:r>
           </a:p>
           <a:p>
@@ -5830,7 +5830,24 @@
                   <a:schemeClr val="tx1"/>
                 </a:solidFill>
               </a:rPr>
-              <a:t>Un diseño generado con IA se adopta mejor con un análisis de brechas antes de migrar</a:t>
+              <a:t>Especificar primero, CLAUDE.md y ESLint protegen la arquitectura</a:t>
+            </a:r>
+          </a:p>
+          <a:p>
+            <a:pPr marL="228600" indent="-228600">
+              <a:spcAft>
+                <a:spcPts val="500"/>
+              </a:spcAft>
+              <a:buSzPct val="100000"/>
+              <a:buChar char="•"/>
+            </a:pPr>
+            <a:r>
+              <a:rPr sz="1300" b="0">
+                <a:solidFill>
+                  <a:schemeClr val="tx1"/>
+                </a:solidFill>
+              </a:rPr>
+              <a:t>Diseño generado con IA: análisis de brechas antes de migrar</a:t>
             </a:r>
           </a:p>
         </p:txBody>

</xml_diff>

<commit_message>
docs(slides): files and validation card, assistant local or hosted, Maestro delivered locally, notes refreshed to current facts
Co-Authored-By: Claude Opus 5.5 <noreply@anthropic.com>
</commit_message>
<xml_diff>
--- a/docs/slides/multicooperativa-tfm.pptx
+++ b/docs/slides/multicooperativa-tfm.pptx
@@ -778,7 +778,7 @@
           <a:lstStyle/>
           <a:p>
             <a:r>
-              <a:t>Los números, medidos el 22 de octubre ejecutando pnpm test y pnpm test:integration: 1148 tests unitarios en 112 ficheros (832 de la API, 295 de la app y 21 de contratos) y 523 tests de integración en 27 ficheros, todos en verde. Los de integración corren contra PostgreSQL y S3 reales, e incluyen el aislamiento entre cooperativas. Husky ejecuta lint, typecheck y tests en el pre-commit, y la CI de GitHub Actions comprueba formato, lint, tipos, tests, migraciones e integración. A la derecha, el benchmark de modelos locales para el asistente, sobre el conjunto de evaluación de entonces, 22 preguntas, medido en un Mac con 12 CPU y sin GPU: qwen3:8b acierta 19, qwen3:4b-instruct 18, gemma4:e4b 15, llama3.2:3b 7, qwen2.5:3b 5 y phi4-mini 4. Hoy el conjunto tiene 23 preguntas. El servidor lleva qwen3:4b-instruct por defecto: pierde una pregunta frente al 8b pero responde más rápido en esa CPU; esa rapidez en el servidor la ha comprobado el autor, no se ha medido con el conjunto de evaluación.</a:t>
+              <a:t>Los números, medidos el 23 de octubre ejecutando pnpm test y pnpm test:integration: 1504 tests unitarios en 136 ficheros (API, app, contratos y reglas de ESLint) y 611 tests de integración en 32 ficheros, todos en verde. Los de integración corren contra PostgreSQL y S3 reales, e incluyen el aislamiento entre cooperativas. Husky ejecuta lint, typecheck y tests en el pre-commit, y la CI de GitHub Actions comprueba formato, lint, tipos, tests, migraciones e integración. A la derecha, el benchmark de modelos locales para el asistente, sobre el conjunto de evaluación de entonces, 22 preguntas, medido en un Mac con 12 CPU y sin GPU: qwen3:8b acierta 19, qwen3:4b-instruct 18, gemma4:e4b 15, llama3.2:3b 7, qwen2.5:3b 5 y phi4-mini 4. Hoy el conjunto de evaluación tiene 60 preguntas: qwen3:4b-instruct acierta 47 y Gemini Flash-Lite, el modelo de la demo publicada, 53. El servidor lleva qwen3:4b-instruct por defecto: pierde una pregunta frente al 8b pero responde más rápido en esa CPU; esa rapidez en el servidor la ha comprobado el autor, no se ha medido con el conjunto de evaluación.</a:t>
             </a:r>
           </a:p>
         </p:txBody>
@@ -864,7 +864,7 @@
           <a:lstStyle/>
           <a:p>
             <a:r>
-              <a:t>La demo cuesta 0 euros. El plan inicial era Render, Neon y Supabase, pero en octubre descubrí que Render y Railway piden tarjeta de crédito y no tengo, así que mover la API a un servidor propio fue la decisión del ADR-012. Es un Windows de casa con Docker Desktop, un i5-10500 y 32 GB de RAM, que ejecuta el mismo stack que el desarrollo: la API, PostgreSQL con pgvector, RustFS como almacenamiento S3 y Ollama con el modelo del asistente y los embeddings. Solo la API sale a internet, por un Cloudflare Tunnel con conexión de salida, sin abrir puertos en el router, en api-cooperativa.chaparro2001.com; los ficheros se sirven con URLs firmadas por files-cooperativa. La app web está en GitHub Pages con dominio propio, cooperativa.chaparro2001.com, ADR-017. Un cron de GitHub Actions llama cada hora al proceso de vencimientos. Gemini solo se usa para la visión y las explicaciones. Los límites: solo responde con el servidor encendido, no hay copias de seguridad y no hay que subir datos reales. La alternativa en la nube con Neon, Supabase y Render sigue documentada.</a:t>
+              <a:t>La demo cuesta 0 euros. El plan inicial era Render, Neon y Supabase, pero en octubre descubrí que Render y Railway piden tarjeta de crédito y no tengo, así que mover la API a un servidor propio fue la decisión del ADR-012. Es un Windows de casa con Docker Desktop, un i5-10500 y 32 GB de RAM, que ejecuta el mismo stack que el desarrollo: la API, PostgreSQL con pgvector, RustFS como almacenamiento S3 y Ollama con el modelo local del asistente y los embeddings. Solo la API sale a internet, por un Cloudflare Tunnel con conexión de salida, sin abrir puertos en el router, en api-cooperativa.chaparro2001.com; los ficheros se sirven con URLs firmadas por files-cooperativa. La app web está en GitHub Pages con dominio propio, cooperativa.chaparro2001.com, ADR-017. Un cron de GitHub Actions llama cada hora al proceso de vencimientos. Gemini se usa para la visión, las explicaciones y, en la demo publicada, el asistente (ADR-026), porque el modelo local era demasiado lento en esa CPU. Los límites: solo responde con el servidor encendido, no hay copias de seguridad y no hay que subir datos reales. La alternativa en la nube con Neon, Supabase y Render sigue documentada.</a:t>
             </a:r>
           </a:p>
         </p:txBody>
@@ -950,7 +950,7 @@
           <a:lstStyle/>
           <a:p>
             <a:r>
-              <a:t>Aquí enseño la demo en directo o en vídeo, en https://cooperativa.chaparro2001.com. La contraseña de la demo se completa antes de la entrega. Conviene hacer una pregunta al asistente un par de minutos antes para que el modelo local esté cargado en memoria. Hay un usuario por perfil en la Cooperativa Agrícola San Isidro: el socio, que ve comunicados, documentos, asamblea y voto, su capital y el asistente; el gestor, que registra facturas, escanea con IA y revisa discrepancias; el consejo, que publica comunicados y vigila pagos y cobros; y el administrador, que invita miembros con un enlace y personaliza la apariencia y el modelo del asistente; en Ajustes, Apariencia, se ve el aspecto Material Design de la app y cómo el color de la cooperativa llega a los chips y a las opciones seleccionadas. Lucía pertenece a dos cooperativas con perfil distinto en cada una, y sirve para ver el selector de cooperativa. Usar solo facturas ficticias: la capa gratuita de Gemini puede usar el contenido.</a:t>
+              <a:t>Aquí enseño la demo en directo o en vídeo, en https://cooperativa.chaparro2001.com. La contraseña de la demo se completa antes de la entrega. El asistente de la demo usa Gemini Flash-Lite (ADR-026): conviene no gastar la cuota diaria de Gemini antes de presentar y comprobar que las cooperativas están en "Modelo del servidor". Hay un usuario por perfil en la Cooperativa Agrícola San Isidro: el socio, que ve comunicados, documentos, asamblea y voto, su capital y el asistente; el gestor, que registra facturas, escanea con IA y revisa discrepancias; el consejo, que publica comunicados y vigila pagos y cobros; y el administrador, que invita miembros con un enlace y personaliza la apariencia y el modelo del asistente; en Ajustes, Apariencia, se ve el aspecto Material Design de la app y cómo el color de la cooperativa llega a los chips y a las opciones seleccionadas. Lucía pertenece a dos cooperativas con perfil distinto en cada una, y sirve para ver el selector de cooperativa. Usar solo facturas ficticias: la capa gratuita de Gemini puede usar el contenido.</a:t>
             </a:r>
           </a:p>
         </p:txBody>
@@ -1036,7 +1036,7 @@
           <a:lstStyle/>
           <a:p>
             <a:r>
-              <a:t>REVISAR: estas lecciones están redactadas a partir de lo que consta en el repositorio; el autor debe personalizarlas con su experiencia. Lecciones: uno, sin tarjeta de crédito no hay nube gratuita que sirva: Render y Railway la pedían, y acabé con un servidor propio y Cloudflare Tunnel. Dos, la cuota gratuita de Gemini, unas 20 peticiones al día en los modelos Flash y de dos a tres llamadas por pregunta, no aguanta a varios evaluadores: por eso el asistente usa un modelo local en Ollama. Tres, la latencia en CPU se midió: qwen3:4b-instruct responde más rápido y acierta 18 de 22 preguntas, frente a 19 del 8b, que es algo más preciso pero más lento. Cuatro, los agentes en paralelo con worktrees funcionan, pero exigen disciplina de integración: ramas pequeñas, tests y revisar cada fusión. Cinco, evaluar contra el modelo real encontró errores que los tests con simulaciones no veían. Seis, especificar primero y proteger la arquitectura con CLAUDE.md y ESLint redujo la ambigüedad con el agente. Trabajo futuro, lo que no está implementado: notificaciones push, Sentry, E2E con Maestro y reclamaciones de facturas; tampoco hay binarios nativos con EAS Build ni invitaciones por correo.</a:t>
+              <a:t>Lecciones. Uno: vengo de casi 15 años de iOS nativo, y este proyecto me ha obligado a aprender todo el stack, desde Docker hasta el backend, la base de datos y la IA. Dos: después de terminar el Máster oficial en IA de UNIR, este máster ha ampliado ese conocimiento hacia el desarrollo con IA. Tres: la cuota gratuita de Gemini me llevó a un modelo local, pero en el servidor la CPU lo hizo inviable, más de 30 segundos por pregunta, y la demo volvió a Gemini con Flash-Lite. Cuatro: la latencia en CPU se midió; el 4b es más rápido y el 8b, algo más preciso. Cinco: los agentes en paralelo exigen disciplina de integración. Seis: evaluar con el modelo real y no solo offline encontró errores que los tests con simulaciones no veían, y subió el acierto de 32 a 47 sobre 60. Siete: especificar primero, con CLAUDE.md y ESLint protegiendo la arquitectura, redujo la ambigüedad con el agente. Ocho: en el diseño generado con IA, el análisis de brechas antes de migrar evitó sorpresas. Trabajo futuro, lo que no está implementado: notificaciones push, Sentry, tests de componentes con React Native Testing Library y E2E en la integración continua (los flujos de Maestro existen, pero solo en local), y las reclamaciones de facturas; tampoco hay binarios nativos con EAS Build ni invitaciones por correo.</a:t>
             </a:r>
           </a:p>
         </p:txBody>
@@ -1122,7 +1122,7 @@
           <a:lstStyle/>
           <a:p>
             <a:r>
-              <a:t>Muchas gracias. El código, la documentación y los 21 ADR están en el repositorio de GitHub; la demo está en cooperativa.chaparro2001.com, la API en api-cooperativa.chaparro2001.com y el vídeo en el enlace de la diapositiva. Quedo a disposición del tribunal para preguntas.</a:t>
+              <a:t>Muchas gracias. El código, la documentación y los 26 ADR están en el repositorio de GitHub; la demo está en cooperativa.chaparro2001.com, la API en api-cooperativa.chaparro2001.com y el vídeo en el enlace de la diapositiva. Quedo a disposición del tribunal para preguntas.</a:t>
             </a:r>
           </a:p>
         </p:txBody>
@@ -1382,7 +1382,7 @@
           <a:lstStyle/>
           <a:p>
             <a:r>
-              <a:t>Esta es la foto honesta. Los siete módulos del MVP están implementados y funcionando: acceso y perfiles, con la administración de miembros y las invitaciones por enlace; comunicados; documentos con búsqueda semántica; asambleas con votación, quórum y mayorías; facturas y albaranes con captura, extracción por IA y explicación de discrepancias, con proveedores y clientes; el área del socio con su capital y aportaciones; y el asistente de IA con citas, historial de conversaciones y modelo local. Además, cada cooperativa puede personalizar su color. Lo que queda como trabajo futuro: notificaciones push, Sentry, pruebas E2E con Maestro, las reclamaciones de facturas, los binarios nativos con EAS Build y el envío de invitaciones por correo.</a:t>
+              <a:t>Esta es la foto honesta. Los siete módulos del MVP están implementados y funcionando: acceso y perfiles, con la administración de miembros y las invitaciones por enlace; comunicados; documentos con búsqueda semántica; asambleas con votación, quórum y mayorías; facturas y albaranes con captura, extracción por IA y explicación de discrepancias, con proveedores y clientes; el área del socio con su capital y aportaciones; y el asistente de IA con citas, historial de conversaciones y modelo local o externo. Además, cada cooperativa puede personalizar su color. Lo que queda como trabajo futuro: notificaciones push, Sentry, tests de componentes con React Native Testing Library y E2E en la integración continua (hay cuatro flujos de Maestro, pero solo en local, con el simulador de iOS y fuera de la CI), las reclamaciones de facturas, los binarios nativos con EAS Build y el envío de invitaciones por correo.</a:t>
             </a:r>
           </a:p>
         </p:txBody>
@@ -1468,7 +1468,7 @@
           <a:lstStyle/>
           <a:p>
             <a:r>
-              <a:t>La app Expo, que genera iOS, Android y web, con la interfaz en react-native-paper (Material Design 3), habla con una API REST en Node y TypeScript. El backend es un monolito modular con Clean Architecture: cada módulo tiene capas de dominio, aplicación e infraestructura y solo expone su index.ts. Los módulos no leen las tablas de otros; se comunican por su interfaz pública o por eventos internos, y una regla de ESLint propia lo hace cumplir. Hay ocho módulos: acceso, comunicados, documentos, asambleas, facturas, área del socio, asistente y marca. A la derecha están las dependencias: PostgreSQL con pgvector, almacenamiento compatible con S3 con URLs firmadas, Ollama en local para el asistente y los embeddings, Gemini solo para la visión y las explicaciones de discrepancias, y, de forma opcional, un proveedor externo de modelos que una cooperativa puede elegir con su propia clave. Todo ello corre en Docker en un servidor propio; solo la API sale a internet, a través de Cloudflare Tunnel.</a:t>
+              <a:t>La app Expo, que genera iOS, Android y web, con la interfaz en react-native-paper (Material Design 3), habla con una API REST en Node y TypeScript. El backend es un monolito modular con Clean Architecture: cada módulo tiene capas de dominio, aplicación e infraestructura y solo expone su index.ts. Los módulos no leen las tablas de otros; se comunican por su interfaz pública o por eventos internos, y una regla de ESLint propia lo hace cumplir. Hay ocho módulos: acceso, comunicados, documentos, asambleas, facturas, área del socio, asistente y marca. A la derecha están las dependencias: PostgreSQL con pgvector, almacenamiento compatible con S3 con URLs firmadas, Ollama en local para los embeddings y como asistente por defecto, Gemini para la visión, las explicaciones de discrepancias y el asistente de la demo publicada, y, de forma opcional, un proveedor externo de modelos que una cooperativa puede elegir con su propia clave. Todo ello corre en Docker en un servidor propio; solo la API sale a internet, a través de Cloudflare Tunnel.</a:t>
             </a:r>
           </a:p>
         </p:txBody>
@@ -1554,7 +1554,7 @@
           <a:lstStyle/>
           <a:p>
             <a:r>
-              <a:t>Cada decisión importante está en un ADR inmutable: si una decisión cambia, se escribe otro ADR. Hay 21. Las primeras, de la 001 a la 005, fijan la base: Expo, monolito modular, multi-cooperativa con base de datos compartida, permisos por perfil y almacenamiento S3 tras un puerto. El 007 elegía Claude para visión y fue sustituido por el 009, con Gemini. Las últimas cuentan lo que pasó al desplegar: la 012 mueve la API a un servidor propio con Cloudflare Tunnel porque Render y Railway pedían tarjeta; la 013 pasa el asistente a un modelo local en Ollama por la cuota de Gemini; la 014 deja elegir el modelo por cooperativa; la 015 fija qwen3:4b-instruct como modelo por defecto tras medir; la 016 entrega las invitaciones como enlace; la 017 pone dominio propio a la web; la 018 permite color por cooperativa (su parte de logo la retira la 021); la 019 deja que una cooperativa use un proveedor externo de modelos con su propia clave, cifrada en el servidor; la 020 migra la interfaz a react-native-paper (Material Design 3), con el tema generado a partir del color de cada cooperativa; y la 021, la última, elimina el logo por cooperativa: solo se veía tras iniciar sesión y la subida de ficheros no compensaba antes de la entrega.</a:t>
+              <a:t>Cada decisión importante está en un ADR inmutable: si una decisión cambia, se escribe otro ADR. Hay 26. Las primeras, de la 001 a la 005, fijan la base: Expo, monolito modular, multi-cooperativa con base de datos compartida, permisos por perfil y almacenamiento S3 tras un puerto. El 007 elegía Claude para visión y fue sustituido por el 009, con Gemini. Las últimas cuentan lo que pasó al desplegar: la 012 mueve la API a un servidor propio con Cloudflare Tunnel porque Render y Railway pedían tarjeta; la 013 pasa el asistente a un modelo local en Ollama por la cuota de Gemini; la 014 deja elegir el modelo por cooperativa; la 015 fija qwen3:4b-instruct como modelo por defecto tras medir; la 016 entrega las invitaciones como enlace; la 017 pone dominio propio a la web; la 018 permite color por cooperativa (su parte de logo la retira la 021); la 019 deja que una cooperativa use un proveedor externo de modelos con su propia clave, cifrada en el servidor; la 020 migra la interfaz a react-native-paper (Material Design 3), con el tema generado a partir del color de cada cooperativa; la 021 elimina el logo por cooperativa: solo se veía tras iniciar sesión y la subida de ficheros no compensaba antes de la entrega; la 022 pasa a búsqueda híbrida con un umbral de similitud; la 023 documenta el benchmark de calidad del RAG; la 024 fija el sistema de diseño de la interfaz; la 025 añade el NIF del socio y el cruce entre socios y terceros; y la 026, la última, usa Gemini Flash-Lite en el asistente de la demo publicada, porque el modelo local tardaba más de 30 segundos por pregunta en la CPU del servidor.</a:t>
             </a:r>
           </a:p>
         </p:txBody>
@@ -1640,7 +1640,7 @@
           <a:lstStyle/>
           <a:p>
             <a:r>
-              <a:t>La seguridad se decide en el backend. Cada caso de uso comprueba el permiso y deniega por defecto; la app solo oculta lo que el servidor dice que no está permitido. El aislamiento es por cooperativa, también en la búsqueda semántica y en las herramientas del asistente: un recurso de otra cooperativa responde 404 y un módulo sin permiso responde 403. Las contraseñas usan Argon2id con bloqueo por intentos fallidos, y las sesiones JWT con refresh rotatorio. Los ficheros se sirven con URLs firmadas que caducan; el color de marca elegido debe cumplir contraste WCAG AA con el texto blanco. CORS tiene una lista de orígenes permitidos y los secretos no están en el repositorio; la clave que una cooperativa aporta para un proveedor externo se guarda cifrada con AES-256-GCM, y el servidor solo llama a un catálogo fijo de proveedores, nunca a una URL enviada por el cliente, para evitar SSRF. Y todo esto está cubierto por tests: la matriz de perfiles por módulos y el aislamiento entre cooperativas.</a:t>
+              <a:t>La seguridad se decide en el backend. Cada caso de uso comprueba el permiso y deniega por defecto; la app solo oculta lo que el servidor dice que no está permitido. El aislamiento es por cooperativa, también en la búsqueda semántica y en las herramientas del asistente: un recurso de otra cooperativa responde 404 y un módulo sin permiso responde 403. Las contraseñas usan Argon2id con bloqueo por intentos fallidos, y las sesiones JWT con refresh rotatorio. Los ficheros se sirven con URLs firmadas que caducan; el servidor valida cada entrada, y también el color de marca que elige el administrador, que debe cumplir un contraste WCAG AA de 4,5:1 con el texto blanco. No hay logo por cooperativa (ADR-021). CORS tiene una lista de orígenes permitidos y los secretos no están en el repositorio; la clave que una cooperativa aporta para un proveedor externo se guarda cifrada con AES-256-GCM, y el servidor solo llama a un catálogo fijo de proveedores, nunca a una URL enviada por el cliente, para evitar SSRF. Y todo esto está cubierto por tests: la matriz de perfiles por módulos y el aislamiento entre cooperativas.</a:t>
             </a:r>
           </a:p>
         </p:txBody>
@@ -1726,7 +1726,7 @@
           <a:lstStyle/>
           <a:p>
             <a:r>
-              <a:t>Hay varios usos de IA, todos con límites. Uno: el asistente responde con un modelo local en Ollama, en el servidor propio, qwen3:4b-instruct por defecto, y el administrador de cada cooperativa puede elegir otro modelo local en Ajustes o, opcionalmente, un proveedor externo de un catálogo fijo (Groq, Mistral, NVIDIA NIM u OpenRouter) con su propia clave, cifrada en el servidor; si el proveedor falla, responde el modelo del servidor. Con el modelo local no se gasta cuota de Gemini y las preguntas no salen del servidor. Dos: usa RAG sobre los documentos de la cooperativa, con búsqueda en pgvector filtrada por cooperativa y citas a la fuente, y herramientas de solo lectura que reutilizan los casos de uso con los permisos del usuario, como listar proveedores y clientes o consultar mis aportaciones; por eso el asistente no puede ver nada que el usuario no pueda ver. Tres: la extracción de facturas usa la visión de Gemini, valida la salida con un esquema Zod y nunca guarda sin confirmación humana; también explica discrepancias entre albarán y factura en lenguaje natural, enviando solo los datos mínimos. Las llamadas a Gemini se reintentan y tienen modelos alternativos. Y cuatro: las conversaciones tienen historial, se pueden reabrir y eliminar, y las respuestas se muestran en Markdown. Los embeddings son locales con bge-m3.</a:t>
+              <a:t>Hay varios usos de IA, todos con límites. Uno: el asistente. Por defecto responde con un modelo local en Ollama, qwen3:4b-instruct, y el administrador de cada cooperativa puede elegir otro modelo local en Ajustes o, opcionalmente, un proveedor externo de un catálogo fijo (Groq, Mistral, NVIDIA NIM u OpenRouter) con su propia clave, cifrada en el servidor; si el proveedor falla, responde el modelo del servidor. La demo publicada usa Gemini Flash-Lite (ADR-026): en la CPU del servidor, qwen3:4b tardaba más de 30 segundos por pregunta, y Flash-Lite acertó 53 de 60 preguntas del conjunto de evaluación con una mediana de 1,7 segundos, frente a 47 de 60 del modelo local en el Mac. Dos: el asistente usa RAG sobre los documentos de la cooperativa, con búsqueda en pgvector filtrada por cooperativa y citas a la fuente, y 18 herramientas de solo lectura que reutilizan los casos de uso con los permisos del usuario: proveedores y clientes, mis aportaciones, facturación agregada calculada en la base de datos, herramientas de socios y el cruce entre socios y terceros por NIF. Las cifras se citan y los periodos relativos, como "el mes pasado", los resuelve el servidor; por eso el asistente no puede ver nada que el usuario no pueda ver. Tres: la extracción de facturas usa la visión de Gemini, valida la salida con un esquema Zod y nunca guarda sin confirmación humana; también explica discrepancias entre albarán y factura en lenguaje natural, enviando solo los datos mínimos. Las llamadas a Gemini se reintentan y tienen modelos alternativos. Y cuatro: las conversaciones tienen historial, se pueden reabrir y eliminar, y las respuestas se muestran en Markdown. Los embeddings son locales con bge-m3.</a:t>
             </a:r>
           </a:p>
         </p:txBody>
@@ -1812,7 +1812,7 @@
           <a:lstStyle/>
           <a:p>
             <a:r>
-              <a:t>Además de usar IA en el producto, el proyecto se ha construido con Claude Code y Spec Driven Development. Primero la especificación: visión, stack, plan por hitos y 56 historias de usuario con reglas de negocio y requisitos no funcionales, antes del código. CLAUDE.md es el contrato con el agente: reglas no negociables, forma de trabajar y comandos; y una regla propia de ESLint hace cumplir las fronteras entre módulos aunque escriba el agente. Dominio con TDD a partir de los criterios de la especificación; los identificadores de requisitos aparecen en tests y en commits con Conventional Commits. 166 de los 167 commits sin fusiones, el 99 por ciento, llevan el trailer Co-Authored-By de Claude; el único sin él es el inicial. Hacia el final trabajé con agentes en paralelo, cada uno en su git worktree y rama, y luego integré; ahí aprendí que hace falta disciplina de integración. También fijé en el repositorio skills de la comunidad (skills.sh, con su lock) para React Native, Vitest, Prisma, Supabase y Node, con una regla de precedencia en CLAUDE.md: CLAUDE.md, los ADR y las especificaciones mandan sobre las skills, y las desviaciones están documentadas; un registro de skills inyecta sus reglas compactas en cada subagente. La migración de la interfaz a react-native-paper (ADR-020) la hizo un agente orquestador que delegó en subagentes: uno de base, luego siete en paralelo sobre carpetas de funcionalidad disjuntas, uno de verificación y uno que lanzó la app en web con Playwright, hizo capturas y encontró errores visuales que se corrigieron. La memoria persistente entre sesiones, con Engram, mantiene el contexto. Y las decisiones sobre IA se tomaron midiendo: un conjunto de evaluación de 23 preguntas contra el modelo real y un benchmark de modelos locales, que se ve en la siguiente diapositiva.</a:t>
+              <a:t>Además de usar IA en el producto, el proyecto se ha construido con Claude Code y Spec Driven Development. Primero la especificación: visión, stack, plan por hitos y 63 historias de usuario con reglas de negocio y requisitos no funcionales, antes del código. CLAUDE.md es el contrato con el agente: reglas no negociables, forma de trabajar y comandos; y una regla propia de ESLint hace cumplir las fronteras entre módulos aunque escriba el agente. Dominio con TDD a partir de los criterios de la especificación; los identificadores de requisitos aparecen en tests y en commits con Conventional Commits. 247 de los 248 commits sin fusiones, el 99 por ciento, llevan el trailer Co-Authored-By de Claude; el único sin él es el inicial. Hacia el final trabajé con agentes en paralelo, cada uno en su git worktree y rama, y luego integré; ahí aprendí que hace falta disciplina de integración. También fijé en el repositorio skills de la comunidad (skills.sh, con su lock) para React Native, Vitest, Prisma, Supabase y Node, con una regla de precedencia en CLAUDE.md: CLAUDE.md, los ADR y las especificaciones mandan sobre las skills, y las desviaciones están documentadas; un registro de skills inyecta sus reglas compactas en cada subagente. El diseño de la interfaz siguió un flujo con IA: un brief, una herramienta de diseño con IA que generó tokens y componentes, un análisis de brechas con lo que ya había, y la migración (ADR-020 y ADR-024) a cargo de un agente orquestador que delegó en subagentes: uno de base, luego siete en paralelo sobre carpetas de funcionalidad disjuntas, uno de verificación y uno que lanzó la app en web con Playwright, hizo capturas y encontró errores visuales que se corrigieron. La memoria persistente entre sesiones, con Engram, mantiene el contexto. Y las decisiones sobre IA se tomaron midiendo: un conjunto de evaluación de 60 preguntas contra el modelo real y un benchmark de modelos locales, que se ve en la siguiente diapositiva.</a:t>
             </a:r>
           </a:p>
         </p:txBody>
@@ -2697,7 +2697,7 @@
                   <a:schemeClr val="accent2"/>
                 </a:solidFill>
               </a:rPr>
-              <a:t>246 / 247</a:t>
+              <a:t>247 / 248</a:t>
             </a:r>
           </a:p>
         </p:txBody>
@@ -6002,7 +6002,7 @@
                   <a:schemeClr val="tx1"/>
                 </a:solidFill>
               </a:rPr>
-              <a:t>E2E con Maestro</a:t>
+              <a:t>Tests de componentes (RNTL) y E2E en CI</a:t>
             </a:r>
           </a:p>
           <a:p>
@@ -7820,7 +7820,7 @@
                   <a:schemeClr val="tx1"/>
                 </a:solidFill>
               </a:rPr>
-              <a:t>E2E con Maestro</a:t>
+              <a:t>Tests de componentes (RNTL) y E2E en CI</a:t>
             </a:r>
           </a:p>
           <a:p>
@@ -13665,7 +13665,7 @@
                   <a:schemeClr val="tx2"/>
                 </a:solidFill>
               </a:rPr>
-              <a:t>Ficheros y marca</a:t>
+              <a:t>Ficheros y validación</a:t>
             </a:r>
           </a:p>
         </p:txBody>
@@ -13698,7 +13698,7 @@
                   <a:schemeClr val="tx1"/>
                 </a:solidFill>
               </a:rPr>
-              <a:t>URLs firmadas que caducan; color de marca con contraste AA</a:t>
+              <a:t>URLs firmadas que caducan; el servidor valida cada entrada, también el contraste AA del color</a:t>
             </a:r>
           </a:p>
         </p:txBody>
@@ -14111,7 +14111,7 @@
                   <a:schemeClr val="tx2"/>
                 </a:solidFill>
               </a:rPr>
-              <a:t>Asistente con modelo local</a:t>
+              <a:t>Asistente: local o en la nube</a:t>
             </a:r>
           </a:p>
         </p:txBody>

</xml_diff>

<commit_message>
docs(slides): separate the RAG search from the 17 data tools on the AI-in-product slide
Co-Authored-By: Claude Opus 5.5 <noreply@anthropic.com>
</commit_message>
<xml_diff>
--- a/docs/slides/multicooperativa-tfm.pptx
+++ b/docs/slides/multicooperativa-tfm.pptx
@@ -1726,7 +1726,7 @@
           <a:lstStyle/>
           <a:p>
             <a:r>
-              <a:t>Hay varios usos de IA, todos con límites. Uno: el asistente. Por defecto responde con un modelo local en Ollama, qwen3:4b-instruct, y el administrador de cada cooperativa puede elegir otro modelo local en Ajustes o, opcionalmente, un proveedor externo de un catálogo fijo (Groq, Mistral, NVIDIA NIM u OpenRouter) con su propia clave, cifrada en el servidor; si el proveedor falla, responde el modelo del servidor. La demo publicada usa Gemini Flash-Lite (ADR-026): en la CPU del servidor, qwen3:4b tardaba más de 30 segundos por pregunta, y Flash-Lite acertó 53 de 60 preguntas del conjunto de evaluación con una mediana de 1,7 segundos, frente a 47 de 60 del modelo local en el Mac. Dos: el asistente usa RAG sobre los documentos de la cooperativa, con búsqueda en pgvector filtrada por cooperativa y citas a la fuente, y 18 herramientas de solo lectura que reutilizan los casos de uso con los permisos del usuario: proveedores y clientes, mis aportaciones, facturación agregada calculada en la base de datos, herramientas de socios y el cruce entre socios y terceros por NIF. Las cifras se citan y los periodos relativos, como "el mes pasado", los resuelve el servidor; por eso el asistente no puede ver nada que el usuario no pueda ver. Tres: la extracción de facturas usa la visión de Gemini, valida la salida con un esquema Zod y nunca guarda sin confirmación humana; también explica discrepancias entre albarán y factura en lenguaje natural, enviando solo los datos mínimos. Las llamadas a Gemini se reintentan y tienen modelos alternativos. Y cuatro: las conversaciones tienen historial, se pueden reabrir y eliminar, y las respuestas se muestran en Markdown. Los embeddings son locales con bge-m3.</a:t>
+              <a:t>Hay varios usos de IA, todos con límites. Uno: el asistente. Por defecto responde con un modelo local en Ollama, qwen3:4b-instruct, y el administrador de cada cooperativa puede elegir otro modelo local en Ajustes o, opcionalmente, un proveedor externo de un catálogo fijo (Groq, Mistral, NVIDIA NIM u OpenRouter) con su propia clave, cifrada en el servidor; si el proveedor falla, responde el modelo del servidor. La demo publicada usa Gemini Flash-Lite (ADR-026): en la CPU del servidor, qwen3:4b tardaba más de 30 segundos por pregunta, y Flash-Lite acertó 53 de 60 preguntas del conjunto de evaluación con una mediana de 1,7 segundos, frente a 47 de 60 del modelo local en el Mac. Dos: el asistente usa RAG sobre los documentos de la cooperativa, con búsqueda en pgvector filtrada por cooperativa y citas a la fuente, y otras 17 herramientas de consulta a datos, de solo lectura, que reutilizan los casos de uso con los permisos del usuario: proveedores y clientes, mis aportaciones, facturación agregada calculada en la base de datos, herramientas de socios y el cruce entre socios y terceros por NIF. Las cifras se citan y los periodos relativos, como "el mes pasado", los resuelve el servidor; por eso el asistente no puede ver nada que el usuario no pueda ver. Tres: la extracción de facturas usa la visión de Gemini, valida la salida con un esquema Zod y nunca guarda sin confirmación humana; también explica discrepancias entre albarán y factura en lenguaje natural, enviando solo los datos mínimos. Las llamadas a Gemini se reintentan y tienen modelos alternativos. Y cuatro: las conversaciones tienen historial, se pueden reabrir y eliminar, y las respuestas se muestran en Markdown. Los embeddings son locales con bge-m3.</a:t>
             </a:r>
           </a:p>
         </p:txBody>
@@ -1812,7 +1812,7 @@
           <a:lstStyle/>
           <a:p>
             <a:r>
-              <a:t>Además de usar IA en el producto, el proyecto se ha construido con Claude Code y Spec Driven Development. Primero la especificación: visión, stack, plan por hitos y 63 historias de usuario con reglas de negocio y requisitos no funcionales, antes del código. CLAUDE.md es el contrato con el agente: reglas no negociables, forma de trabajar y comandos; y una regla propia de ESLint hace cumplir las fronteras entre módulos aunque escriba el agente. Dominio con TDD a partir de los criterios de la especificación; los identificadores de requisitos aparecen en tests y en commits con Conventional Commits. 247 de los 248 commits sin fusiones, el 99 por ciento, llevan el trailer Co-Authored-By de Claude; el único sin él es el inicial. Hacia el final trabajé con agentes en paralelo, cada uno en su git worktree y rama, y luego integré; ahí aprendí que hace falta disciplina de integración. También fijé en el repositorio skills de la comunidad (skills.sh, con su lock) para React Native, Vitest, Prisma, Supabase y Node, con una regla de precedencia en CLAUDE.md: CLAUDE.md, los ADR y las especificaciones mandan sobre las skills, y las desviaciones están documentadas; un registro de skills inyecta sus reglas compactas en cada subagente. El diseño de la interfaz siguió un flujo con IA: un brief, una herramienta de diseño con IA que generó tokens y componentes, un análisis de brechas con lo que ya había, y la migración (ADR-020 y ADR-024) a cargo de un agente orquestador que delegó en subagentes: uno de base, luego siete en paralelo sobre carpetas de funcionalidad disjuntas, uno de verificación y uno que lanzó la app en web con Playwright, hizo capturas y encontró errores visuales que se corrigieron. La memoria persistente entre sesiones, con Engram, mantiene el contexto. Y las decisiones sobre IA se tomaron midiendo: un conjunto de evaluación de 60 preguntas contra el modelo real y un benchmark de modelos locales, que se ve en la siguiente diapositiva.</a:t>
+              <a:t>Además de usar IA en el producto, el proyecto se ha construido con Claude Code y Spec Driven Development. Primero la especificación: visión, stack, plan por hitos y 63 historias de usuario con reglas de negocio y requisitos no funcionales, antes del código. CLAUDE.md es el contrato con el agente: reglas no negociables, forma de trabajar y comandos; y una regla propia de ESLint hace cumplir las fronteras entre módulos aunque escriba el agente. Dominio con TDD a partir de los criterios de la especificación; los identificadores de requisitos aparecen en tests y en commits con Conventional Commits. 248 de los 249 commits sin fusiones, el 99 por ciento, llevan el trailer Co-Authored-By de Claude; el único sin él es el inicial. Hacia el final trabajé con agentes en paralelo, cada uno en su git worktree y rama, y luego integré; ahí aprendí que hace falta disciplina de integración. También fijé en el repositorio skills de la comunidad (skills.sh, con su lock) para React Native, Vitest, Prisma, Supabase y Node, con una regla de precedencia en CLAUDE.md: CLAUDE.md, los ADR y las especificaciones mandan sobre las skills, y las desviaciones están documentadas; un registro de skills inyecta sus reglas compactas en cada subagente. El diseño de la interfaz siguió un flujo con IA: un brief, una herramienta de diseño con IA que generó tokens y componentes, un análisis de brechas con lo que ya había, y la migración (ADR-020 y ADR-024) a cargo de un agente orquestador que delegó en subagentes: uno de base, luego siete en paralelo sobre carpetas de funcionalidad disjuntas, uno de verificación y uno que lanzó la app en web con Playwright, hizo capturas y encontró errores visuales que se corrigieron. La memoria persistente entre sesiones, con Engram, mantiene el contexto. Y las decisiones sobre IA se tomaron midiendo: un conjunto de evaluación de 60 preguntas contra el modelo real y un benchmark de modelos locales, que se ve en la siguiente diapositiva.</a:t>
             </a:r>
           </a:p>
         </p:txBody>
@@ -2697,7 +2697,7 @@
                   <a:schemeClr val="accent2"/>
                 </a:solidFill>
               </a:rPr>
-              <a:t>247 / 248</a:t>
+              <a:t>248 / 249</a:t>
             </a:r>
           </a:p>
         </p:txBody>
@@ -14225,7 +14225,7 @@
                   <a:schemeClr val="tx2"/>
                 </a:solidFill>
               </a:rPr>
-              <a:t>RAG con citas y herramientas</a:t>
+              <a:t>RAG y herramientas con citas</a:t>
             </a:r>
           </a:p>
         </p:txBody>
@@ -14258,7 +14258,7 @@
                   <a:schemeClr val="tx1"/>
                 </a:solidFill>
               </a:rPr>
-              <a:t>18 herramientas de solo lectura con los permisos del usuario: facturación agregada en BD, socios y cruce socio–tercero por NIF; cifras citadas</a:t>
+              <a:t>1 búsqueda en documentos (RAG) y 17 consultas a datos, de solo lectura y con los permisos del usuario: facturación agregada en BD, asambleas, comunicados, socios y cruce socio–tercero por NIF; cifras citadas</a:t>
             </a:r>
           </a:p>
         </p:txBody>

</xml_diff>

<commit_message>
docs(slides): drop the credit-card mentions from the deployment slide, notes and script
Co-Authored-By: Claude Opus 5.5 <noreply@anthropic.com>
</commit_message>
<xml_diff>
--- a/docs/slides/multicooperativa-tfm.pptx
+++ b/docs/slides/multicooperativa-tfm.pptx
@@ -864,7 +864,7 @@
           <a:lstStyle/>
           <a:p>
             <a:r>
-              <a:t>La demo cuesta 0 euros. El plan inicial era Render, Neon y Supabase, pero en octubre descubrí que Render y Railway piden tarjeta de crédito y no tengo, así que mover la API a un servidor propio fue la decisión del ADR-012. Es un Windows de casa con Docker Desktop, un i5-10500 y 32 GB de RAM, que ejecuta el mismo stack que el desarrollo: la API, PostgreSQL con pgvector, RustFS como almacenamiento S3 y Ollama con el modelo local del asistente y los embeddings. Solo la API sale a internet, por un Cloudflare Tunnel con conexión de salida, sin abrir puertos en el router, en api-cooperativa.chaparro2001.com; los ficheros se sirven con URLs firmadas por files-cooperativa. La app web está en GitHub Pages con dominio propio, cooperativa.chaparro2001.com, ADR-017. Un cron de GitHub Actions llama cada hora al proceso de vencimientos. Gemini se usa para la visión, las explicaciones y, en la demo publicada, el asistente (ADR-026), porque el modelo local era demasiado lento en esa CPU. Los límites: solo responde con el servidor encendido, no hay copias de seguridad y no hay que subir datos reales. La alternativa en la nube con Neon, Supabase y Render sigue documentada.</a:t>
+              <a:t>La demo cuesta 0 euros. El plan inicial era Render, Neon y Supabase, pero para mantener el coste en cero moví la API a un servidor propio, que es la decisión del ADR-012. Es un Windows de casa con Docker Desktop, un i5-10500 y 32 GB de RAM, que ejecuta el mismo stack que el desarrollo: la API, PostgreSQL con pgvector, RustFS como almacenamiento S3 y Ollama con el modelo local del asistente y los embeddings. Solo la API sale a internet, por un Cloudflare Tunnel con conexión de salida, sin abrir puertos en el router, en api-cooperativa.chaparro2001.com; los ficheros se sirven con URLs firmadas por files-cooperativa. La app web está en GitHub Pages con dominio propio, cooperativa.chaparro2001.com, ADR-017. Un cron de GitHub Actions llama cada hora al proceso de vencimientos. Gemini se usa para la visión, las explicaciones y, en la demo publicada, el asistente (ADR-026), porque el modelo local era demasiado lento en esa CPU. Los límites: solo responde con el servidor encendido, no hay copias de seguridad y no hay que subir datos reales. La alternativa en la nube con Neon, Supabase y Render sigue documentada.</a:t>
             </a:r>
           </a:p>
         </p:txBody>
@@ -1554,7 +1554,7 @@
           <a:lstStyle/>
           <a:p>
             <a:r>
-              <a:t>Cada decisión importante está en un ADR inmutable: si una decisión cambia, se escribe otro ADR. Hay 26. Las primeras, de la 001 a la 005, fijan la base: Expo, monolito modular, multi-cooperativa con base de datos compartida, permisos por perfil y almacenamiento S3 tras un puerto. El 007 elegía Claude para visión y fue sustituido por el 009, con Gemini. Las últimas cuentan lo que pasó al desplegar: la 012 mueve la API a un servidor propio con Cloudflare Tunnel porque Render y Railway pedían tarjeta; la 013 pasa el asistente a un modelo local en Ollama por la cuota de Gemini; la 014 deja elegir el modelo por cooperativa; la 015 fija qwen3:4b-instruct como modelo por defecto tras medir; la 016 entrega las invitaciones como enlace; la 017 pone dominio propio a la web; la 018 permite color por cooperativa (su parte de logo la retira la 021); la 019 deja que una cooperativa use un proveedor externo de modelos con su propia clave, cifrada en el servidor; la 020 migra la interfaz a react-native-paper (Material Design 3), con el tema generado a partir del color de cada cooperativa; la 021 elimina el logo por cooperativa: solo se veía tras iniciar sesión y la subida de ficheros no compensaba antes de la entrega; la 022 pasa a búsqueda híbrida con un umbral de similitud; la 023 documenta el benchmark de calidad del RAG; la 024 fija el sistema de diseño de la interfaz; la 025 añade el NIF del socio y el cruce entre socios y terceros; y la 026, la última, usa Gemini Flash-Lite en el asistente de la demo publicada, porque el modelo local tardaba más de 30 segundos por pregunta en la CPU del servidor.</a:t>
+              <a:t>Cada decisión importante está en un ADR inmutable: si una decisión cambia, se escribe otro ADR. Hay 26. Las primeras, de la 001 a la 005, fijan la base: Expo, monolito modular, multi-cooperativa con base de datos compartida, permisos por perfil y almacenamiento S3 tras un puerto. El 007 elegía Claude para visión y fue sustituido por el 009, con Gemini. Las últimas cuentan lo que pasó al desplegar: la 012 mueve la API a un servidor propio con Cloudflare Tunnel para mantener el coste en cero; la 013 pasa el asistente a un modelo local en Ollama por la cuota de Gemini; la 014 deja elegir el modelo por cooperativa; la 015 fija qwen3:4b-instruct como modelo por defecto tras medir; la 016 entrega las invitaciones como enlace; la 017 pone dominio propio a la web; la 018 permite color por cooperativa (su parte de logo la retira la 021); la 019 deja que una cooperativa use un proveedor externo de modelos con su propia clave, cifrada en el servidor; la 020 migra la interfaz a react-native-paper (Material Design 3), con el tema generado a partir del color de cada cooperativa; la 021 elimina el logo por cooperativa: solo se veía tras iniciar sesión y la subida de ficheros no compensaba antes de la entrega; la 022 pasa a búsqueda híbrida con un umbral de similitud; la 023 documenta el benchmark de calidad del RAG; la 024 fija el sistema de diseño de la interfaz; la 025 añade el NIF del socio y el cruce entre socios y terceros; y la 026, la última, usa Gemini Flash-Lite en el asistente de la demo publicada, porque el modelo local tardaba más de 30 segundos por pregunta en la CPU del servidor.</a:t>
             </a:r>
           </a:p>
         </p:txBody>
@@ -1812,7 +1812,7 @@
           <a:lstStyle/>
           <a:p>
             <a:r>
-              <a:t>Además de usar IA en el producto, el proyecto se ha construido con Claude Code y Spec Driven Development. Primero la especificación: visión, stack, plan por hitos y 63 historias de usuario con reglas de negocio y requisitos no funcionales, antes del código. CLAUDE.md es el contrato con el agente: reglas no negociables, forma de trabajar y comandos; y una regla propia de ESLint hace cumplir las fronteras entre módulos aunque escriba el agente. Dominio con TDD a partir de los criterios de la especificación; los identificadores de requisitos aparecen en tests y en commits con Conventional Commits. 248 de los 249 commits sin fusiones, el 99 por ciento, llevan el trailer Co-Authored-By de Claude; el único sin él es el inicial. Hacia el final trabajé con agentes en paralelo, cada uno en su git worktree y rama, y luego integré; ahí aprendí que hace falta disciplina de integración. También fijé en el repositorio skills de la comunidad (skills.sh, con su lock) para React Native, Vitest, Prisma, Supabase y Node, con una regla de precedencia en CLAUDE.md: CLAUDE.md, los ADR y las especificaciones mandan sobre las skills, y las desviaciones están documentadas; un registro de skills inyecta sus reglas compactas en cada subagente. El diseño de la interfaz siguió un flujo con IA: un brief, una herramienta de diseño con IA que generó tokens y componentes, un análisis de brechas con lo que ya había, y la migración (ADR-020 y ADR-024) a cargo de un agente orquestador que delegó en subagentes: uno de base, luego siete en paralelo sobre carpetas de funcionalidad disjuntas, uno de verificación y uno que lanzó la app en web con Playwright, hizo capturas y encontró errores visuales que se corrigieron. La memoria persistente entre sesiones, con Engram, mantiene el contexto. Y las decisiones sobre IA se tomaron midiendo: un conjunto de evaluación de 60 preguntas contra el modelo real y un benchmark de modelos locales, que se ve en la siguiente diapositiva.</a:t>
+              <a:t>Además de usar IA en el producto, el proyecto se ha construido con Claude Code y Spec Driven Development. Primero la especificación: visión, stack, plan por hitos y 63 historias de usuario con reglas de negocio y requisitos no funcionales, antes del código. CLAUDE.md es el contrato con el agente: reglas no negociables, forma de trabajar y comandos; y una regla propia de ESLint hace cumplir las fronteras entre módulos aunque escriba el agente. Dominio con TDD a partir de los criterios de la especificación; los identificadores de requisitos aparecen en tests y en commits con Conventional Commits. 249 de los 250 commits sin fusiones, el 99 por ciento, llevan el trailer Co-Authored-By de Claude; el único sin él es el inicial. Hacia el final trabajé con agentes en paralelo, cada uno en su git worktree y rama, y luego integré; ahí aprendí que hace falta disciplina de integración. También fijé en el repositorio skills de la comunidad (skills.sh, con su lock) para React Native, Vitest, Prisma, Supabase y Node, con una regla de precedencia en CLAUDE.md: CLAUDE.md, los ADR y las especificaciones mandan sobre las skills, y las desviaciones están documentadas; un registro de skills inyecta sus reglas compactas en cada subagente. El diseño de la interfaz siguió un flujo con IA: un brief, una herramienta de diseño con IA que generó tokens y componentes, un análisis de brechas con lo que ya había, y la migración (ADR-020 y ADR-024) a cargo de un agente orquestador que delegó en subagentes: uno de base, luego siete en paralelo sobre carpetas de funcionalidad disjuntas, uno de verificación y uno que lanzó la app en web con Playwright, hizo capturas y encontró errores visuales que se corrigieron. La memoria persistente entre sesiones, con Engram, mantiene el contexto. Y las decisiones sobre IA se tomaron midiendo: un conjunto de evaluación de 60 preguntas contra el modelo real y un benchmark de modelos locales, que se ve en la siguiente diapositiva.</a:t>
             </a:r>
           </a:p>
         </p:txBody>
@@ -2697,7 +2697,7 @@
                   <a:schemeClr val="accent2"/>
                 </a:solidFill>
               </a:rPr>
-              <a:t>248 / 249</a:t>
+              <a:t>249 / 250</a:t>
             </a:r>
           </a:p>
         </p:txBody>
@@ -3631,7 +3631,7 @@
                 </a:solidFill>
                 <a:latin typeface="Cambria"/>
               </a:rPr>
-              <a:t>Despliegue gratuito, sin tarjeta</a:t>
+              <a:t>Despliegue gratuito</a:t>
             </a:r>
           </a:p>
         </p:txBody>
@@ -4634,7 +4634,7 @@
                   <a:schemeClr val="tx1"/>
                 </a:solidFill>
               </a:rPr>
-              <a:t>Coste: 0 EUR</a:t>
+              <a:t>Coste: 0 EUR  ·  Neon, Supabase y Render siguen documentados como alternativa en la nube</a:t>
             </a:r>
             <a:r>
               <a:rPr sz="1300" b="0">
@@ -4642,7 +4642,7 @@
                   <a:schemeClr val="tx1"/>
                 </a:solidFill>
               </a:rPr>
-              <a:t>  ·  Render y Railway pedían tarjeta; Neon, Supabase y Render siguen documentados</a:t>
+              <a:t/>
             </a:r>
           </a:p>
         </p:txBody>

</xml_diff>